<commit_message>
Expand pitch deck to 12 slides: business, team, and thank-you.
Adds freemium/B2B2C model, Talodabioluwa Paul and Folarin Oyewole, and a dedicated close.

Co-authored-by: Cursor <cursoragent@cursor.com>
</commit_message>
<xml_diff>
--- a/docs/reca/pitch/Reca-Pitch-Deck.pptx
+++ b/docs/reca/pitch/Reca-Pitch-Deck.pptx
@@ -15,9 +15,11 @@
     <p:sldId id="263" r:id="rId9"/>
     <p:sldId id="264" r:id="rId10"/>
     <p:sldId id="265" r:id="rId11"/>
+    <p:sldId id="266" r:id="rId12"/>
+    <p:sldId id="267" r:id="rId13"/>
   </p:sldIdLst>
   <p:notesMasterIdLst>
-    <p:notesMasterId r:id="rId12"/>
+    <p:notesMasterId r:id="rId14"/>
   </p:notesMasterIdLst>
   <p:sldSz cx="12191695" cy="6858000"/>
   <p:notesSz cx="6858000" cy="12191695"/>
@@ -623,6 +625,182 @@
             <a:fld id="{F7021451-1387-4CA6-816F-3879F97B5CBC}" type="slidenum">
               <a:rPr lang="en-US"/>
               <a:t>10</a:t>
+            </a:fld>
+            <a:endParaRPr lang="en-US"/>
+          </a:p>
+        </p:txBody>
+      </p:sp>
+    </p:spTree>
+    <p:extLst>
+      <p:ext uri="{BB962C8B-B14F-4D97-AF65-F5344CB8AC3E}">
+        <p14:creationId xmlns:p14="http://schemas.microsoft.com/office/powerpoint/2010/main" val="1024086991"/>
+      </p:ext>
+    </p:extLst>
+  </p:cSld>
+  <p:clrMapOvr>
+    <a:masterClrMapping/>
+  </p:clrMapOvr>
+</p:notes>
+</file>
+
+<file path=ppt/notesSlides/notesSlide11.xml><?xml version="1.0" encoding="utf-8"?>
+<p:notes xmlns:a="http://schemas.openxmlformats.org/drawingml/2006/main" xmlns:r="http://schemas.openxmlformats.org/officeDocument/2006/relationships" xmlns:p="http://schemas.openxmlformats.org/presentationml/2006/main">
+  <p:cSld>
+    <p:spTree>
+      <p:nvGrpSpPr>
+        <p:cNvPr id="1" name=""/>
+        <p:cNvGrpSpPr/>
+        <p:nvPr/>
+      </p:nvGrpSpPr>
+      <p:grpSpPr>
+        <a:xfrm>
+          <a:off x="0" y="0"/>
+          <a:ext cx="0" cy="0"/>
+          <a:chOff x="0" y="0"/>
+          <a:chExt cx="0" cy="0"/>
+        </a:xfrm>
+      </p:grpSpPr>
+      <p:sp>
+        <p:nvSpPr>
+          <p:cNvPr id="2" name="Slide Image Placeholder 1"/>
+          <p:cNvSpPr>
+            <a:spLocks noGrp="1" noRot="1" noChangeAspect="1"/>
+          </p:cNvSpPr>
+          <p:nvPr>
+            <p:ph type="sldImg"/>
+          </p:nvPr>
+        </p:nvSpPr>
+        <p:spPr/>
+      </p:sp>
+      <p:sp>
+        <p:nvSpPr>
+          <p:cNvPr id="3" name="Notes Placeholder 2"/>
+          <p:cNvSpPr>
+            <a:spLocks noGrp="1"/>
+          </p:cNvSpPr>
+          <p:nvPr>
+            <p:ph type="body" idx="1"/>
+          </p:nvPr>
+        </p:nvSpPr>
+        <p:spPr/>
+        <p:txBody>
+          <a:bodyPr/>
+          <a:lstStyle/>
+          <a:p>
+            <a:r>
+              <a:rPr lang="en-US" dirty="0"/>
+              <a:t/>
+            </a:r>
+            <a:endParaRPr lang="en-US" dirty="0"/>
+          </a:p>
+        </p:txBody>
+      </p:sp>
+      <p:sp>
+        <p:nvSpPr>
+          <p:cNvPr id="4" name="Slide Number Placeholder 3"/>
+          <p:cNvSpPr>
+            <a:spLocks noGrp="1"/>
+          </p:cNvSpPr>
+          <p:nvPr>
+            <p:ph type="sldNum" sz="quarter" idx="10"/>
+          </p:nvPr>
+        </p:nvSpPr>
+        <p:spPr/>
+        <p:txBody>
+          <a:bodyPr/>
+          <a:lstStyle/>
+          <a:p>
+            <a:fld id="{F7021451-1387-4CA6-816F-3879F97B5CBC}" type="slidenum">
+              <a:rPr lang="en-US"/>
+              <a:t>11</a:t>
+            </a:fld>
+            <a:endParaRPr lang="en-US"/>
+          </a:p>
+        </p:txBody>
+      </p:sp>
+    </p:spTree>
+    <p:extLst>
+      <p:ext uri="{BB962C8B-B14F-4D97-AF65-F5344CB8AC3E}">
+        <p14:creationId xmlns:p14="http://schemas.microsoft.com/office/powerpoint/2010/main" val="1024086991"/>
+      </p:ext>
+    </p:extLst>
+  </p:cSld>
+  <p:clrMapOvr>
+    <a:masterClrMapping/>
+  </p:clrMapOvr>
+</p:notes>
+</file>
+
+<file path=ppt/notesSlides/notesSlide12.xml><?xml version="1.0" encoding="utf-8"?>
+<p:notes xmlns:a="http://schemas.openxmlformats.org/drawingml/2006/main" xmlns:r="http://schemas.openxmlformats.org/officeDocument/2006/relationships" xmlns:p="http://schemas.openxmlformats.org/presentationml/2006/main">
+  <p:cSld>
+    <p:spTree>
+      <p:nvGrpSpPr>
+        <p:cNvPr id="1" name=""/>
+        <p:cNvGrpSpPr/>
+        <p:nvPr/>
+      </p:nvGrpSpPr>
+      <p:grpSpPr>
+        <a:xfrm>
+          <a:off x="0" y="0"/>
+          <a:ext cx="0" cy="0"/>
+          <a:chOff x="0" y="0"/>
+          <a:chExt cx="0" cy="0"/>
+        </a:xfrm>
+      </p:grpSpPr>
+      <p:sp>
+        <p:nvSpPr>
+          <p:cNvPr id="2" name="Slide Image Placeholder 1"/>
+          <p:cNvSpPr>
+            <a:spLocks noGrp="1" noRot="1" noChangeAspect="1"/>
+          </p:cNvSpPr>
+          <p:nvPr>
+            <p:ph type="sldImg"/>
+          </p:nvPr>
+        </p:nvSpPr>
+        <p:spPr/>
+      </p:sp>
+      <p:sp>
+        <p:nvSpPr>
+          <p:cNvPr id="3" name="Notes Placeholder 2"/>
+          <p:cNvSpPr>
+            <a:spLocks noGrp="1"/>
+          </p:cNvSpPr>
+          <p:nvPr>
+            <p:ph type="body" idx="1"/>
+          </p:nvPr>
+        </p:nvSpPr>
+        <p:spPr/>
+        <p:txBody>
+          <a:bodyPr/>
+          <a:lstStyle/>
+          <a:p>
+            <a:r>
+              <a:rPr lang="en-US" dirty="0"/>
+              <a:t/>
+            </a:r>
+            <a:endParaRPr lang="en-US" dirty="0"/>
+          </a:p>
+        </p:txBody>
+      </p:sp>
+      <p:sp>
+        <p:nvSpPr>
+          <p:cNvPr id="4" name="Slide Number Placeholder 3"/>
+          <p:cNvSpPr>
+            <a:spLocks noGrp="1"/>
+          </p:cNvSpPr>
+          <p:nvPr>
+            <p:ph type="sldNum" sz="quarter" idx="10"/>
+          </p:nvPr>
+        </p:nvSpPr>
+        <p:spPr/>
+        <p:txBody>
+          <a:bodyPr/>
+          <a:lstStyle/>
+          <a:p>
+            <a:fld id="{F7021451-1387-4CA6-816F-3879F97B5CBC}" type="slidenum">
+              <a:rPr lang="en-US"/>
+              <a:t>12</a:t>
             </a:fld>
             <a:endParaRPr lang="en-US"/>
           </a:p>
@@ -2034,7 +2212,7 @@
                 <a:ea typeface="Calibri" pitchFamily="34" charset="-122"/>
                 <a:cs typeface="Calibri" pitchFamily="34" charset="-120"/>
               </a:rPr>
-              <a:t>1 / 10</a:t>
+              <a:t>1 / 12</a:t>
             </a:r>
             <a:endParaRPr lang="en-US" sz="1100" dirty="0"/>
           </a:p>
@@ -2118,7 +2296,7 @@
                 <a:ea typeface="Calibri" pitchFamily="34" charset="-122"/>
                 <a:cs typeface="Calibri" pitchFamily="34" charset="-120"/>
               </a:rPr>
-              <a:t>WHAT’S NEXT</a:t>
+              <a:t>THE TEAM</a:t>
             </a:r>
             <a:endParaRPr lang="en-US" sz="1200" dirty="0"/>
           </a:p>
@@ -2133,23 +2311,23 @@
         <p:spPr>
           <a:xfrm>
             <a:off x="640080" y="1005840"/>
-            <a:ext cx="10515600" cy="1097280"/>
-          </a:xfrm>
-          <a:prstGeom prst="rect">
-            <a:avLst/>
-          </a:prstGeom>
-          <a:noFill/>
-          <a:ln/>
-        </p:spPr>
-        <p:txBody>
-          <a:bodyPr wrap="square" rtlCol="0" anchor="ctr"/>
-          <a:lstStyle/>
-          <a:p>
-            <a:pPr indent="0" marL="0">
-              <a:buNone/>
-            </a:pPr>
-            <a:r>
-              <a:rPr lang="en-US" sz="3000" dirty="0">
+            <a:ext cx="10515600" cy="731520"/>
+          </a:xfrm>
+          <a:prstGeom prst="rect">
+            <a:avLst/>
+          </a:prstGeom>
+          <a:noFill/>
+          <a:ln/>
+        </p:spPr>
+        <p:txBody>
+          <a:bodyPr wrap="square" rtlCol="0" anchor="ctr"/>
+          <a:lstStyle/>
+          <a:p>
+            <a:pPr indent="0" marL="0">
+              <a:buNone/>
+            </a:pPr>
+            <a:r>
+              <a:rPr lang="en-US" sz="3200" dirty="0">
                 <a:solidFill>
                   <a:srgbClr val="F4F6FB"/>
                 </a:solidFill>
@@ -2157,9 +2335,527 @@
                 <a:ea typeface="Georgia" pitchFamily="34" charset="-122"/>
                 <a:cs typeface="Georgia" pitchFamily="34" charset="-120"/>
               </a:rPr>
+              <a:t>Who built Reca.</a:t>
+            </a:r>
+            <a:endParaRPr lang="en-US" sz="3200" dirty="0"/>
+          </a:p>
+        </p:txBody>
+      </p:sp>
+      <p:sp>
+        <p:nvSpPr>
+          <p:cNvPr id="5" name="Shape 3"/>
+          <p:cNvSpPr/>
+          <p:nvPr/>
+        </p:nvSpPr>
+        <p:spPr>
+          <a:xfrm>
+            <a:off x="640080" y="2011680"/>
+            <a:ext cx="5212080" cy="2560320"/>
+          </a:xfrm>
+          <a:prstGeom prst="roundRect">
+            <a:avLst>
+              <a:gd name="adj" fmla="val 4286"/>
+            </a:avLst>
+          </a:prstGeom>
+          <a:solidFill>
+            <a:srgbClr val="0E121B"/>
+          </a:solidFill>
+          <a:ln/>
+        </p:spPr>
+      </p:sp>
+      <p:sp>
+        <p:nvSpPr>
+          <p:cNvPr id="6" name="Shape 4"/>
+          <p:cNvSpPr/>
+          <p:nvPr/>
+        </p:nvSpPr>
+        <p:spPr>
+          <a:xfrm>
+            <a:off x="6309360" y="2011680"/>
+            <a:ext cx="5212080" cy="2560320"/>
+          </a:xfrm>
+          <a:prstGeom prst="roundRect">
+            <a:avLst>
+              <a:gd name="adj" fmla="val 4286"/>
+            </a:avLst>
+          </a:prstGeom>
+          <a:solidFill>
+            <a:srgbClr val="0E121B"/>
+          </a:solidFill>
+          <a:ln/>
+        </p:spPr>
+      </p:sp>
+      <p:sp>
+        <p:nvSpPr>
+          <p:cNvPr id="7" name="Text 5"/>
+          <p:cNvSpPr/>
+          <p:nvPr/>
+        </p:nvSpPr>
+        <p:spPr>
+          <a:xfrm>
+            <a:off x="914400" y="2240280"/>
+            <a:ext cx="4572000" cy="274320"/>
+          </a:xfrm>
+          <a:prstGeom prst="rect">
+            <a:avLst/>
+          </a:prstGeom>
+          <a:noFill/>
+          <a:ln/>
+        </p:spPr>
+        <p:txBody>
+          <a:bodyPr wrap="square" rtlCol="0" anchor="ctr"/>
+          <a:lstStyle/>
+          <a:p>
+            <a:pPr indent="0" marL="0">
+              <a:buNone/>
+            </a:pPr>
+            <a:r>
+              <a:rPr lang="en-US" sz="1200" b="1" dirty="0">
+                <a:solidFill>
+                  <a:srgbClr val="9AA3B5"/>
+                </a:solidFill>
+                <a:latin typeface="Calibri" pitchFamily="34" charset="0"/>
+                <a:ea typeface="Calibri" pitchFamily="34" charset="-122"/>
+                <a:cs typeface="Calibri" pitchFamily="34" charset="-120"/>
+              </a:rPr>
+              <a:t>PRODUCT DESIGN &amp; UX</a:t>
+            </a:r>
+            <a:endParaRPr lang="en-US" sz="1200" dirty="0"/>
+          </a:p>
+        </p:txBody>
+      </p:sp>
+      <p:sp>
+        <p:nvSpPr>
+          <p:cNvPr id="8" name="Text 6"/>
+          <p:cNvSpPr/>
+          <p:nvPr/>
+        </p:nvSpPr>
+        <p:spPr>
+          <a:xfrm>
+            <a:off x="914400" y="2651760"/>
+            <a:ext cx="4572000" cy="457200"/>
+          </a:xfrm>
+          <a:prstGeom prst="rect">
+            <a:avLst/>
+          </a:prstGeom>
+          <a:noFill/>
+          <a:ln/>
+        </p:spPr>
+        <p:txBody>
+          <a:bodyPr wrap="square" rtlCol="0" anchor="ctr"/>
+          <a:lstStyle/>
+          <a:p>
+            <a:pPr indent="0" marL="0">
+              <a:buNone/>
+            </a:pPr>
+            <a:r>
+              <a:rPr lang="en-US" sz="2200" dirty="0">
+                <a:solidFill>
+                  <a:srgbClr val="F4F6FB"/>
+                </a:solidFill>
+                <a:latin typeface="Georgia" pitchFamily="34" charset="0"/>
+                <a:ea typeface="Georgia" pitchFamily="34" charset="-122"/>
+                <a:cs typeface="Georgia" pitchFamily="34" charset="-120"/>
+              </a:rPr>
+              <a:t>Talodabioluwa Paul</a:t>
+            </a:r>
+            <a:endParaRPr lang="en-US" sz="2200" dirty="0"/>
+          </a:p>
+        </p:txBody>
+      </p:sp>
+      <p:sp>
+        <p:nvSpPr>
+          <p:cNvPr id="9" name="Text 7"/>
+          <p:cNvSpPr/>
+          <p:nvPr/>
+        </p:nvSpPr>
+        <p:spPr>
+          <a:xfrm>
+            <a:off x="914400" y="3246120"/>
+            <a:ext cx="4663440" cy="914400"/>
+          </a:xfrm>
+          <a:prstGeom prst="rect">
+            <a:avLst/>
+          </a:prstGeom>
+          <a:noFill/>
+          <a:ln/>
+        </p:spPr>
+        <p:txBody>
+          <a:bodyPr wrap="square" rtlCol="0" anchor="ctr"/>
+          <a:lstStyle/>
+          <a:p>
+            <a:pPr indent="0" marL="0">
+              <a:buNone/>
+            </a:pPr>
+            <a:r>
+              <a:rPr lang="en-US" sz="1400" dirty="0">
+                <a:solidFill>
+                  <a:srgbClr val="9AA3B5"/>
+                </a:solidFill>
+                <a:latin typeface="Calibri" pitchFamily="34" charset="0"/>
+                <a:ea typeface="Calibri" pitchFamily="34" charset="-122"/>
+                <a:cs typeface="Calibri" pitchFamily="34" charset="-120"/>
+              </a:rPr>
+              <a:t>Experience, copy, flows, and the student-facing product system.</a:t>
+            </a:r>
+            <a:endParaRPr lang="en-US" sz="1400" dirty="0"/>
+          </a:p>
+        </p:txBody>
+      </p:sp>
+      <p:sp>
+        <p:nvSpPr>
+          <p:cNvPr id="10" name="Text 8"/>
+          <p:cNvSpPr/>
+          <p:nvPr/>
+        </p:nvSpPr>
+        <p:spPr>
+          <a:xfrm>
+            <a:off x="6583680" y="2240280"/>
+            <a:ext cx="4572000" cy="274320"/>
+          </a:xfrm>
+          <a:prstGeom prst="rect">
+            <a:avLst/>
+          </a:prstGeom>
+          <a:noFill/>
+          <a:ln/>
+        </p:spPr>
+        <p:txBody>
+          <a:bodyPr wrap="square" rtlCol="0" anchor="ctr"/>
+          <a:lstStyle/>
+          <a:p>
+            <a:pPr indent="0" marL="0">
+              <a:buNone/>
+            </a:pPr>
+            <a:r>
+              <a:rPr lang="en-US" sz="1200" b="1" dirty="0">
+                <a:solidFill>
+                  <a:srgbClr val="9AA3B5"/>
+                </a:solidFill>
+                <a:latin typeface="Calibri" pitchFamily="34" charset="0"/>
+                <a:ea typeface="Calibri" pitchFamily="34" charset="-122"/>
+                <a:cs typeface="Calibri" pitchFamily="34" charset="-120"/>
+              </a:rPr>
+              <a:t>ENGINEERING &amp; WHATSAPP</a:t>
+            </a:r>
+            <a:endParaRPr lang="en-US" sz="1200" dirty="0"/>
+          </a:p>
+        </p:txBody>
+      </p:sp>
+      <p:sp>
+        <p:nvSpPr>
+          <p:cNvPr id="11" name="Text 9"/>
+          <p:cNvSpPr/>
+          <p:nvPr/>
+        </p:nvSpPr>
+        <p:spPr>
+          <a:xfrm>
+            <a:off x="6583680" y="2651760"/>
+            <a:ext cx="4572000" cy="457200"/>
+          </a:xfrm>
+          <a:prstGeom prst="rect">
+            <a:avLst/>
+          </a:prstGeom>
+          <a:noFill/>
+          <a:ln/>
+        </p:spPr>
+        <p:txBody>
+          <a:bodyPr wrap="square" rtlCol="0" anchor="ctr"/>
+          <a:lstStyle/>
+          <a:p>
+            <a:pPr indent="0" marL="0">
+              <a:buNone/>
+            </a:pPr>
+            <a:r>
+              <a:rPr lang="en-US" sz="2200" dirty="0">
+                <a:solidFill>
+                  <a:srgbClr val="F4F6FB"/>
+                </a:solidFill>
+                <a:latin typeface="Georgia" pitchFamily="34" charset="0"/>
+                <a:ea typeface="Georgia" pitchFamily="34" charset="-122"/>
+                <a:cs typeface="Georgia" pitchFamily="34" charset="-120"/>
+              </a:rPr>
+              <a:t>Folarin Oyewole</a:t>
+            </a:r>
+            <a:endParaRPr lang="en-US" sz="2200" dirty="0"/>
+          </a:p>
+        </p:txBody>
+      </p:sp>
+      <p:sp>
+        <p:nvSpPr>
+          <p:cNvPr id="12" name="Text 10"/>
+          <p:cNvSpPr/>
+          <p:nvPr/>
+        </p:nvSpPr>
+        <p:spPr>
+          <a:xfrm>
+            <a:off x="6583680" y="3246120"/>
+            <a:ext cx="4663440" cy="914400"/>
+          </a:xfrm>
+          <a:prstGeom prst="rect">
+            <a:avLst/>
+          </a:prstGeom>
+          <a:noFill/>
+          <a:ln/>
+        </p:spPr>
+        <p:txBody>
+          <a:bodyPr wrap="square" rtlCol="0" anchor="ctr"/>
+          <a:lstStyle/>
+          <a:p>
+            <a:pPr indent="0" marL="0">
+              <a:buNone/>
+            </a:pPr>
+            <a:r>
+              <a:rPr lang="en-US" sz="1400" dirty="0">
+                <a:solidFill>
+                  <a:srgbClr val="9AA3B5"/>
+                </a:solidFill>
+                <a:latin typeface="Calibri" pitchFamily="34" charset="0"/>
+                <a:ea typeface="Calibri" pitchFamily="34" charset="-122"/>
+                <a:cs typeface="Calibri" pitchFamily="34" charset="-120"/>
+              </a:rPr>
+              <a:t>Backend, Meta Cloud API, memory loop, and deploy.</a:t>
+            </a:r>
+            <a:endParaRPr lang="en-US" sz="1400" dirty="0"/>
+          </a:p>
+        </p:txBody>
+      </p:sp>
+      <p:sp>
+        <p:nvSpPr>
+          <p:cNvPr id="13" name="Text 11"/>
+          <p:cNvSpPr/>
+          <p:nvPr/>
+        </p:nvSpPr>
+        <p:spPr>
+          <a:xfrm>
+            <a:off x="640080" y="4937760"/>
+            <a:ext cx="10972800" cy="365760"/>
+          </a:xfrm>
+          <a:prstGeom prst="rect">
+            <a:avLst/>
+          </a:prstGeom>
+          <a:noFill/>
+          <a:ln/>
+        </p:spPr>
+        <p:txBody>
+          <a:bodyPr wrap="square" rtlCol="0" anchor="ctr"/>
+          <a:lstStyle/>
+          <a:p>
+            <a:pPr indent="0" marL="0">
+              <a:buNone/>
+            </a:pPr>
+            <a:r>
+              <a:rPr lang="en-US" sz="1300" dirty="0">
+                <a:solidFill>
+                  <a:srgbClr val="9AA3B5"/>
+                </a:solidFill>
+                <a:latin typeface="Calibri" pitchFamily="34" charset="0"/>
+                <a:ea typeface="Calibri" pitchFamily="34" charset="-122"/>
+                <a:cs typeface="Calibri" pitchFamily="34" charset="-120"/>
+              </a:rPr>
+              <a:t>AI BuildFest 2026 · Track 3 · Case Study 2 · Participant ID BF-0933</a:t>
+            </a:r>
+            <a:endParaRPr lang="en-US" sz="1300" dirty="0"/>
+          </a:p>
+        </p:txBody>
+      </p:sp>
+      <p:sp>
+        <p:nvSpPr>
+          <p:cNvPr id="14" name="Text 12"/>
+          <p:cNvSpPr/>
+          <p:nvPr/>
+        </p:nvSpPr>
+        <p:spPr>
+          <a:xfrm>
+            <a:off x="640080" y="6446520"/>
+            <a:ext cx="7315200" cy="274320"/>
+          </a:xfrm>
+          <a:prstGeom prst="rect">
+            <a:avLst/>
+          </a:prstGeom>
+          <a:noFill/>
+          <a:ln/>
+        </p:spPr>
+        <p:txBody>
+          <a:bodyPr wrap="square" rtlCol="0" anchor="ctr"/>
+          <a:lstStyle/>
+          <a:p>
+            <a:pPr indent="0" marL="0">
+              <a:buNone/>
+            </a:pPr>
+            <a:r>
+              <a:rPr lang="en-US" sz="1100" dirty="0">
+                <a:solidFill>
+                  <a:srgbClr val="9AA3B5"/>
+                </a:solidFill>
+                <a:latin typeface="Calibri" pitchFamily="34" charset="0"/>
+                <a:ea typeface="Calibri" pitchFamily="34" charset="-122"/>
+                <a:cs typeface="Calibri" pitchFamily="34" charset="-120"/>
+              </a:rPr>
+              <a:t>Built in two days on a free stack</a:t>
+            </a:r>
+            <a:endParaRPr lang="en-US" sz="1100" dirty="0"/>
+          </a:p>
+        </p:txBody>
+      </p:sp>
+      <p:sp>
+        <p:nvSpPr>
+          <p:cNvPr id="15" name="Text 13"/>
+          <p:cNvSpPr/>
+          <p:nvPr/>
+        </p:nvSpPr>
+        <p:spPr>
+          <a:xfrm>
+            <a:off x="10241280" y="6446520"/>
+            <a:ext cx="1280160" cy="274320"/>
+          </a:xfrm>
+          <a:prstGeom prst="rect">
+            <a:avLst/>
+          </a:prstGeom>
+          <a:noFill/>
+          <a:ln/>
+        </p:spPr>
+        <p:txBody>
+          <a:bodyPr wrap="square" rtlCol="0" anchor="ctr"/>
+          <a:lstStyle/>
+          <a:p>
+            <a:pPr algn="r" indent="0" marL="0">
+              <a:buNone/>
+            </a:pPr>
+            <a:r>
+              <a:rPr lang="en-US" sz="1100" dirty="0">
+                <a:solidFill>
+                  <a:srgbClr val="9AA3B5"/>
+                </a:solidFill>
+                <a:latin typeface="Calibri" pitchFamily="34" charset="0"/>
+                <a:ea typeface="Calibri" pitchFamily="34" charset="-122"/>
+                <a:cs typeface="Calibri" pitchFamily="34" charset="-120"/>
+              </a:rPr>
+              <a:t>10 / 12</a:t>
+            </a:r>
+            <a:endParaRPr lang="en-US" sz="1100" dirty="0"/>
+          </a:p>
+        </p:txBody>
+      </p:sp>
+    </p:spTree>
+  </p:cSld>
+  <p:clrMapOvr>
+    <a:masterClrMapping/>
+  </p:clrMapOvr>
+</p:sld>
+</file>
+
+<file path=ppt/slides/slide11.xml><?xml version="1.0" encoding="utf-8"?>
+<p:sld xmlns:a="http://schemas.openxmlformats.org/drawingml/2006/main" xmlns:r="http://schemas.openxmlformats.org/officeDocument/2006/relationships" xmlns:p="http://schemas.openxmlformats.org/presentationml/2006/main">
+  <p:cSld name="Slide 11">
+    <p:spTree>
+      <p:nvGrpSpPr>
+        <p:cNvPr id="1" name=""/>
+        <p:cNvGrpSpPr/>
+        <p:nvPr/>
+      </p:nvGrpSpPr>
+      <p:grpSpPr>
+        <a:xfrm>
+          <a:off x="0" y="0"/>
+          <a:ext cx="0" cy="0"/>
+          <a:chOff x="0" y="0"/>
+          <a:chExt cx="0" cy="0"/>
+        </a:xfrm>
+      </p:grpSpPr>
+      <p:sp>
+        <p:nvSpPr>
+          <p:cNvPr id="2" name="Shape 0"/>
+          <p:cNvSpPr/>
+          <p:nvPr/>
+        </p:nvSpPr>
+        <p:spPr>
+          <a:xfrm>
+            <a:off x="0" y="0"/>
+            <a:ext cx="12191695" cy="6858000"/>
+          </a:xfrm>
+          <a:prstGeom prst="rect">
+            <a:avLst/>
+          </a:prstGeom>
+          <a:solidFill>
+            <a:srgbClr val="07090F"/>
+          </a:solidFill>
+          <a:ln/>
+        </p:spPr>
+      </p:sp>
+      <p:sp>
+        <p:nvSpPr>
+          <p:cNvPr id="3" name="Text 1"/>
+          <p:cNvSpPr/>
+          <p:nvPr/>
+        </p:nvSpPr>
+        <p:spPr>
+          <a:xfrm>
+            <a:off x="640080" y="502920"/>
+            <a:ext cx="10972800" cy="320040"/>
+          </a:xfrm>
+          <a:prstGeom prst="rect">
+            <a:avLst/>
+          </a:prstGeom>
+          <a:noFill/>
+          <a:ln/>
+        </p:spPr>
+        <p:txBody>
+          <a:bodyPr wrap="square" rtlCol="0" anchor="ctr"/>
+          <a:lstStyle/>
+          <a:p>
+            <a:pPr indent="0" marL="0">
+              <a:buNone/>
+            </a:pPr>
+            <a:r>
+              <a:rPr lang="en-US" sz="1200" b="1" spc="300" kern="0" dirty="0">
+                <a:solidFill>
+                  <a:srgbClr val="FB735B"/>
+                </a:solidFill>
+                <a:latin typeface="Calibri" pitchFamily="34" charset="0"/>
+                <a:ea typeface="Calibri" pitchFamily="34" charset="-122"/>
+                <a:cs typeface="Calibri" pitchFamily="34" charset="-120"/>
+              </a:rPr>
+              <a:t>WHAT’S NEXT</a:t>
+            </a:r>
+            <a:endParaRPr lang="en-US" sz="1200" dirty="0"/>
+          </a:p>
+        </p:txBody>
+      </p:sp>
+      <p:sp>
+        <p:nvSpPr>
+          <p:cNvPr id="4" name="Text 2"/>
+          <p:cNvSpPr/>
+          <p:nvPr/>
+        </p:nvSpPr>
+        <p:spPr>
+          <a:xfrm>
+            <a:off x="640080" y="1005840"/>
+            <a:ext cx="10515600" cy="1097280"/>
+          </a:xfrm>
+          <a:prstGeom prst="rect">
+            <a:avLst/>
+          </a:prstGeom>
+          <a:noFill/>
+          <a:ln/>
+        </p:spPr>
+        <p:txBody>
+          <a:bodyPr wrap="square" rtlCol="0" anchor="ctr"/>
+          <a:lstStyle/>
+          <a:p>
+            <a:pPr indent="0" marL="0">
+              <a:buNone/>
+            </a:pPr>
+            <a:r>
+              <a:rPr lang="en-US" sz="2800" dirty="0">
+                <a:solidFill>
+                  <a:srgbClr val="F4F6FB"/>
+                </a:solidFill>
+                <a:latin typeface="Georgia" pitchFamily="34" charset="0"/>
+                <a:ea typeface="Georgia" pitchFamily="34" charset="-122"/>
+                <a:cs typeface="Georgia" pitchFamily="34" charset="-120"/>
+              </a:rPr>
               <a:t>Pilot with real students. Expand the syllabus. Keep coming first.</a:t>
             </a:r>
-            <a:endParaRPr lang="en-US" sz="3000" dirty="0"/>
+            <a:endParaRPr lang="en-US" sz="2800" dirty="0"/>
           </a:p>
         </p:txBody>
       </p:sp>
@@ -2318,7 +3014,7 @@
                 <a:ea typeface="Calibri" pitchFamily="34" charset="-122"/>
                 <a:cs typeface="Calibri" pitchFamily="34" charset="-120"/>
               </a:rPr>
-              <a:t>NEXT</a:t>
+              <a:t>NEXT 90 DAYS</a:t>
             </a:r>
             <a:endParaRPr lang="en-US" sz="1200" dirty="0"/>
           </a:p>
@@ -2357,7 +3053,7 @@
                 <a:ea typeface="Calibri" pitchFamily="34" charset="-122"/>
                 <a:cs typeface="Calibri" pitchFamily="34" charset="-120"/>
               </a:rPr>
-              <a:t>School / tutorial pilots · teacher progress view · broader WAEC coverage.</a:t>
+              <a:t>2–3 school / tutorial pilots · teacher progress view · broader WAEC coverage.</a:t>
             </a:r>
             <a:endParaRPr lang="en-US" sz="1500" dirty="0"/>
           </a:p>
@@ -2372,31 +3068,254 @@
         <p:spPr>
           <a:xfrm>
             <a:off x="640080" y="4389120"/>
-            <a:ext cx="10972800" cy="457200"/>
-          </a:xfrm>
-          <a:prstGeom prst="rect">
-            <a:avLst/>
-          </a:prstGeom>
-          <a:noFill/>
-          <a:ln/>
-        </p:spPr>
-        <p:txBody>
-          <a:bodyPr wrap="square" rtlCol="0" anchor="ctr"/>
-          <a:lstStyle/>
-          <a:p>
-            <a:pPr indent="0" marL="0">
-              <a:buNone/>
-            </a:pPr>
-            <a:r>
-              <a:rPr lang="en-US" sz="2000" dirty="0">
+            <a:ext cx="10972800" cy="640080"/>
+          </a:xfrm>
+          <a:prstGeom prst="rect">
+            <a:avLst/>
+          </a:prstGeom>
+          <a:noFill/>
+          <a:ln/>
+        </p:spPr>
+        <p:txBody>
+          <a:bodyPr wrap="square" rtlCol="0" anchor="ctr"/>
+          <a:lstStyle/>
+          <a:p>
+            <a:pPr indent="0" marL="0">
+              <a:buNone/>
+            </a:pPr>
+            <a:r>
+              <a:rPr lang="en-US" sz="1600" dirty="0">
                 <a:solidFill>
                   <a:srgbClr val="F4F6FB"/>
+                </a:solidFill>
+                <a:latin typeface="Calibri" pitchFamily="34" charset="0"/>
+                <a:ea typeface="Calibri" pitchFamily="34" charset="-122"/>
+                <a:cs typeface="Calibri" pitchFamily="34" charset="-120"/>
+              </a:rPr>
+              <a:t>The ask: recognition and support to pilot Reca with real students for the next WAEC/JAMB cycle.</a:t>
+            </a:r>
+            <a:endParaRPr lang="en-US" sz="1600" dirty="0"/>
+          </a:p>
+        </p:txBody>
+      </p:sp>
+      <p:sp>
+        <p:nvSpPr>
+          <p:cNvPr id="12" name="Text 10"/>
+          <p:cNvSpPr/>
+          <p:nvPr/>
+        </p:nvSpPr>
+        <p:spPr>
+          <a:xfrm>
+            <a:off x="640080" y="6446520"/>
+            <a:ext cx="7315200" cy="274320"/>
+          </a:xfrm>
+          <a:prstGeom prst="rect">
+            <a:avLst/>
+          </a:prstGeom>
+          <a:noFill/>
+          <a:ln/>
+        </p:spPr>
+        <p:txBody>
+          <a:bodyPr wrap="square" rtlCol="0" anchor="ctr"/>
+          <a:lstStyle/>
+          <a:p>
+            <a:pPr indent="0" marL="0">
+              <a:buNone/>
+            </a:pPr>
+            <a:r>
+              <a:rPr lang="en-US" sz="1100" dirty="0">
+                <a:solidFill>
+                  <a:srgbClr val="9AA3B5"/>
+                </a:solidFill>
+                <a:latin typeface="Calibri" pitchFamily="34" charset="0"/>
+                <a:ea typeface="Calibri" pitchFamily="34" charset="-122"/>
+                <a:cs typeface="Calibri" pitchFamily="34" charset="-120"/>
+              </a:rPr>
+              <a:t>Case Study 2 · AI for Everyday Life</a:t>
+            </a:r>
+            <a:endParaRPr lang="en-US" sz="1100" dirty="0"/>
+          </a:p>
+        </p:txBody>
+      </p:sp>
+      <p:sp>
+        <p:nvSpPr>
+          <p:cNvPr id="13" name="Text 11"/>
+          <p:cNvSpPr/>
+          <p:nvPr/>
+        </p:nvSpPr>
+        <p:spPr>
+          <a:xfrm>
+            <a:off x="10241280" y="6446520"/>
+            <a:ext cx="1280160" cy="274320"/>
+          </a:xfrm>
+          <a:prstGeom prst="rect">
+            <a:avLst/>
+          </a:prstGeom>
+          <a:noFill/>
+          <a:ln/>
+        </p:spPr>
+        <p:txBody>
+          <a:bodyPr wrap="square" rtlCol="0" anchor="ctr"/>
+          <a:lstStyle/>
+          <a:p>
+            <a:pPr algn="r" indent="0" marL="0">
+              <a:buNone/>
+            </a:pPr>
+            <a:r>
+              <a:rPr lang="en-US" sz="1100" dirty="0">
+                <a:solidFill>
+                  <a:srgbClr val="9AA3B5"/>
+                </a:solidFill>
+                <a:latin typeface="Calibri" pitchFamily="34" charset="0"/>
+                <a:ea typeface="Calibri" pitchFamily="34" charset="-122"/>
+                <a:cs typeface="Calibri" pitchFamily="34" charset="-120"/>
+              </a:rPr>
+              <a:t>11 / 12</a:t>
+            </a:r>
+            <a:endParaRPr lang="en-US" sz="1100" dirty="0"/>
+          </a:p>
+        </p:txBody>
+      </p:sp>
+    </p:spTree>
+  </p:cSld>
+  <p:clrMapOvr>
+    <a:masterClrMapping/>
+  </p:clrMapOvr>
+</p:sld>
+</file>
+
+<file path=ppt/slides/slide12.xml><?xml version="1.0" encoding="utf-8"?>
+<p:sld xmlns:a="http://schemas.openxmlformats.org/drawingml/2006/main" xmlns:r="http://schemas.openxmlformats.org/officeDocument/2006/relationships" xmlns:p="http://schemas.openxmlformats.org/presentationml/2006/main">
+  <p:cSld name="Slide 12">
+    <p:spTree>
+      <p:nvGrpSpPr>
+        <p:cNvPr id="1" name=""/>
+        <p:cNvGrpSpPr/>
+        <p:nvPr/>
+      </p:nvGrpSpPr>
+      <p:grpSpPr>
+        <a:xfrm>
+          <a:off x="0" y="0"/>
+          <a:ext cx="0" cy="0"/>
+          <a:chOff x="0" y="0"/>
+          <a:chExt cx="0" cy="0"/>
+        </a:xfrm>
+      </p:grpSpPr>
+      <p:sp>
+        <p:nvSpPr>
+          <p:cNvPr id="2" name="Shape 0"/>
+          <p:cNvSpPr/>
+          <p:nvPr/>
+        </p:nvSpPr>
+        <p:spPr>
+          <a:xfrm>
+            <a:off x="0" y="0"/>
+            <a:ext cx="12191695" cy="6858000"/>
+          </a:xfrm>
+          <a:prstGeom prst="rect">
+            <a:avLst/>
+          </a:prstGeom>
+          <a:solidFill>
+            <a:srgbClr val="07090F"/>
+          </a:solidFill>
+          <a:ln/>
+        </p:spPr>
+      </p:sp>
+      <p:sp>
+        <p:nvSpPr>
+          <p:cNvPr id="3" name="Shape 1"/>
+          <p:cNvSpPr/>
+          <p:nvPr/>
+        </p:nvSpPr>
+        <p:spPr>
+          <a:xfrm>
+            <a:off x="640080" y="502920"/>
+            <a:ext cx="384048" cy="384048"/>
+          </a:xfrm>
+          <a:prstGeom prst="roundRect">
+            <a:avLst>
+              <a:gd name="adj" fmla="val 19048"/>
+            </a:avLst>
+          </a:prstGeom>
+          <a:solidFill>
+            <a:srgbClr val="FB735B"/>
+          </a:solidFill>
+          <a:ln/>
+        </p:spPr>
+      </p:sp>
+      <p:sp>
+        <p:nvSpPr>
+          <p:cNvPr id="4" name="Text 2"/>
+          <p:cNvSpPr/>
+          <p:nvPr/>
+        </p:nvSpPr>
+        <p:spPr>
+          <a:xfrm>
+            <a:off x="640080" y="502920"/>
+            <a:ext cx="384048" cy="384048"/>
+          </a:xfrm>
+          <a:prstGeom prst="rect">
+            <a:avLst/>
+          </a:prstGeom>
+          <a:noFill/>
+          <a:ln/>
+        </p:spPr>
+        <p:txBody>
+          <a:bodyPr wrap="square" rtlCol="0" anchor="ctr"/>
+          <a:lstStyle/>
+          <a:p>
+            <a:pPr algn="ctr" indent="0" marL="0">
+              <a:buNone/>
+            </a:pPr>
+            <a:r>
+              <a:rPr lang="en-US" sz="1600" dirty="0">
+                <a:solidFill>
+                  <a:srgbClr val="FFFFFF"/>
                 </a:solidFill>
                 <a:latin typeface="Georgia" pitchFamily="34" charset="0"/>
                 <a:ea typeface="Georgia" pitchFamily="34" charset="-122"/>
                 <a:cs typeface="Georgia" pitchFamily="34" charset="-120"/>
               </a:rPr>
-              <a:t>Claude waits for you. Reca comes first.</a:t>
+              <a:t>R</a:t>
+            </a:r>
+            <a:endParaRPr lang="en-US" sz="1600" dirty="0"/>
+          </a:p>
+        </p:txBody>
+      </p:sp>
+      <p:sp>
+        <p:nvSpPr>
+          <p:cNvPr id="5" name="Text 3"/>
+          <p:cNvSpPr/>
+          <p:nvPr/>
+        </p:nvSpPr>
+        <p:spPr>
+          <a:xfrm>
+            <a:off x="1143000" y="530352"/>
+            <a:ext cx="2743200" cy="365760"/>
+          </a:xfrm>
+          <a:prstGeom prst="rect">
+            <a:avLst/>
+          </a:prstGeom>
+          <a:noFill/>
+          <a:ln/>
+        </p:spPr>
+        <p:txBody>
+          <a:bodyPr wrap="square" rtlCol="0" anchor="ctr"/>
+          <a:lstStyle/>
+          <a:p>
+            <a:pPr indent="0" marL="0">
+              <a:buNone/>
+            </a:pPr>
+            <a:r>
+              <a:rPr lang="en-US" sz="2000" dirty="0">
+                <a:solidFill>
+                  <a:srgbClr val="F4F6FB"/>
+                </a:solidFill>
+                <a:latin typeface="Georgia" pitchFamily="34" charset="0"/>
+                <a:ea typeface="Georgia" pitchFamily="34" charset="-122"/>
+                <a:cs typeface="Georgia" pitchFamily="34" charset="-120"/>
+              </a:rPr>
+              <a:t>Reca</a:t>
             </a:r>
             <a:endParaRPr lang="en-US" sz="2000" dirty="0"/>
           </a:p>
@@ -2404,13 +3323,108 @@
       </p:sp>
       <p:sp>
         <p:nvSpPr>
-          <p:cNvPr id="12" name="Text 10"/>
-          <p:cNvSpPr/>
-          <p:nvPr/>
-        </p:nvSpPr>
-        <p:spPr>
-          <a:xfrm>
-            <a:off x="640080" y="5029200"/>
+          <p:cNvPr id="6" name="Text 4"/>
+          <p:cNvSpPr/>
+          <p:nvPr/>
+        </p:nvSpPr>
+        <p:spPr>
+          <a:xfrm>
+            <a:off x="640080" y="2560320"/>
+            <a:ext cx="10972800" cy="320040"/>
+          </a:xfrm>
+          <a:prstGeom prst="rect">
+            <a:avLst/>
+          </a:prstGeom>
+          <a:noFill/>
+          <a:ln/>
+        </p:spPr>
+        <p:txBody>
+          <a:bodyPr wrap="square" rtlCol="0" anchor="ctr"/>
+          <a:lstStyle/>
+          <a:p>
+            <a:pPr indent="0" marL="0">
+              <a:buNone/>
+            </a:pPr>
+            <a:r>
+              <a:rPr lang="en-US" sz="1200" b="1" dirty="0">
+                <a:solidFill>
+                  <a:srgbClr val="FB735B"/>
+                </a:solidFill>
+                <a:latin typeface="Calibri" pitchFamily="34" charset="0"/>
+                <a:ea typeface="Calibri" pitchFamily="34" charset="-122"/>
+                <a:cs typeface="Calibri" pitchFamily="34" charset="-120"/>
+              </a:rPr>
+              <a:t>THANK YOU</a:t>
+            </a:r>
+            <a:endParaRPr lang="en-US" sz="1200" dirty="0"/>
+          </a:p>
+        </p:txBody>
+      </p:sp>
+      <p:sp>
+        <p:nvSpPr>
+          <p:cNvPr id="7" name="Text 5"/>
+          <p:cNvSpPr/>
+          <p:nvPr/>
+        </p:nvSpPr>
+        <p:spPr>
+          <a:xfrm>
+            <a:off x="640080" y="2971800"/>
+            <a:ext cx="10515600" cy="1463040"/>
+          </a:xfrm>
+          <a:prstGeom prst="rect">
+            <a:avLst/>
+          </a:prstGeom>
+          <a:noFill/>
+          <a:ln/>
+        </p:spPr>
+        <p:txBody>
+          <a:bodyPr wrap="square" rtlCol="0" anchor="ctr"/>
+          <a:lstStyle/>
+          <a:p>
+            <a:pPr indent="0" marL="0">
+              <a:buNone/>
+            </a:pPr>
+            <a:r>
+              <a:rPr lang="en-US" sz="3600" dirty="0">
+                <a:solidFill>
+                  <a:srgbClr val="F4F6FB"/>
+                </a:solidFill>
+                <a:latin typeface="Georgia" pitchFamily="34" charset="0"/>
+                <a:ea typeface="Georgia" pitchFamily="34" charset="-122"/>
+                <a:cs typeface="Georgia" pitchFamily="34" charset="-120"/>
+              </a:rPr>
+              <a:t>Claude waits for you.</a:t>
+            </a:r>
+            <a:endParaRPr lang="en-US" sz="3600" dirty="0"/>
+          </a:p>
+          <a:p>
+            <a:pPr indent="0" marL="0">
+              <a:buNone/>
+            </a:pPr>
+            <a:r>
+              <a:rPr lang="en-US" sz="3600" dirty="0">
+                <a:solidFill>
+                  <a:srgbClr val="F4F6FB"/>
+                </a:solidFill>
+                <a:latin typeface="Georgia" pitchFamily="34" charset="0"/>
+                <a:ea typeface="Georgia" pitchFamily="34" charset="-122"/>
+                <a:cs typeface="Georgia" pitchFamily="34" charset="-120"/>
+              </a:rPr>
+              <a:t>Reca comes first.</a:t>
+            </a:r>
+            <a:endParaRPr lang="en-US" sz="3600" dirty="0"/>
+          </a:p>
+        </p:txBody>
+      </p:sp>
+      <p:sp>
+        <p:nvSpPr>
+          <p:cNvPr id="8" name="Text 6"/>
+          <p:cNvSpPr/>
+          <p:nvPr/>
+        </p:nvSpPr>
+        <p:spPr>
+          <a:xfrm>
+            <a:off x="640080" y="4709160"/>
             <a:ext cx="10972800" cy="365760"/>
           </a:xfrm>
           <a:prstGeom prst="rect">
@@ -2427,7 +3441,7 @@
               <a:buNone/>
             </a:pPr>
             <a:r>
-              <a:rPr lang="en-US" sz="1400" dirty="0">
+              <a:rPr lang="en-US" sz="1600" dirty="0">
                 <a:solidFill>
                   <a:srgbClr val="225AEB"/>
                 </a:solidFill>
@@ -2437,13 +3451,52 @@
               </a:rPr>
               <a:t>https://reca-study-companion.vercel.app/signup.html</a:t>
             </a:r>
-            <a:endParaRPr lang="en-US" sz="1400" dirty="0"/>
-          </a:p>
-        </p:txBody>
-      </p:sp>
-      <p:sp>
-        <p:nvSpPr>
-          <p:cNvPr id="13" name="Text 11"/>
+            <a:endParaRPr lang="en-US" sz="1600" dirty="0"/>
+          </a:p>
+        </p:txBody>
+      </p:sp>
+      <p:sp>
+        <p:nvSpPr>
+          <p:cNvPr id="9" name="Text 7"/>
+          <p:cNvSpPr/>
+          <p:nvPr/>
+        </p:nvSpPr>
+        <p:spPr>
+          <a:xfrm>
+            <a:off x="640080" y="5212080"/>
+            <a:ext cx="10972800" cy="320040"/>
+          </a:xfrm>
+          <a:prstGeom prst="rect">
+            <a:avLst/>
+          </a:prstGeom>
+          <a:noFill/>
+          <a:ln/>
+        </p:spPr>
+        <p:txBody>
+          <a:bodyPr wrap="square" rtlCol="0" anchor="ctr"/>
+          <a:lstStyle/>
+          <a:p>
+            <a:pPr indent="0" marL="0">
+              <a:buNone/>
+            </a:pPr>
+            <a:r>
+              <a:rPr lang="en-US" sz="1300" dirty="0">
+                <a:solidFill>
+                  <a:srgbClr val="9AA3B5"/>
+                </a:solidFill>
+                <a:latin typeface="Calibri" pitchFamily="34" charset="0"/>
+                <a:ea typeface="Calibri" pitchFamily="34" charset="-122"/>
+                <a:cs typeface="Calibri" pitchFamily="34" charset="-120"/>
+              </a:rPr>
+              <a:t>Talodabioluwa Paul · Folarin Oyewole · BF-0933</a:t>
+            </a:r>
+            <a:endParaRPr lang="en-US" sz="1300" dirty="0"/>
+          </a:p>
+        </p:txBody>
+      </p:sp>
+      <p:sp>
+        <p:nvSpPr>
+          <p:cNvPr id="10" name="Text 8"/>
           <p:cNvSpPr/>
           <p:nvPr/>
         </p:nvSpPr>
@@ -2474,7 +3527,7 @@
                 <a:ea typeface="Calibri" pitchFamily="34" charset="-122"/>
                 <a:cs typeface="Calibri" pitchFamily="34" charset="-120"/>
               </a:rPr>
-              <a:t>Thank you · Reca</a:t>
+              <a:t>AI BuildFest 2026</a:t>
             </a:r>
             <a:endParaRPr lang="en-US" sz="1100" dirty="0"/>
           </a:p>
@@ -2482,7 +3535,7 @@
       </p:sp>
       <p:sp>
         <p:nvSpPr>
-          <p:cNvPr id="14" name="Text 12"/>
+          <p:cNvPr id="11" name="Text 9"/>
           <p:cNvSpPr/>
           <p:nvPr/>
         </p:nvSpPr>
@@ -2513,7 +3566,7 @@
                 <a:ea typeface="Calibri" pitchFamily="34" charset="-122"/>
                 <a:cs typeface="Calibri" pitchFamily="34" charset="-120"/>
               </a:rPr>
-              <a:t>10 / 10</a:t>
+              <a:t>12 / 12</a:t>
             </a:r>
             <a:endParaRPr lang="en-US" sz="1100" dirty="0"/>
           </a:p>
@@ -3047,7 +4100,7 @@
                 <a:ea typeface="Calibri" pitchFamily="34" charset="-122"/>
                 <a:cs typeface="Calibri" pitchFamily="34" charset="-120"/>
               </a:rPr>
-              <a:t>2 / 10</a:t>
+              <a:t>2 / 12</a:t>
             </a:r>
             <a:endParaRPr lang="en-US" sz="1100" dirty="0"/>
           </a:p>
@@ -3568,7 +4621,7 @@
                 <a:ea typeface="Calibri" pitchFamily="34" charset="-122"/>
                 <a:cs typeface="Calibri" pitchFamily="34" charset="-120"/>
               </a:rPr>
-              <a:t>3 / 10</a:t>
+              <a:t>3 / 12</a:t>
             </a:r>
             <a:endParaRPr lang="en-US" sz="1100" dirty="0"/>
           </a:p>
@@ -3847,7 +4900,7 @@
                 <a:ea typeface="Calibri" pitchFamily="34" charset="-122"/>
                 <a:cs typeface="Calibri" pitchFamily="34" charset="-120"/>
               </a:rPr>
-              <a:t>4 / 10</a:t>
+              <a:t>4 / 12</a:t>
             </a:r>
             <a:endParaRPr lang="en-US" sz="1100" dirty="0"/>
           </a:p>
@@ -4646,7 +5699,7 @@
                 <a:ea typeface="Calibri" pitchFamily="34" charset="-122"/>
                 <a:cs typeface="Calibri" pitchFamily="34" charset="-120"/>
               </a:rPr>
-              <a:t>5 / 10</a:t>
+              <a:t>5 / 12</a:t>
             </a:r>
             <a:endParaRPr lang="en-US" sz="1100" dirty="0"/>
           </a:p>
@@ -5086,7 +6139,7 @@
                 <a:ea typeface="Calibri" pitchFamily="34" charset="-122"/>
                 <a:cs typeface="Calibri" pitchFamily="34" charset="-120"/>
               </a:rPr>
-              <a:t>6 / 10</a:t>
+              <a:t>6 / 12</a:t>
             </a:r>
             <a:endParaRPr lang="en-US" sz="1100" dirty="0"/>
           </a:p>
@@ -5599,7 +6652,7 @@
                 <a:ea typeface="Calibri" pitchFamily="34" charset="-122"/>
                 <a:cs typeface="Calibri" pitchFamily="34" charset="-120"/>
               </a:rPr>
-              <a:t>7 / 10</a:t>
+              <a:t>7 / 12</a:t>
             </a:r>
             <a:endParaRPr lang="en-US" sz="1100" dirty="0"/>
           </a:p>
@@ -5683,7 +6736,7 @@
                 <a:ea typeface="Calibri" pitchFamily="34" charset="-122"/>
                 <a:cs typeface="Calibri" pitchFamily="34" charset="-120"/>
               </a:rPr>
-              <a:t>LIVE LINK &amp; DEMO</a:t>
+              <a:t>BUSINESS MODEL</a:t>
             </a:r>
             <a:endParaRPr lang="en-US" sz="1200" dirty="0"/>
           </a:p>
@@ -5698,23 +6751,23 @@
         <p:spPr>
           <a:xfrm>
             <a:off x="640080" y="1005840"/>
-            <a:ext cx="10515600" cy="822960"/>
-          </a:xfrm>
-          <a:prstGeom prst="rect">
-            <a:avLst/>
-          </a:prstGeom>
-          <a:noFill/>
-          <a:ln/>
-        </p:spPr>
-        <p:txBody>
-          <a:bodyPr wrap="square" rtlCol="0" anchor="ctr"/>
-          <a:lstStyle/>
-          <a:p>
-            <a:pPr indent="0" marL="0">
-              <a:buNone/>
-            </a:pPr>
-            <a:r>
-              <a:rPr lang="en-US" sz="3200" dirty="0">
+            <a:ext cx="10972800" cy="1005840"/>
+          </a:xfrm>
+          <a:prstGeom prst="rect">
+            <a:avLst/>
+          </a:prstGeom>
+          <a:noFill/>
+          <a:ln/>
+        </p:spPr>
+        <p:txBody>
+          <a:bodyPr wrap="square" rtlCol="0" anchor="ctr"/>
+          <a:lstStyle/>
+          <a:p>
+            <a:pPr indent="0" marL="0">
+              <a:buNone/>
+            </a:pPr>
+            <a:r>
+              <a:rPr lang="en-US" sz="2800" dirty="0">
                 <a:solidFill>
                   <a:srgbClr val="F4F6FB"/>
                 </a:solidFill>
@@ -5722,38 +6775,60 @@
                 <a:ea typeface="Georgia" pitchFamily="34" charset="-122"/>
                 <a:cs typeface="Georgia" pitchFamily="34" charset="-120"/>
               </a:rPr>
-              <a:t>Try the product. Watch the aha.</a:t>
-            </a:r>
-            <a:endParaRPr lang="en-US" sz="3200" dirty="0"/>
-          </a:p>
-        </p:txBody>
-      </p:sp>
-      <p:sp>
-        <p:nvSpPr>
-          <p:cNvPr id="5" name="Text 3"/>
-          <p:cNvSpPr/>
-          <p:nvPr/>
-        </p:nvSpPr>
-        <p:spPr>
-          <a:xfrm>
-            <a:off x="640080" y="2011680"/>
-            <a:ext cx="10515600" cy="1005840"/>
-          </a:xfrm>
-          <a:prstGeom prst="rect">
-            <a:avLst/>
-          </a:prstGeom>
-          <a:noFill/>
-          <a:ln/>
-        </p:spPr>
-        <p:txBody>
-          <a:bodyPr wrap="square" rtlCol="0" anchor="ctr"/>
-          <a:lstStyle/>
-          <a:p>
-            <a:pPr indent="0" marL="0">
-              <a:buNone/>
-            </a:pPr>
-            <a:r>
-              <a:rPr lang="en-US" sz="1600" dirty="0">
+              <a:t>Free for students first. Paid where schools need visibility.</a:t>
+            </a:r>
+            <a:endParaRPr lang="en-US" sz="2800" dirty="0"/>
+          </a:p>
+        </p:txBody>
+      </p:sp>
+      <p:sp>
+        <p:nvSpPr>
+          <p:cNvPr id="5" name="Shape 3"/>
+          <p:cNvSpPr/>
+          <p:nvPr/>
+        </p:nvSpPr>
+        <p:spPr>
+          <a:xfrm>
+            <a:off x="640080" y="2286000"/>
+            <a:ext cx="3566160" cy="2377440"/>
+          </a:xfrm>
+          <a:prstGeom prst="roundRect">
+            <a:avLst>
+              <a:gd name="adj" fmla="val 4615"/>
+            </a:avLst>
+          </a:prstGeom>
+          <a:solidFill>
+            <a:srgbClr val="0E121B"/>
+          </a:solidFill>
+          <a:ln/>
+        </p:spPr>
+      </p:sp>
+      <p:sp>
+        <p:nvSpPr>
+          <p:cNvPr id="6" name="Text 4"/>
+          <p:cNvSpPr/>
+          <p:nvPr/>
+        </p:nvSpPr>
+        <p:spPr>
+          <a:xfrm>
+            <a:off x="868680" y="2514600"/>
+            <a:ext cx="3108960" cy="320040"/>
+          </a:xfrm>
+          <a:prstGeom prst="rect">
+            <a:avLst/>
+          </a:prstGeom>
+          <a:noFill/>
+          <a:ln/>
+        </p:spPr>
+        <p:txBody>
+          <a:bodyPr wrap="square" rtlCol="0" anchor="ctr"/>
+          <a:lstStyle/>
+          <a:p>
+            <a:pPr indent="0" marL="0">
+              <a:buNone/>
+            </a:pPr>
+            <a:r>
+              <a:rPr lang="en-US" sz="1200" b="1" dirty="0">
                 <a:solidFill>
                   <a:srgbClr val="9AA3B5"/>
                 </a:solidFill>
@@ -5761,21 +6836,260 @@
                 <a:ea typeface="Calibri" pitchFamily="34" charset="-122"/>
                 <a:cs typeface="Calibri" pitchFamily="34" charset="-120"/>
               </a:rPr>
-              <a:t>Web companion (same memory loop): open Learn → ask a topic → miss one question → Reca comes back. WhatsApp is the stage hero — Reca messages first.</a:t>
-            </a:r>
-            <a:endParaRPr lang="en-US" sz="1600" dirty="0"/>
-          </a:p>
-        </p:txBody>
-      </p:sp>
-      <p:sp>
-        <p:nvSpPr>
-          <p:cNvPr id="6" name="Text 4"/>
-          <p:cNvSpPr/>
-          <p:nvPr/>
-        </p:nvSpPr>
-        <p:spPr>
-          <a:xfrm>
-            <a:off x="640080" y="3291840"/>
+              <a:t>FREEMIUM</a:t>
+            </a:r>
+            <a:endParaRPr lang="en-US" sz="1200" dirty="0"/>
+          </a:p>
+        </p:txBody>
+      </p:sp>
+      <p:sp>
+        <p:nvSpPr>
+          <p:cNvPr id="7" name="Text 5"/>
+          <p:cNvSpPr/>
+          <p:nvPr/>
+        </p:nvSpPr>
+        <p:spPr>
+          <a:xfrm>
+            <a:off x="868680" y="3017520"/>
+            <a:ext cx="3108960" cy="1371600"/>
+          </a:xfrm>
+          <a:prstGeom prst="rect">
+            <a:avLst/>
+          </a:prstGeom>
+          <a:noFill/>
+          <a:ln/>
+        </p:spPr>
+        <p:txBody>
+          <a:bodyPr wrap="square" rtlCol="0" anchor="ctr"/>
+          <a:lstStyle/>
+          <a:p>
+            <a:pPr indent="0" marL="0">
+              <a:buNone/>
+            </a:pPr>
+            <a:r>
+              <a:rPr lang="en-US" sz="1400" dirty="0">
+                <a:solidFill>
+                  <a:srgbClr val="F4F6FB"/>
+                </a:solidFill>
+                <a:latin typeface="Calibri" pitchFamily="34" charset="0"/>
+                <a:ea typeface="Calibri" pitchFamily="34" charset="-122"/>
+                <a:cs typeface="Calibri" pitchFamily="34" charset="-120"/>
+              </a:rPr>
+              <a:t>Individual students stay free — low marginal AI cost per interaction.</a:t>
+            </a:r>
+            <a:endParaRPr lang="en-US" sz="1400" dirty="0"/>
+          </a:p>
+        </p:txBody>
+      </p:sp>
+      <p:sp>
+        <p:nvSpPr>
+          <p:cNvPr id="8" name="Shape 6"/>
+          <p:cNvSpPr/>
+          <p:nvPr/>
+        </p:nvSpPr>
+        <p:spPr>
+          <a:xfrm>
+            <a:off x="4389120" y="2286000"/>
+            <a:ext cx="3566160" cy="2377440"/>
+          </a:xfrm>
+          <a:prstGeom prst="roundRect">
+            <a:avLst>
+              <a:gd name="adj" fmla="val 4615"/>
+            </a:avLst>
+          </a:prstGeom>
+          <a:solidFill>
+            <a:srgbClr val="0E121B"/>
+          </a:solidFill>
+          <a:ln/>
+        </p:spPr>
+      </p:sp>
+      <p:sp>
+        <p:nvSpPr>
+          <p:cNvPr id="9" name="Text 7"/>
+          <p:cNvSpPr/>
+          <p:nvPr/>
+        </p:nvSpPr>
+        <p:spPr>
+          <a:xfrm>
+            <a:off x="4617720" y="2514600"/>
+            <a:ext cx="3108960" cy="320040"/>
+          </a:xfrm>
+          <a:prstGeom prst="rect">
+            <a:avLst/>
+          </a:prstGeom>
+          <a:noFill/>
+          <a:ln/>
+        </p:spPr>
+        <p:txBody>
+          <a:bodyPr wrap="square" rtlCol="0" anchor="ctr"/>
+          <a:lstStyle/>
+          <a:p>
+            <a:pPr indent="0" marL="0">
+              <a:buNone/>
+            </a:pPr>
+            <a:r>
+              <a:rPr lang="en-US" sz="1200" b="1" dirty="0">
+                <a:solidFill>
+                  <a:srgbClr val="9AA3B5"/>
+                </a:solidFill>
+                <a:latin typeface="Calibri" pitchFamily="34" charset="0"/>
+                <a:ea typeface="Calibri" pitchFamily="34" charset="-122"/>
+                <a:cs typeface="Calibri" pitchFamily="34" charset="-120"/>
+              </a:rPr>
+              <a:t>B2B2C</a:t>
+            </a:r>
+            <a:endParaRPr lang="en-US" sz="1200" dirty="0"/>
+          </a:p>
+        </p:txBody>
+      </p:sp>
+      <p:sp>
+        <p:nvSpPr>
+          <p:cNvPr id="10" name="Text 8"/>
+          <p:cNvSpPr/>
+          <p:nvPr/>
+        </p:nvSpPr>
+        <p:spPr>
+          <a:xfrm>
+            <a:off x="4617720" y="3017520"/>
+            <a:ext cx="3108960" cy="1371600"/>
+          </a:xfrm>
+          <a:prstGeom prst="rect">
+            <a:avLst/>
+          </a:prstGeom>
+          <a:noFill/>
+          <a:ln/>
+        </p:spPr>
+        <p:txBody>
+          <a:bodyPr wrap="square" rtlCol="0" anchor="ctr"/>
+          <a:lstStyle/>
+          <a:p>
+            <a:pPr indent="0" marL="0">
+              <a:buNone/>
+            </a:pPr>
+            <a:r>
+              <a:rPr lang="en-US" sz="1400" dirty="0">
+                <a:solidFill>
+                  <a:srgbClr val="F4F6FB"/>
+                </a:solidFill>
+                <a:latin typeface="Calibri" pitchFamily="34" charset="0"/>
+                <a:ea typeface="Calibri" pitchFamily="34" charset="-122"/>
+                <a:cs typeface="Calibri" pitchFamily="34" charset="-120"/>
+              </a:rPr>
+              <a:t>Private schools &amp; tutorial centres — per-student / cohort plans + teacher progress view.</a:t>
+            </a:r>
+            <a:endParaRPr lang="en-US" sz="1400" dirty="0"/>
+          </a:p>
+        </p:txBody>
+      </p:sp>
+      <p:sp>
+        <p:nvSpPr>
+          <p:cNvPr id="11" name="Shape 9"/>
+          <p:cNvSpPr/>
+          <p:nvPr/>
+        </p:nvSpPr>
+        <p:spPr>
+          <a:xfrm>
+            <a:off x="8138160" y="2286000"/>
+            <a:ext cx="3566160" cy="2377440"/>
+          </a:xfrm>
+          <a:prstGeom prst="roundRect">
+            <a:avLst>
+              <a:gd name="adj" fmla="val 4615"/>
+            </a:avLst>
+          </a:prstGeom>
+          <a:solidFill>
+            <a:srgbClr val="0E121B"/>
+          </a:solidFill>
+          <a:ln/>
+        </p:spPr>
+      </p:sp>
+      <p:sp>
+        <p:nvSpPr>
+          <p:cNvPr id="12" name="Text 10"/>
+          <p:cNvSpPr/>
+          <p:nvPr/>
+        </p:nvSpPr>
+        <p:spPr>
+          <a:xfrm>
+            <a:off x="8366760" y="2514600"/>
+            <a:ext cx="3108960" cy="320040"/>
+          </a:xfrm>
+          <a:prstGeom prst="rect">
+            <a:avLst/>
+          </a:prstGeom>
+          <a:noFill/>
+          <a:ln/>
+        </p:spPr>
+        <p:txBody>
+          <a:bodyPr wrap="square" rtlCol="0" anchor="ctr"/>
+          <a:lstStyle/>
+          <a:p>
+            <a:pPr indent="0" marL="0">
+              <a:buNone/>
+            </a:pPr>
+            <a:r>
+              <a:rPr lang="en-US" sz="1200" b="1" dirty="0">
+                <a:solidFill>
+                  <a:srgbClr val="9AA3B5"/>
+                </a:solidFill>
+                <a:latin typeface="Calibri" pitchFamily="34" charset="0"/>
+                <a:ea typeface="Calibri" pitchFamily="34" charset="-122"/>
+                <a:cs typeface="Calibri" pitchFamily="34" charset="-120"/>
+              </a:rPr>
+              <a:t>SPONSORED</a:t>
+            </a:r>
+            <a:endParaRPr lang="en-US" sz="1200" dirty="0"/>
+          </a:p>
+        </p:txBody>
+      </p:sp>
+      <p:sp>
+        <p:nvSpPr>
+          <p:cNvPr id="13" name="Text 11"/>
+          <p:cNvSpPr/>
+          <p:nvPr/>
+        </p:nvSpPr>
+        <p:spPr>
+          <a:xfrm>
+            <a:off x="8366760" y="3017520"/>
+            <a:ext cx="3108960" cy="1371600"/>
+          </a:xfrm>
+          <a:prstGeom prst="rect">
+            <a:avLst/>
+          </a:prstGeom>
+          <a:noFill/>
+          <a:ln/>
+        </p:spPr>
+        <p:txBody>
+          <a:bodyPr wrap="square" rtlCol="0" anchor="ctr"/>
+          <a:lstStyle/>
+          <a:p>
+            <a:pPr indent="0" marL="0">
+              <a:buNone/>
+            </a:pPr>
+            <a:r>
+              <a:rPr lang="en-US" sz="1400" dirty="0">
+                <a:solidFill>
+                  <a:srgbClr val="F4F6FB"/>
+                </a:solidFill>
+                <a:latin typeface="Calibri" pitchFamily="34" charset="0"/>
+                <a:ea typeface="Calibri" pitchFamily="34" charset="-122"/>
+                <a:cs typeface="Calibri" pitchFamily="34" charset="-120"/>
+              </a:rPr>
+              <a:t>Exam-prep sponsors, NGOs, or telcos subsidise public-school students.</a:t>
+            </a:r>
+            <a:endParaRPr lang="en-US" sz="1400" dirty="0"/>
+          </a:p>
+        </p:txBody>
+      </p:sp>
+      <p:sp>
+        <p:nvSpPr>
+          <p:cNvPr id="14" name="Text 12"/>
+          <p:cNvSpPr/>
+          <p:nvPr/>
+        </p:nvSpPr>
+        <p:spPr>
+          <a:xfrm>
+            <a:off x="640080" y="5029200"/>
             <a:ext cx="10972800" cy="457200"/>
           </a:xfrm>
           <a:prstGeom prst="rect">
@@ -5792,45 +7106,6 @@
               <a:buNone/>
             </a:pPr>
             <a:r>
-              <a:rPr lang="en-US" sz="1800" b="1" dirty="0">
-                <a:solidFill>
-                  <a:srgbClr val="225AEB"/>
-                </a:solidFill>
-                <a:latin typeface="Calibri" pitchFamily="34" charset="0"/>
-                <a:ea typeface="Calibri" pitchFamily="34" charset="-122"/>
-                <a:cs typeface="Calibri" pitchFamily="34" charset="-120"/>
-              </a:rPr>
-              <a:t>https://reca-study-companion.vercel.app/signup.html</a:t>
-            </a:r>
-            <a:endParaRPr lang="en-US" sz="1800" dirty="0"/>
-          </a:p>
-        </p:txBody>
-      </p:sp>
-      <p:sp>
-        <p:nvSpPr>
-          <p:cNvPr id="7" name="Text 5"/>
-          <p:cNvSpPr/>
-          <p:nvPr/>
-        </p:nvSpPr>
-        <p:spPr>
-          <a:xfrm>
-            <a:off x="640080" y="4114800"/>
-            <a:ext cx="10972800" cy="640080"/>
-          </a:xfrm>
-          <a:prstGeom prst="rect">
-            <a:avLst/>
-          </a:prstGeom>
-          <a:noFill/>
-          <a:ln/>
-        </p:spPr>
-        <p:txBody>
-          <a:bodyPr wrap="square" rtlCol="0" anchor="ctr"/>
-          <a:lstStyle/>
-          <a:p>
-            <a:pPr indent="0" marL="0">
-              <a:buNone/>
-            </a:pPr>
-            <a:r>
               <a:rPr lang="en-US" sz="1400" dirty="0">
                 <a:solidFill>
                   <a:srgbClr val="9AA3B5"/>
@@ -5839,7 +7114,7 @@
                 <a:ea typeface="Calibri" pitchFamily="34" charset="-122"/>
                 <a:cs typeface="Calibri" pitchFamily="34" charset="-120"/>
               </a:rPr>
-              <a:t>Demo script: explain photosynthesis → wrong Q1 (mitochondria) → unprompted resurface → chloroplast</a:t>
+              <a:t>Moat: attempt history + WhatsApp distribution + WAEC/JAMB curriculum.</a:t>
             </a:r>
             <a:endParaRPr lang="en-US" sz="1400" dirty="0"/>
           </a:p>
@@ -5847,7 +7122,7 @@
       </p:sp>
       <p:sp>
         <p:nvSpPr>
-          <p:cNvPr id="8" name="Text 6"/>
+          <p:cNvPr id="15" name="Text 13"/>
           <p:cNvSpPr/>
           <p:nvPr/>
         </p:nvSpPr>
@@ -5878,7 +7153,7 @@
                 <a:ea typeface="Calibri" pitchFamily="34" charset="-122"/>
                 <a:cs typeface="Calibri" pitchFamily="34" charset="-120"/>
               </a:rPr>
-              <a:t>Guest mode available</a:t>
+              <a:t>Post-fest roadmap</a:t>
             </a:r>
             <a:endParaRPr lang="en-US" sz="1100" dirty="0"/>
           </a:p>
@@ -5886,7 +7161,7 @@
       </p:sp>
       <p:sp>
         <p:nvSpPr>
-          <p:cNvPr id="9" name="Text 7"/>
+          <p:cNvPr id="16" name="Text 14"/>
           <p:cNvSpPr/>
           <p:nvPr/>
         </p:nvSpPr>
@@ -5917,7 +7192,7 @@
                 <a:ea typeface="Calibri" pitchFamily="34" charset="-122"/>
                 <a:cs typeface="Calibri" pitchFamily="34" charset="-120"/>
               </a:rPr>
-              <a:t>8 / 10</a:t>
+              <a:t>8 / 12</a:t>
             </a:r>
             <a:endParaRPr lang="en-US" sz="1100" dirty="0"/>
           </a:p>
@@ -6001,7 +7276,7 @@
                 <a:ea typeface="Calibri" pitchFamily="34" charset="-122"/>
                 <a:cs typeface="Calibri" pitchFamily="34" charset="-120"/>
               </a:rPr>
-              <a:t>WHY WE BUILT RECA</a:t>
+              <a:t>LIVE LINK &amp; DEMO</a:t>
             </a:r>
             <a:endParaRPr lang="en-US" sz="1200" dirty="0"/>
           </a:p>
@@ -6015,24 +7290,24 @@
         </p:nvSpPr>
         <p:spPr>
           <a:xfrm>
-            <a:off x="640080" y="1097280"/>
-            <a:ext cx="10515600" cy="1371600"/>
-          </a:xfrm>
-          <a:prstGeom prst="rect">
-            <a:avLst/>
-          </a:prstGeom>
-          <a:noFill/>
-          <a:ln/>
-        </p:spPr>
-        <p:txBody>
-          <a:bodyPr wrap="square" rtlCol="0" anchor="ctr"/>
-          <a:lstStyle/>
-          <a:p>
-            <a:pPr indent="0" marL="0">
-              <a:buNone/>
-            </a:pPr>
-            <a:r>
-              <a:rPr lang="en-US" sz="3000" dirty="0">
+            <a:off x="640080" y="1005840"/>
+            <a:ext cx="10515600" cy="822960"/>
+          </a:xfrm>
+          <a:prstGeom prst="rect">
+            <a:avLst/>
+          </a:prstGeom>
+          <a:noFill/>
+          <a:ln/>
+        </p:spPr>
+        <p:txBody>
+          <a:bodyPr wrap="square" rtlCol="0" anchor="ctr"/>
+          <a:lstStyle/>
+          <a:p>
+            <a:pPr indent="0" marL="0">
+              <a:buNone/>
+            </a:pPr>
+            <a:r>
+              <a:rPr lang="en-US" sz="3200" dirty="0">
                 <a:solidFill>
                   <a:srgbClr val="F4F6FB"/>
                 </a:solidFill>
@@ -6040,9 +7315,9 @@
                 <a:ea typeface="Georgia" pitchFamily="34" charset="-122"/>
                 <a:cs typeface="Georgia" pitchFamily="34" charset="-120"/>
               </a:rPr>
-              <a:t>Because explanations without follow-up still leave students alone.</a:t>
-            </a:r>
-            <a:endParaRPr lang="en-US" sz="3000" dirty="0"/>
+              <a:t>Try the product. Watch the aha.</a:t>
+            </a:r>
+            <a:endParaRPr lang="en-US" sz="3200" dirty="0"/>
           </a:p>
         </p:txBody>
       </p:sp>
@@ -6054,8 +7329,8 @@
         </p:nvSpPr>
         <p:spPr>
           <a:xfrm>
-            <a:off x="640080" y="2743200"/>
-            <a:ext cx="10515600" cy="1188720"/>
+            <a:off x="640080" y="2011680"/>
+            <a:ext cx="10515600" cy="1005840"/>
           </a:xfrm>
           <a:prstGeom prst="rect">
             <a:avLst/>
@@ -6079,7 +7354,7 @@
                 <a:ea typeface="Calibri" pitchFamily="34" charset="-122"/>
                 <a:cs typeface="Calibri" pitchFamily="34" charset="-120"/>
               </a:rPr>
-              <a:t>We didn’t set out to build “another chatbot.” We set out to close the gap between understanding a topic tonight and still owning it on exam day — on the phone students already hold after school.</a:t>
+              <a:t>Web companion (same memory loop): open Learn → ask a topic → miss one question → Reca comes back. WhatsApp is the stage hero — Reca messages first.</a:t>
             </a:r>
             <a:endParaRPr lang="en-US" sz="1600" dirty="0"/>
           </a:p>
@@ -6093,24 +7368,63 @@
         </p:nvSpPr>
         <p:spPr>
           <a:xfrm>
+            <a:off x="640080" y="3291840"/>
+            <a:ext cx="10972800" cy="457200"/>
+          </a:xfrm>
+          <a:prstGeom prst="rect">
+            <a:avLst/>
+          </a:prstGeom>
+          <a:noFill/>
+          <a:ln/>
+        </p:spPr>
+        <p:txBody>
+          <a:bodyPr wrap="square" rtlCol="0" anchor="ctr"/>
+          <a:lstStyle/>
+          <a:p>
+            <a:pPr indent="0" marL="0">
+              <a:buNone/>
+            </a:pPr>
+            <a:r>
+              <a:rPr lang="en-US" sz="1800" b="1" dirty="0">
+                <a:solidFill>
+                  <a:srgbClr val="225AEB"/>
+                </a:solidFill>
+                <a:latin typeface="Calibri" pitchFamily="34" charset="0"/>
+                <a:ea typeface="Calibri" pitchFamily="34" charset="-122"/>
+                <a:cs typeface="Calibri" pitchFamily="34" charset="-120"/>
+              </a:rPr>
+              <a:t>https://reca-study-companion.vercel.app/signup.html</a:t>
+            </a:r>
+            <a:endParaRPr lang="en-US" sz="1800" dirty="0"/>
+          </a:p>
+        </p:txBody>
+      </p:sp>
+      <p:sp>
+        <p:nvSpPr>
+          <p:cNvPr id="7" name="Text 5"/>
+          <p:cNvSpPr/>
+          <p:nvPr/>
+        </p:nvSpPr>
+        <p:spPr>
+          <a:xfrm>
             <a:off x="640080" y="4114800"/>
-            <a:ext cx="10515600" cy="914400"/>
-          </a:xfrm>
-          <a:prstGeom prst="rect">
-            <a:avLst/>
-          </a:prstGeom>
-          <a:noFill/>
-          <a:ln/>
-        </p:spPr>
-        <p:txBody>
-          <a:bodyPr wrap="square" rtlCol="0" anchor="ctr"/>
-          <a:lstStyle/>
-          <a:p>
-            <a:pPr indent="0" marL="0">
-              <a:buNone/>
-            </a:pPr>
-            <a:r>
-              <a:rPr lang="en-US" sz="1600" dirty="0">
+            <a:ext cx="10972800" cy="640080"/>
+          </a:xfrm>
+          <a:prstGeom prst="rect">
+            <a:avLst/>
+          </a:prstGeom>
+          <a:noFill/>
+          <a:ln/>
+        </p:spPr>
+        <p:txBody>
+          <a:bodyPr wrap="square" rtlCol="0" anchor="ctr"/>
+          <a:lstStyle/>
+          <a:p>
+            <a:pPr indent="0" marL="0">
+              <a:buNone/>
+            </a:pPr>
+            <a:r>
+              <a:rPr lang="en-US" sz="1400" dirty="0">
                 <a:solidFill>
                   <a:srgbClr val="9AA3B5"/>
                 </a:solidFill>
@@ -6118,15 +7432,15 @@
                 <a:ea typeface="Calibri" pitchFamily="34" charset="-122"/>
                 <a:cs typeface="Calibri" pitchFamily="34" charset="-120"/>
               </a:rPr>
-              <a:t>AI BuildFest gave us two days. We shipped the full loop on a free stack — and the hero is still that unprompted return.</a:t>
-            </a:r>
-            <a:endParaRPr lang="en-US" sz="1600" dirty="0"/>
-          </a:p>
-        </p:txBody>
-      </p:sp>
-      <p:sp>
-        <p:nvSpPr>
-          <p:cNvPr id="7" name="Text 5"/>
+              <a:t>Demo script: explain photosynthesis → wrong Q1 (mitochondria) → unprompted resurface → chloroplast</a:t>
+            </a:r>
+            <a:endParaRPr lang="en-US" sz="1400" dirty="0"/>
+          </a:p>
+        </p:txBody>
+      </p:sp>
+      <p:sp>
+        <p:nvSpPr>
+          <p:cNvPr id="8" name="Text 6"/>
           <p:cNvSpPr/>
           <p:nvPr/>
         </p:nvSpPr>
@@ -6157,7 +7471,7 @@
                 <a:ea typeface="Calibri" pitchFamily="34" charset="-122"/>
                 <a:cs typeface="Calibri" pitchFamily="34" charset="-120"/>
               </a:rPr>
-              <a:t>Case Study 2 · AI for Everyday Life</a:t>
+              <a:t>Guest mode available</a:t>
             </a:r>
             <a:endParaRPr lang="en-US" sz="1100" dirty="0"/>
           </a:p>
@@ -6165,7 +7479,7 @@
       </p:sp>
       <p:sp>
         <p:nvSpPr>
-          <p:cNvPr id="8" name="Text 6"/>
+          <p:cNvPr id="9" name="Text 7"/>
           <p:cNvSpPr/>
           <p:nvPr/>
         </p:nvSpPr>
@@ -6196,7 +7510,7 @@
                 <a:ea typeface="Calibri" pitchFamily="34" charset="-122"/>
                 <a:cs typeface="Calibri" pitchFamily="34" charset="-120"/>
               </a:rPr>
-              <a:t>9 / 10</a:t>
+              <a:t>9 / 12</a:t>
             </a:r>
             <a:endParaRPr lang="en-US" sz="1100" dirty="0"/>
           </a:p>

</xml_diff>

<commit_message>
Expand BuildFest pitch package to 13 slides with tools slide.
Add Meta/Gemini/Antigravity/Cursor tooling to the deck and sync checklist plus HTML/PPTX generators.

Co-authored-by: Cursor <cursoragent@cursor.com>
</commit_message>
<xml_diff>
--- a/docs/reca/pitch/Reca-Pitch-Deck.pptx
+++ b/docs/reca/pitch/Reca-Pitch-Deck.pptx
@@ -17,9 +17,10 @@
     <p:sldId id="265" r:id="rId11"/>
     <p:sldId id="266" r:id="rId12"/>
     <p:sldId id="267" r:id="rId13"/>
+    <p:sldId id="268" r:id="rId14"/>
   </p:sldIdLst>
   <p:notesMasterIdLst>
-    <p:notesMasterId r:id="rId14"/>
+    <p:notesMasterId r:id="rId15"/>
   </p:notesMasterIdLst>
   <p:sldSz cx="12191695" cy="6858000"/>
   <p:notesSz cx="6858000" cy="12191695"/>
@@ -801,6 +802,94 @@
             <a:fld id="{F7021451-1387-4CA6-816F-3879F97B5CBC}" type="slidenum">
               <a:rPr lang="en-US"/>
               <a:t>12</a:t>
+            </a:fld>
+            <a:endParaRPr lang="en-US"/>
+          </a:p>
+        </p:txBody>
+      </p:sp>
+    </p:spTree>
+    <p:extLst>
+      <p:ext uri="{BB962C8B-B14F-4D97-AF65-F5344CB8AC3E}">
+        <p14:creationId xmlns:p14="http://schemas.microsoft.com/office/powerpoint/2010/main" val="1024086991"/>
+      </p:ext>
+    </p:extLst>
+  </p:cSld>
+  <p:clrMapOvr>
+    <a:masterClrMapping/>
+  </p:clrMapOvr>
+</p:notes>
+</file>
+
+<file path=ppt/notesSlides/notesSlide13.xml><?xml version="1.0" encoding="utf-8"?>
+<p:notes xmlns:a="http://schemas.openxmlformats.org/drawingml/2006/main" xmlns:r="http://schemas.openxmlformats.org/officeDocument/2006/relationships" xmlns:p="http://schemas.openxmlformats.org/presentationml/2006/main">
+  <p:cSld>
+    <p:spTree>
+      <p:nvGrpSpPr>
+        <p:cNvPr id="1" name=""/>
+        <p:cNvGrpSpPr/>
+        <p:nvPr/>
+      </p:nvGrpSpPr>
+      <p:grpSpPr>
+        <a:xfrm>
+          <a:off x="0" y="0"/>
+          <a:ext cx="0" cy="0"/>
+          <a:chOff x="0" y="0"/>
+          <a:chExt cx="0" cy="0"/>
+        </a:xfrm>
+      </p:grpSpPr>
+      <p:sp>
+        <p:nvSpPr>
+          <p:cNvPr id="2" name="Slide Image Placeholder 1"/>
+          <p:cNvSpPr>
+            <a:spLocks noGrp="1" noRot="1" noChangeAspect="1"/>
+          </p:cNvSpPr>
+          <p:nvPr>
+            <p:ph type="sldImg"/>
+          </p:nvPr>
+        </p:nvSpPr>
+        <p:spPr/>
+      </p:sp>
+      <p:sp>
+        <p:nvSpPr>
+          <p:cNvPr id="3" name="Notes Placeholder 2"/>
+          <p:cNvSpPr>
+            <a:spLocks noGrp="1"/>
+          </p:cNvSpPr>
+          <p:nvPr>
+            <p:ph type="body" idx="1"/>
+          </p:nvPr>
+        </p:nvSpPr>
+        <p:spPr/>
+        <p:txBody>
+          <a:bodyPr/>
+          <a:lstStyle/>
+          <a:p>
+            <a:r>
+              <a:rPr lang="en-US" dirty="0"/>
+              <a:t/>
+            </a:r>
+            <a:endParaRPr lang="en-US" dirty="0"/>
+          </a:p>
+        </p:txBody>
+      </p:sp>
+      <p:sp>
+        <p:nvSpPr>
+          <p:cNvPr id="4" name="Slide Number Placeholder 3"/>
+          <p:cNvSpPr>
+            <a:spLocks noGrp="1"/>
+          </p:cNvSpPr>
+          <p:nvPr>
+            <p:ph type="sldNum" sz="quarter" idx="10"/>
+          </p:nvPr>
+        </p:nvSpPr>
+        <p:spPr/>
+        <p:txBody>
+          <a:bodyPr/>
+          <a:lstStyle/>
+          <a:p>
+            <a:fld id="{F7021451-1387-4CA6-816F-3879F97B5CBC}" type="slidenum">
+              <a:rPr lang="en-US"/>
+              <a:t>13</a:t>
             </a:fld>
             <a:endParaRPr lang="en-US"/>
           </a:p>
@@ -2212,7 +2301,7 @@
                 <a:ea typeface="Calibri" pitchFamily="34" charset="-122"/>
                 <a:cs typeface="Calibri" pitchFamily="34" charset="-120"/>
               </a:rPr>
-              <a:t>1 / 12</a:t>
+              <a:t>1 / 13</a:t>
             </a:r>
             <a:endParaRPr lang="en-US" sz="1100" dirty="0"/>
           </a:p>
@@ -2296,7 +2385,7 @@
                 <a:ea typeface="Calibri" pitchFamily="34" charset="-122"/>
                 <a:cs typeface="Calibri" pitchFamily="34" charset="-120"/>
               </a:rPr>
-              <a:t>THE TEAM</a:t>
+              <a:t>LIVE LINK &amp; DEMO</a:t>
             </a:r>
             <a:endParaRPr lang="en-US" sz="1200" dirty="0"/>
           </a:p>
@@ -2311,7 +2400,7 @@
         <p:spPr>
           <a:xfrm>
             <a:off x="640080" y="1005840"/>
-            <a:ext cx="10515600" cy="731520"/>
+            <a:ext cx="10515600" cy="822960"/>
           </a:xfrm>
           <a:prstGeom prst="rect">
             <a:avLst/>
@@ -2335,7 +2424,7 @@
                 <a:ea typeface="Georgia" pitchFamily="34" charset="-122"/>
                 <a:cs typeface="Georgia" pitchFamily="34" charset="-120"/>
               </a:rPr>
-              <a:t>Who built Reca.</a:t>
+              <a:t>Try the product. Watch the aha.</a:t>
             </a:r>
             <a:endParaRPr lang="en-US" sz="3200" dirty="0"/>
           </a:p>
@@ -2343,47 +2432,81 @@
       </p:sp>
       <p:sp>
         <p:nvSpPr>
-          <p:cNvPr id="5" name="Shape 3"/>
+          <p:cNvPr id="5" name="Text 3"/>
           <p:cNvSpPr/>
           <p:nvPr/>
         </p:nvSpPr>
         <p:spPr>
           <a:xfrm>
             <a:off x="640080" y="2011680"/>
-            <a:ext cx="5212080" cy="2560320"/>
-          </a:xfrm>
-          <a:prstGeom prst="roundRect">
-            <a:avLst>
-              <a:gd name="adj" fmla="val 4286"/>
-            </a:avLst>
-          </a:prstGeom>
-          <a:solidFill>
-            <a:srgbClr val="0E121B"/>
-          </a:solidFill>
-          <a:ln/>
-        </p:spPr>
-      </p:sp>
-      <p:sp>
-        <p:nvSpPr>
-          <p:cNvPr id="6" name="Shape 4"/>
-          <p:cNvSpPr/>
-          <p:nvPr/>
-        </p:nvSpPr>
-        <p:spPr>
-          <a:xfrm>
-            <a:off x="6309360" y="2011680"/>
-            <a:ext cx="5212080" cy="2560320"/>
-          </a:xfrm>
-          <a:prstGeom prst="roundRect">
-            <a:avLst>
-              <a:gd name="adj" fmla="val 4286"/>
-            </a:avLst>
-          </a:prstGeom>
-          <a:solidFill>
-            <a:srgbClr val="0E121B"/>
-          </a:solidFill>
-          <a:ln/>
-        </p:spPr>
+            <a:ext cx="10515600" cy="1005840"/>
+          </a:xfrm>
+          <a:prstGeom prst="rect">
+            <a:avLst/>
+          </a:prstGeom>
+          <a:noFill/>
+          <a:ln/>
+        </p:spPr>
+        <p:txBody>
+          <a:bodyPr wrap="square" rtlCol="0" anchor="ctr"/>
+          <a:lstStyle/>
+          <a:p>
+            <a:pPr indent="0" marL="0">
+              <a:buNone/>
+            </a:pPr>
+            <a:r>
+              <a:rPr lang="en-US" sz="1600" dirty="0">
+                <a:solidFill>
+                  <a:srgbClr val="9AA3B5"/>
+                </a:solidFill>
+                <a:latin typeface="Calibri" pitchFamily="34" charset="0"/>
+                <a:ea typeface="Calibri" pitchFamily="34" charset="-122"/>
+                <a:cs typeface="Calibri" pitchFamily="34" charset="-120"/>
+              </a:rPr>
+              <a:t>Web companion (same memory loop): open Learn → ask a topic → miss one question → Reca comes back. WhatsApp is the stage hero — Reca messages first.</a:t>
+            </a:r>
+            <a:endParaRPr lang="en-US" sz="1600" dirty="0"/>
+          </a:p>
+        </p:txBody>
+      </p:sp>
+      <p:sp>
+        <p:nvSpPr>
+          <p:cNvPr id="6" name="Text 4"/>
+          <p:cNvSpPr/>
+          <p:nvPr/>
+        </p:nvSpPr>
+        <p:spPr>
+          <a:xfrm>
+            <a:off x="640080" y="3291840"/>
+            <a:ext cx="10972800" cy="457200"/>
+          </a:xfrm>
+          <a:prstGeom prst="rect">
+            <a:avLst/>
+          </a:prstGeom>
+          <a:noFill/>
+          <a:ln/>
+        </p:spPr>
+        <p:txBody>
+          <a:bodyPr wrap="square" rtlCol="0" anchor="ctr"/>
+          <a:lstStyle/>
+          <a:p>
+            <a:pPr indent="0" marL="0">
+              <a:buNone/>
+            </a:pPr>
+            <a:r>
+              <a:rPr lang="en-US" sz="1800" b="1" dirty="0">
+                <a:solidFill>
+                  <a:srgbClr val="225AEB"/>
+                </a:solidFill>
+                <a:latin typeface="Calibri" pitchFamily="34" charset="0"/>
+                <a:ea typeface="Calibri" pitchFamily="34" charset="-122"/>
+                <a:cs typeface="Calibri" pitchFamily="34" charset="-120"/>
+              </a:rPr>
+              <a:t>https://reca-study-companion.vercel.app/signup.html</a:t>
+            </a:r>
+            <a:endParaRPr lang="en-US" sz="1800" dirty="0"/>
+          </a:p>
+        </p:txBody>
       </p:sp>
       <p:sp>
         <p:nvSpPr>
@@ -2393,24 +2516,24 @@
         </p:nvSpPr>
         <p:spPr>
           <a:xfrm>
-            <a:off x="914400" y="2240280"/>
-            <a:ext cx="4572000" cy="274320"/>
-          </a:xfrm>
-          <a:prstGeom prst="rect">
-            <a:avLst/>
-          </a:prstGeom>
-          <a:noFill/>
-          <a:ln/>
-        </p:spPr>
-        <p:txBody>
-          <a:bodyPr wrap="square" rtlCol="0" anchor="ctr"/>
-          <a:lstStyle/>
-          <a:p>
-            <a:pPr indent="0" marL="0">
-              <a:buNone/>
-            </a:pPr>
-            <a:r>
-              <a:rPr lang="en-US" sz="1200" b="1" dirty="0">
+            <a:off x="640080" y="4114800"/>
+            <a:ext cx="10972800" cy="640080"/>
+          </a:xfrm>
+          <a:prstGeom prst="rect">
+            <a:avLst/>
+          </a:prstGeom>
+          <a:noFill/>
+          <a:ln/>
+        </p:spPr>
+        <p:txBody>
+          <a:bodyPr wrap="square" rtlCol="0" anchor="ctr"/>
+          <a:lstStyle/>
+          <a:p>
+            <a:pPr indent="0" marL="0">
+              <a:buNone/>
+            </a:pPr>
+            <a:r>
+              <a:rPr lang="en-US" sz="1400" dirty="0">
                 <a:solidFill>
                   <a:srgbClr val="9AA3B5"/>
                 </a:solidFill>
@@ -2418,249 +2541,15 @@
                 <a:ea typeface="Calibri" pitchFamily="34" charset="-122"/>
                 <a:cs typeface="Calibri" pitchFamily="34" charset="-120"/>
               </a:rPr>
-              <a:t>PRODUCT DESIGN &amp; UX</a:t>
-            </a:r>
-            <a:endParaRPr lang="en-US" sz="1200" dirty="0"/>
+              <a:t>Demo script: explain photosynthesis → wrong Q1 (mitochondria) → unprompted resurface → chloroplast</a:t>
+            </a:r>
+            <a:endParaRPr lang="en-US" sz="1400" dirty="0"/>
           </a:p>
         </p:txBody>
       </p:sp>
       <p:sp>
         <p:nvSpPr>
           <p:cNvPr id="8" name="Text 6"/>
-          <p:cNvSpPr/>
-          <p:nvPr/>
-        </p:nvSpPr>
-        <p:spPr>
-          <a:xfrm>
-            <a:off x="914400" y="2651760"/>
-            <a:ext cx="4572000" cy="457200"/>
-          </a:xfrm>
-          <a:prstGeom prst="rect">
-            <a:avLst/>
-          </a:prstGeom>
-          <a:noFill/>
-          <a:ln/>
-        </p:spPr>
-        <p:txBody>
-          <a:bodyPr wrap="square" rtlCol="0" anchor="ctr"/>
-          <a:lstStyle/>
-          <a:p>
-            <a:pPr indent="0" marL="0">
-              <a:buNone/>
-            </a:pPr>
-            <a:r>
-              <a:rPr lang="en-US" sz="2200" dirty="0">
-                <a:solidFill>
-                  <a:srgbClr val="F4F6FB"/>
-                </a:solidFill>
-                <a:latin typeface="Georgia" pitchFamily="34" charset="0"/>
-                <a:ea typeface="Georgia" pitchFamily="34" charset="-122"/>
-                <a:cs typeface="Georgia" pitchFamily="34" charset="-120"/>
-              </a:rPr>
-              <a:t>Talodabioluwa Paul</a:t>
-            </a:r>
-            <a:endParaRPr lang="en-US" sz="2200" dirty="0"/>
-          </a:p>
-        </p:txBody>
-      </p:sp>
-      <p:sp>
-        <p:nvSpPr>
-          <p:cNvPr id="9" name="Text 7"/>
-          <p:cNvSpPr/>
-          <p:nvPr/>
-        </p:nvSpPr>
-        <p:spPr>
-          <a:xfrm>
-            <a:off x="914400" y="3246120"/>
-            <a:ext cx="4663440" cy="914400"/>
-          </a:xfrm>
-          <a:prstGeom prst="rect">
-            <a:avLst/>
-          </a:prstGeom>
-          <a:noFill/>
-          <a:ln/>
-        </p:spPr>
-        <p:txBody>
-          <a:bodyPr wrap="square" rtlCol="0" anchor="ctr"/>
-          <a:lstStyle/>
-          <a:p>
-            <a:pPr indent="0" marL="0">
-              <a:buNone/>
-            </a:pPr>
-            <a:r>
-              <a:rPr lang="en-US" sz="1400" dirty="0">
-                <a:solidFill>
-                  <a:srgbClr val="9AA3B5"/>
-                </a:solidFill>
-                <a:latin typeface="Calibri" pitchFamily="34" charset="0"/>
-                <a:ea typeface="Calibri" pitchFamily="34" charset="-122"/>
-                <a:cs typeface="Calibri" pitchFamily="34" charset="-120"/>
-              </a:rPr>
-              <a:t>Experience, copy, flows, and the student-facing product system.</a:t>
-            </a:r>
-            <a:endParaRPr lang="en-US" sz="1400" dirty="0"/>
-          </a:p>
-        </p:txBody>
-      </p:sp>
-      <p:sp>
-        <p:nvSpPr>
-          <p:cNvPr id="10" name="Text 8"/>
-          <p:cNvSpPr/>
-          <p:nvPr/>
-        </p:nvSpPr>
-        <p:spPr>
-          <a:xfrm>
-            <a:off x="6583680" y="2240280"/>
-            <a:ext cx="4572000" cy="274320"/>
-          </a:xfrm>
-          <a:prstGeom prst="rect">
-            <a:avLst/>
-          </a:prstGeom>
-          <a:noFill/>
-          <a:ln/>
-        </p:spPr>
-        <p:txBody>
-          <a:bodyPr wrap="square" rtlCol="0" anchor="ctr"/>
-          <a:lstStyle/>
-          <a:p>
-            <a:pPr indent="0" marL="0">
-              <a:buNone/>
-            </a:pPr>
-            <a:r>
-              <a:rPr lang="en-US" sz="1200" b="1" dirty="0">
-                <a:solidFill>
-                  <a:srgbClr val="9AA3B5"/>
-                </a:solidFill>
-                <a:latin typeface="Calibri" pitchFamily="34" charset="0"/>
-                <a:ea typeface="Calibri" pitchFamily="34" charset="-122"/>
-                <a:cs typeface="Calibri" pitchFamily="34" charset="-120"/>
-              </a:rPr>
-              <a:t>ENGINEERING &amp; WHATSAPP</a:t>
-            </a:r>
-            <a:endParaRPr lang="en-US" sz="1200" dirty="0"/>
-          </a:p>
-        </p:txBody>
-      </p:sp>
-      <p:sp>
-        <p:nvSpPr>
-          <p:cNvPr id="11" name="Text 9"/>
-          <p:cNvSpPr/>
-          <p:nvPr/>
-        </p:nvSpPr>
-        <p:spPr>
-          <a:xfrm>
-            <a:off x="6583680" y="2651760"/>
-            <a:ext cx="4572000" cy="457200"/>
-          </a:xfrm>
-          <a:prstGeom prst="rect">
-            <a:avLst/>
-          </a:prstGeom>
-          <a:noFill/>
-          <a:ln/>
-        </p:spPr>
-        <p:txBody>
-          <a:bodyPr wrap="square" rtlCol="0" anchor="ctr"/>
-          <a:lstStyle/>
-          <a:p>
-            <a:pPr indent="0" marL="0">
-              <a:buNone/>
-            </a:pPr>
-            <a:r>
-              <a:rPr lang="en-US" sz="2200" dirty="0">
-                <a:solidFill>
-                  <a:srgbClr val="F4F6FB"/>
-                </a:solidFill>
-                <a:latin typeface="Georgia" pitchFamily="34" charset="0"/>
-                <a:ea typeface="Georgia" pitchFamily="34" charset="-122"/>
-                <a:cs typeface="Georgia" pitchFamily="34" charset="-120"/>
-              </a:rPr>
-              <a:t>Folarin Oyewole</a:t>
-            </a:r>
-            <a:endParaRPr lang="en-US" sz="2200" dirty="0"/>
-          </a:p>
-        </p:txBody>
-      </p:sp>
-      <p:sp>
-        <p:nvSpPr>
-          <p:cNvPr id="12" name="Text 10"/>
-          <p:cNvSpPr/>
-          <p:nvPr/>
-        </p:nvSpPr>
-        <p:spPr>
-          <a:xfrm>
-            <a:off x="6583680" y="3246120"/>
-            <a:ext cx="4663440" cy="914400"/>
-          </a:xfrm>
-          <a:prstGeom prst="rect">
-            <a:avLst/>
-          </a:prstGeom>
-          <a:noFill/>
-          <a:ln/>
-        </p:spPr>
-        <p:txBody>
-          <a:bodyPr wrap="square" rtlCol="0" anchor="ctr"/>
-          <a:lstStyle/>
-          <a:p>
-            <a:pPr indent="0" marL="0">
-              <a:buNone/>
-            </a:pPr>
-            <a:r>
-              <a:rPr lang="en-US" sz="1400" dirty="0">
-                <a:solidFill>
-                  <a:srgbClr val="9AA3B5"/>
-                </a:solidFill>
-                <a:latin typeface="Calibri" pitchFamily="34" charset="0"/>
-                <a:ea typeface="Calibri" pitchFamily="34" charset="-122"/>
-                <a:cs typeface="Calibri" pitchFamily="34" charset="-120"/>
-              </a:rPr>
-              <a:t>Backend, Meta Cloud API, memory loop, and deploy.</a:t>
-            </a:r>
-            <a:endParaRPr lang="en-US" sz="1400" dirty="0"/>
-          </a:p>
-        </p:txBody>
-      </p:sp>
-      <p:sp>
-        <p:nvSpPr>
-          <p:cNvPr id="13" name="Text 11"/>
-          <p:cNvSpPr/>
-          <p:nvPr/>
-        </p:nvSpPr>
-        <p:spPr>
-          <a:xfrm>
-            <a:off x="640080" y="4937760"/>
-            <a:ext cx="10972800" cy="365760"/>
-          </a:xfrm>
-          <a:prstGeom prst="rect">
-            <a:avLst/>
-          </a:prstGeom>
-          <a:noFill/>
-          <a:ln/>
-        </p:spPr>
-        <p:txBody>
-          <a:bodyPr wrap="square" rtlCol="0" anchor="ctr"/>
-          <a:lstStyle/>
-          <a:p>
-            <a:pPr indent="0" marL="0">
-              <a:buNone/>
-            </a:pPr>
-            <a:r>
-              <a:rPr lang="en-US" sz="1300" dirty="0">
-                <a:solidFill>
-                  <a:srgbClr val="9AA3B5"/>
-                </a:solidFill>
-                <a:latin typeface="Calibri" pitchFamily="34" charset="0"/>
-                <a:ea typeface="Calibri" pitchFamily="34" charset="-122"/>
-                <a:cs typeface="Calibri" pitchFamily="34" charset="-120"/>
-              </a:rPr>
-              <a:t>AI BuildFest 2026 · Track 3 · Case Study 2 · Participant ID BF-0933</a:t>
-            </a:r>
-            <a:endParaRPr lang="en-US" sz="1300" dirty="0"/>
-          </a:p>
-        </p:txBody>
-      </p:sp>
-      <p:sp>
-        <p:nvSpPr>
-          <p:cNvPr id="14" name="Text 12"/>
           <p:cNvSpPr/>
           <p:nvPr/>
         </p:nvSpPr>
@@ -2691,7 +2580,7 @@
                 <a:ea typeface="Calibri" pitchFamily="34" charset="-122"/>
                 <a:cs typeface="Calibri" pitchFamily="34" charset="-120"/>
               </a:rPr>
-              <a:t>Built in two days on a free stack</a:t>
+              <a:t>Guest mode available</a:t>
             </a:r>
             <a:endParaRPr lang="en-US" sz="1100" dirty="0"/>
           </a:p>
@@ -2699,7 +2588,7 @@
       </p:sp>
       <p:sp>
         <p:nvSpPr>
-          <p:cNvPr id="15" name="Text 13"/>
+          <p:cNvPr id="9" name="Text 7"/>
           <p:cNvSpPr/>
           <p:nvPr/>
         </p:nvSpPr>
@@ -2730,7 +2619,7 @@
                 <a:ea typeface="Calibri" pitchFamily="34" charset="-122"/>
                 <a:cs typeface="Calibri" pitchFamily="34" charset="-120"/>
               </a:rPr>
-              <a:t>10 / 12</a:t>
+              <a:t>10 / 13</a:t>
             </a:r>
             <a:endParaRPr lang="en-US" sz="1100" dirty="0"/>
           </a:p>
@@ -2814,7 +2703,7 @@
                 <a:ea typeface="Calibri" pitchFamily="34" charset="-122"/>
                 <a:cs typeface="Calibri" pitchFamily="34" charset="-120"/>
               </a:rPr>
-              <a:t>WHAT’S NEXT</a:t>
+              <a:t>THE TEAM</a:t>
             </a:r>
             <a:endParaRPr lang="en-US" sz="1200" dirty="0"/>
           </a:p>
@@ -2829,23 +2718,23 @@
         <p:spPr>
           <a:xfrm>
             <a:off x="640080" y="1005840"/>
-            <a:ext cx="10515600" cy="1097280"/>
-          </a:xfrm>
-          <a:prstGeom prst="rect">
-            <a:avLst/>
-          </a:prstGeom>
-          <a:noFill/>
-          <a:ln/>
-        </p:spPr>
-        <p:txBody>
-          <a:bodyPr wrap="square" rtlCol="0" anchor="ctr"/>
-          <a:lstStyle/>
-          <a:p>
-            <a:pPr indent="0" marL="0">
-              <a:buNone/>
-            </a:pPr>
-            <a:r>
-              <a:rPr lang="en-US" sz="2800" dirty="0">
+            <a:ext cx="10515600" cy="731520"/>
+          </a:xfrm>
+          <a:prstGeom prst="rect">
+            <a:avLst/>
+          </a:prstGeom>
+          <a:noFill/>
+          <a:ln/>
+        </p:spPr>
+        <p:txBody>
+          <a:bodyPr wrap="square" rtlCol="0" anchor="ctr"/>
+          <a:lstStyle/>
+          <a:p>
+            <a:pPr indent="0" marL="0">
+              <a:buNone/>
+            </a:pPr>
+            <a:r>
+              <a:rPr lang="en-US" sz="3200" dirty="0">
                 <a:solidFill>
                   <a:srgbClr val="F4F6FB"/>
                 </a:solidFill>
@@ -2853,9 +2742,9 @@
                 <a:ea typeface="Georgia" pitchFamily="34" charset="-122"/>
                 <a:cs typeface="Georgia" pitchFamily="34" charset="-120"/>
               </a:rPr>
-              <a:t>Pilot with real students. Expand the syllabus. Keep coming first.</a:t>
-            </a:r>
-            <a:endParaRPr lang="en-US" sz="2800" dirty="0"/>
+              <a:t>Who built Reca.</a:t>
+            </a:r>
+            <a:endParaRPr lang="en-US" sz="3200" dirty="0"/>
           </a:p>
         </p:txBody>
       </p:sp>
@@ -2867,12 +2756,12 @@
         </p:nvSpPr>
         <p:spPr>
           <a:xfrm>
-            <a:off x="640080" y="2377440"/>
-            <a:ext cx="5212080" cy="1645920"/>
+            <a:off x="640080" y="2011680"/>
+            <a:ext cx="5212080" cy="2560320"/>
           </a:xfrm>
           <a:prstGeom prst="roundRect">
             <a:avLst>
-              <a:gd name="adj" fmla="val 6667"/>
+              <a:gd name="adj" fmla="val 4286"/>
             </a:avLst>
           </a:prstGeom>
           <a:solidFill>
@@ -2889,12 +2778,12 @@
         </p:nvSpPr>
         <p:spPr>
           <a:xfrm>
-            <a:off x="6309360" y="2377440"/>
-            <a:ext cx="5212080" cy="1645920"/>
+            <a:off x="6309360" y="2011680"/>
+            <a:ext cx="5212080" cy="2560320"/>
           </a:xfrm>
           <a:prstGeom prst="roundRect">
             <a:avLst>
-              <a:gd name="adj" fmla="val 6667"/>
+              <a:gd name="adj" fmla="val 4286"/>
             </a:avLst>
           </a:prstGeom>
           <a:solidFill>
@@ -2911,7 +2800,7 @@
         </p:nvSpPr>
         <p:spPr>
           <a:xfrm>
-            <a:off x="914400" y="2606040"/>
+            <a:off x="914400" y="2240280"/>
             <a:ext cx="4572000" cy="274320"/>
           </a:xfrm>
           <a:prstGeom prst="rect">
@@ -2936,7 +2825,7 @@
                 <a:ea typeface="Calibri" pitchFamily="34" charset="-122"/>
                 <a:cs typeface="Calibri" pitchFamily="34" charset="-120"/>
               </a:rPr>
-              <a:t>NOW</a:t>
+              <a:t>PRODUCT DESIGN &amp; UX</a:t>
             </a:r>
             <a:endParaRPr lang="en-US" sz="1200" dirty="0"/>
           </a:p>
@@ -2950,34 +2839,34 @@
         </p:nvSpPr>
         <p:spPr>
           <a:xfrm>
-            <a:off x="914400" y="3017520"/>
-            <a:ext cx="4663440" cy="731520"/>
-          </a:xfrm>
-          <a:prstGeom prst="rect">
-            <a:avLst/>
-          </a:prstGeom>
-          <a:noFill/>
-          <a:ln/>
-        </p:spPr>
-        <p:txBody>
-          <a:bodyPr wrap="square" rtlCol="0" anchor="ctr"/>
-          <a:lstStyle/>
-          <a:p>
-            <a:pPr indent="0" marL="0">
-              <a:buNone/>
-            </a:pPr>
-            <a:r>
-              <a:rPr lang="en-US" sz="1500" dirty="0">
+            <a:off x="914400" y="2651760"/>
+            <a:ext cx="4572000" cy="457200"/>
+          </a:xfrm>
+          <a:prstGeom prst="rect">
+            <a:avLst/>
+          </a:prstGeom>
+          <a:noFill/>
+          <a:ln/>
+        </p:spPr>
+        <p:txBody>
+          <a:bodyPr wrap="square" rtlCol="0" anchor="ctr"/>
+          <a:lstStyle/>
+          <a:p>
+            <a:pPr indent="0" marL="0">
+              <a:buNone/>
+            </a:pPr>
+            <a:r>
+              <a:rPr lang="en-US" sz="2200" dirty="0">
                 <a:solidFill>
                   <a:srgbClr val="F4F6FB"/>
                 </a:solidFill>
-                <a:latin typeface="Calibri" pitchFamily="34" charset="0"/>
-                <a:ea typeface="Calibri" pitchFamily="34" charset="-122"/>
-                <a:cs typeface="Calibri" pitchFamily="34" charset="-120"/>
-              </a:rPr>
-              <a:t>Working loop on WhatsApp + web. Live link ready for judges.</a:t>
-            </a:r>
-            <a:endParaRPr lang="en-US" sz="1500" dirty="0"/>
+                <a:latin typeface="Georgia" pitchFamily="34" charset="0"/>
+                <a:ea typeface="Georgia" pitchFamily="34" charset="-122"/>
+                <a:cs typeface="Georgia" pitchFamily="34" charset="-120"/>
+              </a:rPr>
+              <a:t>Talodabioluwa Paul</a:t>
+            </a:r>
+            <a:endParaRPr lang="en-US" sz="2200" dirty="0"/>
           </a:p>
         </p:txBody>
       </p:sp>
@@ -2989,7 +2878,46 @@
         </p:nvSpPr>
         <p:spPr>
           <a:xfrm>
-            <a:off x="6583680" y="2606040"/>
+            <a:off x="914400" y="3246120"/>
+            <a:ext cx="4663440" cy="914400"/>
+          </a:xfrm>
+          <a:prstGeom prst="rect">
+            <a:avLst/>
+          </a:prstGeom>
+          <a:noFill/>
+          <a:ln/>
+        </p:spPr>
+        <p:txBody>
+          <a:bodyPr wrap="square" rtlCol="0" anchor="ctr"/>
+          <a:lstStyle/>
+          <a:p>
+            <a:pPr indent="0" marL="0">
+              <a:buNone/>
+            </a:pPr>
+            <a:r>
+              <a:rPr lang="en-US" sz="1400" dirty="0">
+                <a:solidFill>
+                  <a:srgbClr val="9AA3B5"/>
+                </a:solidFill>
+                <a:latin typeface="Calibri" pitchFamily="34" charset="0"/>
+                <a:ea typeface="Calibri" pitchFamily="34" charset="-122"/>
+                <a:cs typeface="Calibri" pitchFamily="34" charset="-120"/>
+              </a:rPr>
+              <a:t>Experience, copy, flows, and the student-facing product system.</a:t>
+            </a:r>
+            <a:endParaRPr lang="en-US" sz="1400" dirty="0"/>
+          </a:p>
+        </p:txBody>
+      </p:sp>
+      <p:sp>
+        <p:nvSpPr>
+          <p:cNvPr id="10" name="Text 8"/>
+          <p:cNvSpPr/>
+          <p:nvPr/>
+        </p:nvSpPr>
+        <p:spPr>
+          <a:xfrm>
+            <a:off x="6583680" y="2240280"/>
             <a:ext cx="4572000" cy="274320"/>
           </a:xfrm>
           <a:prstGeom prst="rect">
@@ -3014,7 +2942,7 @@
                 <a:ea typeface="Calibri" pitchFamily="34" charset="-122"/>
                 <a:cs typeface="Calibri" pitchFamily="34" charset="-120"/>
               </a:rPr>
-              <a:t>NEXT 90 DAYS</a:t>
+              <a:t>ENGINEERING &amp; WHATSAPP</a:t>
             </a:r>
             <a:endParaRPr lang="en-US" sz="1200" dirty="0"/>
           </a:p>
@@ -3022,85 +2950,124 @@
       </p:sp>
       <p:sp>
         <p:nvSpPr>
-          <p:cNvPr id="10" name="Text 8"/>
-          <p:cNvSpPr/>
-          <p:nvPr/>
-        </p:nvSpPr>
-        <p:spPr>
-          <a:xfrm>
-            <a:off x="6583680" y="3017520"/>
-            <a:ext cx="4663440" cy="731520"/>
-          </a:xfrm>
-          <a:prstGeom prst="rect">
-            <a:avLst/>
-          </a:prstGeom>
-          <a:noFill/>
-          <a:ln/>
-        </p:spPr>
-        <p:txBody>
-          <a:bodyPr wrap="square" rtlCol="0" anchor="ctr"/>
-          <a:lstStyle/>
-          <a:p>
-            <a:pPr indent="0" marL="0">
-              <a:buNone/>
-            </a:pPr>
-            <a:r>
-              <a:rPr lang="en-US" sz="1500" dirty="0">
+          <p:cNvPr id="11" name="Text 9"/>
+          <p:cNvSpPr/>
+          <p:nvPr/>
+        </p:nvSpPr>
+        <p:spPr>
+          <a:xfrm>
+            <a:off x="6583680" y="2651760"/>
+            <a:ext cx="4572000" cy="457200"/>
+          </a:xfrm>
+          <a:prstGeom prst="rect">
+            <a:avLst/>
+          </a:prstGeom>
+          <a:noFill/>
+          <a:ln/>
+        </p:spPr>
+        <p:txBody>
+          <a:bodyPr wrap="square" rtlCol="0" anchor="ctr"/>
+          <a:lstStyle/>
+          <a:p>
+            <a:pPr indent="0" marL="0">
+              <a:buNone/>
+            </a:pPr>
+            <a:r>
+              <a:rPr lang="en-US" sz="2200" dirty="0">
                 <a:solidFill>
                   <a:srgbClr val="F4F6FB"/>
                 </a:solidFill>
-                <a:latin typeface="Calibri" pitchFamily="34" charset="0"/>
-                <a:ea typeface="Calibri" pitchFamily="34" charset="-122"/>
-                <a:cs typeface="Calibri" pitchFamily="34" charset="-120"/>
-              </a:rPr>
-              <a:t>2–3 school / tutorial pilots · teacher progress view · broader WAEC coverage.</a:t>
-            </a:r>
-            <a:endParaRPr lang="en-US" sz="1500" dirty="0"/>
-          </a:p>
-        </p:txBody>
-      </p:sp>
-      <p:sp>
-        <p:nvSpPr>
-          <p:cNvPr id="11" name="Text 9"/>
-          <p:cNvSpPr/>
-          <p:nvPr/>
-        </p:nvSpPr>
-        <p:spPr>
-          <a:xfrm>
-            <a:off x="640080" y="4389120"/>
-            <a:ext cx="10972800" cy="640080"/>
-          </a:xfrm>
-          <a:prstGeom prst="rect">
-            <a:avLst/>
-          </a:prstGeom>
-          <a:noFill/>
-          <a:ln/>
-        </p:spPr>
-        <p:txBody>
-          <a:bodyPr wrap="square" rtlCol="0" anchor="ctr"/>
-          <a:lstStyle/>
-          <a:p>
-            <a:pPr indent="0" marL="0">
-              <a:buNone/>
-            </a:pPr>
-            <a:r>
-              <a:rPr lang="en-US" sz="1600" dirty="0">
-                <a:solidFill>
-                  <a:srgbClr val="F4F6FB"/>
-                </a:solidFill>
-                <a:latin typeface="Calibri" pitchFamily="34" charset="0"/>
-                <a:ea typeface="Calibri" pitchFamily="34" charset="-122"/>
-                <a:cs typeface="Calibri" pitchFamily="34" charset="-120"/>
-              </a:rPr>
-              <a:t>The ask: recognition and support to pilot Reca with real students for the next WAEC/JAMB cycle.</a:t>
-            </a:r>
-            <a:endParaRPr lang="en-US" sz="1600" dirty="0"/>
+                <a:latin typeface="Georgia" pitchFamily="34" charset="0"/>
+                <a:ea typeface="Georgia" pitchFamily="34" charset="-122"/>
+                <a:cs typeface="Georgia" pitchFamily="34" charset="-120"/>
+              </a:rPr>
+              <a:t>Folarin Oyewole</a:t>
+            </a:r>
+            <a:endParaRPr lang="en-US" sz="2200" dirty="0"/>
           </a:p>
         </p:txBody>
       </p:sp>
       <p:sp>
         <p:nvSpPr>
           <p:cNvPr id="12" name="Text 10"/>
+          <p:cNvSpPr/>
+          <p:nvPr/>
+        </p:nvSpPr>
+        <p:spPr>
+          <a:xfrm>
+            <a:off x="6583680" y="3246120"/>
+            <a:ext cx="4663440" cy="914400"/>
+          </a:xfrm>
+          <a:prstGeom prst="rect">
+            <a:avLst/>
+          </a:prstGeom>
+          <a:noFill/>
+          <a:ln/>
+        </p:spPr>
+        <p:txBody>
+          <a:bodyPr wrap="square" rtlCol="0" anchor="ctr"/>
+          <a:lstStyle/>
+          <a:p>
+            <a:pPr indent="0" marL="0">
+              <a:buNone/>
+            </a:pPr>
+            <a:r>
+              <a:rPr lang="en-US" sz="1400" dirty="0">
+                <a:solidFill>
+                  <a:srgbClr val="9AA3B5"/>
+                </a:solidFill>
+                <a:latin typeface="Calibri" pitchFamily="34" charset="0"/>
+                <a:ea typeface="Calibri" pitchFamily="34" charset="-122"/>
+                <a:cs typeface="Calibri" pitchFamily="34" charset="-120"/>
+              </a:rPr>
+              <a:t>Backend, Meta Cloud API, memory loop, and deploy.</a:t>
+            </a:r>
+            <a:endParaRPr lang="en-US" sz="1400" dirty="0"/>
+          </a:p>
+        </p:txBody>
+      </p:sp>
+      <p:sp>
+        <p:nvSpPr>
+          <p:cNvPr id="13" name="Text 11"/>
+          <p:cNvSpPr/>
+          <p:nvPr/>
+        </p:nvSpPr>
+        <p:spPr>
+          <a:xfrm>
+            <a:off x="640080" y="4937760"/>
+            <a:ext cx="10972800" cy="365760"/>
+          </a:xfrm>
+          <a:prstGeom prst="rect">
+            <a:avLst/>
+          </a:prstGeom>
+          <a:noFill/>
+          <a:ln/>
+        </p:spPr>
+        <p:txBody>
+          <a:bodyPr wrap="square" rtlCol="0" anchor="ctr"/>
+          <a:lstStyle/>
+          <a:p>
+            <a:pPr indent="0" marL="0">
+              <a:buNone/>
+            </a:pPr>
+            <a:r>
+              <a:rPr lang="en-US" sz="1300" dirty="0">
+                <a:solidFill>
+                  <a:srgbClr val="9AA3B5"/>
+                </a:solidFill>
+                <a:latin typeface="Calibri" pitchFamily="34" charset="0"/>
+                <a:ea typeface="Calibri" pitchFamily="34" charset="-122"/>
+                <a:cs typeface="Calibri" pitchFamily="34" charset="-120"/>
+              </a:rPr>
+              <a:t>AI BuildFest 2026 · Track 3 · Case Study 2 · Participant ID BF-0933</a:t>
+            </a:r>
+            <a:endParaRPr lang="en-US" sz="1300" dirty="0"/>
+          </a:p>
+        </p:txBody>
+      </p:sp>
+      <p:sp>
+        <p:nvSpPr>
+          <p:cNvPr id="14" name="Text 12"/>
           <p:cNvSpPr/>
           <p:nvPr/>
         </p:nvSpPr>
@@ -3131,7 +3098,7 @@
                 <a:ea typeface="Calibri" pitchFamily="34" charset="-122"/>
                 <a:cs typeface="Calibri" pitchFamily="34" charset="-120"/>
               </a:rPr>
-              <a:t>Case Study 2 · AI for Everyday Life</a:t>
+              <a:t>Built in two days on a free stack</a:t>
             </a:r>
             <a:endParaRPr lang="en-US" sz="1100" dirty="0"/>
           </a:p>
@@ -3139,7 +3106,7 @@
       </p:sp>
       <p:sp>
         <p:nvSpPr>
-          <p:cNvPr id="13" name="Text 11"/>
+          <p:cNvPr id="15" name="Text 13"/>
           <p:cNvSpPr/>
           <p:nvPr/>
         </p:nvSpPr>
@@ -3170,7 +3137,7 @@
                 <a:ea typeface="Calibri" pitchFamily="34" charset="-122"/>
                 <a:cs typeface="Calibri" pitchFamily="34" charset="-120"/>
               </a:rPr>
-              <a:t>11 / 12</a:t>
+              <a:t>11 / 13</a:t>
             </a:r>
             <a:endParaRPr lang="en-US" sz="1100" dirty="0"/>
           </a:p>
@@ -3223,6 +3190,446 @@
       </p:sp>
       <p:sp>
         <p:nvSpPr>
+          <p:cNvPr id="3" name="Text 1"/>
+          <p:cNvSpPr/>
+          <p:nvPr/>
+        </p:nvSpPr>
+        <p:spPr>
+          <a:xfrm>
+            <a:off x="640080" y="502920"/>
+            <a:ext cx="10972800" cy="320040"/>
+          </a:xfrm>
+          <a:prstGeom prst="rect">
+            <a:avLst/>
+          </a:prstGeom>
+          <a:noFill/>
+          <a:ln/>
+        </p:spPr>
+        <p:txBody>
+          <a:bodyPr wrap="square" rtlCol="0" anchor="ctr"/>
+          <a:lstStyle/>
+          <a:p>
+            <a:pPr indent="0" marL="0">
+              <a:buNone/>
+            </a:pPr>
+            <a:r>
+              <a:rPr lang="en-US" sz="1200" b="1" spc="300" kern="0" dirty="0">
+                <a:solidFill>
+                  <a:srgbClr val="FB735B"/>
+                </a:solidFill>
+                <a:latin typeface="Calibri" pitchFamily="34" charset="0"/>
+                <a:ea typeface="Calibri" pitchFamily="34" charset="-122"/>
+                <a:cs typeface="Calibri" pitchFamily="34" charset="-120"/>
+              </a:rPr>
+              <a:t>WHAT’S NEXT</a:t>
+            </a:r>
+            <a:endParaRPr lang="en-US" sz="1200" dirty="0"/>
+          </a:p>
+        </p:txBody>
+      </p:sp>
+      <p:sp>
+        <p:nvSpPr>
+          <p:cNvPr id="4" name="Text 2"/>
+          <p:cNvSpPr/>
+          <p:nvPr/>
+        </p:nvSpPr>
+        <p:spPr>
+          <a:xfrm>
+            <a:off x="640080" y="1005840"/>
+            <a:ext cx="10515600" cy="1097280"/>
+          </a:xfrm>
+          <a:prstGeom prst="rect">
+            <a:avLst/>
+          </a:prstGeom>
+          <a:noFill/>
+          <a:ln/>
+        </p:spPr>
+        <p:txBody>
+          <a:bodyPr wrap="square" rtlCol="0" anchor="ctr"/>
+          <a:lstStyle/>
+          <a:p>
+            <a:pPr indent="0" marL="0">
+              <a:buNone/>
+            </a:pPr>
+            <a:r>
+              <a:rPr lang="en-US" sz="2800" dirty="0">
+                <a:solidFill>
+                  <a:srgbClr val="F4F6FB"/>
+                </a:solidFill>
+                <a:latin typeface="Georgia" pitchFamily="34" charset="0"/>
+                <a:ea typeface="Georgia" pitchFamily="34" charset="-122"/>
+                <a:cs typeface="Georgia" pitchFamily="34" charset="-120"/>
+              </a:rPr>
+              <a:t>Pilot with real students. Expand the syllabus. Keep coming first.</a:t>
+            </a:r>
+            <a:endParaRPr lang="en-US" sz="2800" dirty="0"/>
+          </a:p>
+        </p:txBody>
+      </p:sp>
+      <p:sp>
+        <p:nvSpPr>
+          <p:cNvPr id="5" name="Shape 3"/>
+          <p:cNvSpPr/>
+          <p:nvPr/>
+        </p:nvSpPr>
+        <p:spPr>
+          <a:xfrm>
+            <a:off x="640080" y="2377440"/>
+            <a:ext cx="5212080" cy="1645920"/>
+          </a:xfrm>
+          <a:prstGeom prst="roundRect">
+            <a:avLst>
+              <a:gd name="adj" fmla="val 6667"/>
+            </a:avLst>
+          </a:prstGeom>
+          <a:solidFill>
+            <a:srgbClr val="0E121B"/>
+          </a:solidFill>
+          <a:ln/>
+        </p:spPr>
+      </p:sp>
+      <p:sp>
+        <p:nvSpPr>
+          <p:cNvPr id="6" name="Shape 4"/>
+          <p:cNvSpPr/>
+          <p:nvPr/>
+        </p:nvSpPr>
+        <p:spPr>
+          <a:xfrm>
+            <a:off x="6309360" y="2377440"/>
+            <a:ext cx="5212080" cy="1645920"/>
+          </a:xfrm>
+          <a:prstGeom prst="roundRect">
+            <a:avLst>
+              <a:gd name="adj" fmla="val 6667"/>
+            </a:avLst>
+          </a:prstGeom>
+          <a:solidFill>
+            <a:srgbClr val="0E121B"/>
+          </a:solidFill>
+          <a:ln/>
+        </p:spPr>
+      </p:sp>
+      <p:sp>
+        <p:nvSpPr>
+          <p:cNvPr id="7" name="Text 5"/>
+          <p:cNvSpPr/>
+          <p:nvPr/>
+        </p:nvSpPr>
+        <p:spPr>
+          <a:xfrm>
+            <a:off x="914400" y="2606040"/>
+            <a:ext cx="4572000" cy="274320"/>
+          </a:xfrm>
+          <a:prstGeom prst="rect">
+            <a:avLst/>
+          </a:prstGeom>
+          <a:noFill/>
+          <a:ln/>
+        </p:spPr>
+        <p:txBody>
+          <a:bodyPr wrap="square" rtlCol="0" anchor="ctr"/>
+          <a:lstStyle/>
+          <a:p>
+            <a:pPr indent="0" marL="0">
+              <a:buNone/>
+            </a:pPr>
+            <a:r>
+              <a:rPr lang="en-US" sz="1200" b="1" dirty="0">
+                <a:solidFill>
+                  <a:srgbClr val="9AA3B5"/>
+                </a:solidFill>
+                <a:latin typeface="Calibri" pitchFamily="34" charset="0"/>
+                <a:ea typeface="Calibri" pitchFamily="34" charset="-122"/>
+                <a:cs typeface="Calibri" pitchFamily="34" charset="-120"/>
+              </a:rPr>
+              <a:t>NOW</a:t>
+            </a:r>
+            <a:endParaRPr lang="en-US" sz="1200" dirty="0"/>
+          </a:p>
+        </p:txBody>
+      </p:sp>
+      <p:sp>
+        <p:nvSpPr>
+          <p:cNvPr id="8" name="Text 6"/>
+          <p:cNvSpPr/>
+          <p:nvPr/>
+        </p:nvSpPr>
+        <p:spPr>
+          <a:xfrm>
+            <a:off x="914400" y="3017520"/>
+            <a:ext cx="4663440" cy="731520"/>
+          </a:xfrm>
+          <a:prstGeom prst="rect">
+            <a:avLst/>
+          </a:prstGeom>
+          <a:noFill/>
+          <a:ln/>
+        </p:spPr>
+        <p:txBody>
+          <a:bodyPr wrap="square" rtlCol="0" anchor="ctr"/>
+          <a:lstStyle/>
+          <a:p>
+            <a:pPr indent="0" marL="0">
+              <a:buNone/>
+            </a:pPr>
+            <a:r>
+              <a:rPr lang="en-US" sz="1500" dirty="0">
+                <a:solidFill>
+                  <a:srgbClr val="F4F6FB"/>
+                </a:solidFill>
+                <a:latin typeface="Calibri" pitchFamily="34" charset="0"/>
+                <a:ea typeface="Calibri" pitchFamily="34" charset="-122"/>
+                <a:cs typeface="Calibri" pitchFamily="34" charset="-120"/>
+              </a:rPr>
+              <a:t>Working loop on WhatsApp + web. Live link ready for judges.</a:t>
+            </a:r>
+            <a:endParaRPr lang="en-US" sz="1500" dirty="0"/>
+          </a:p>
+        </p:txBody>
+      </p:sp>
+      <p:sp>
+        <p:nvSpPr>
+          <p:cNvPr id="9" name="Text 7"/>
+          <p:cNvSpPr/>
+          <p:nvPr/>
+        </p:nvSpPr>
+        <p:spPr>
+          <a:xfrm>
+            <a:off x="6583680" y="2606040"/>
+            <a:ext cx="4572000" cy="274320"/>
+          </a:xfrm>
+          <a:prstGeom prst="rect">
+            <a:avLst/>
+          </a:prstGeom>
+          <a:noFill/>
+          <a:ln/>
+        </p:spPr>
+        <p:txBody>
+          <a:bodyPr wrap="square" rtlCol="0" anchor="ctr"/>
+          <a:lstStyle/>
+          <a:p>
+            <a:pPr indent="0" marL="0">
+              <a:buNone/>
+            </a:pPr>
+            <a:r>
+              <a:rPr lang="en-US" sz="1200" b="1" dirty="0">
+                <a:solidFill>
+                  <a:srgbClr val="9AA3B5"/>
+                </a:solidFill>
+                <a:latin typeface="Calibri" pitchFamily="34" charset="0"/>
+                <a:ea typeface="Calibri" pitchFamily="34" charset="-122"/>
+                <a:cs typeface="Calibri" pitchFamily="34" charset="-120"/>
+              </a:rPr>
+              <a:t>NEXT 90 DAYS</a:t>
+            </a:r>
+            <a:endParaRPr lang="en-US" sz="1200" dirty="0"/>
+          </a:p>
+        </p:txBody>
+      </p:sp>
+      <p:sp>
+        <p:nvSpPr>
+          <p:cNvPr id="10" name="Text 8"/>
+          <p:cNvSpPr/>
+          <p:nvPr/>
+        </p:nvSpPr>
+        <p:spPr>
+          <a:xfrm>
+            <a:off x="6583680" y="3017520"/>
+            <a:ext cx="4663440" cy="731520"/>
+          </a:xfrm>
+          <a:prstGeom prst="rect">
+            <a:avLst/>
+          </a:prstGeom>
+          <a:noFill/>
+          <a:ln/>
+        </p:spPr>
+        <p:txBody>
+          <a:bodyPr wrap="square" rtlCol="0" anchor="ctr"/>
+          <a:lstStyle/>
+          <a:p>
+            <a:pPr indent="0" marL="0">
+              <a:buNone/>
+            </a:pPr>
+            <a:r>
+              <a:rPr lang="en-US" sz="1500" dirty="0">
+                <a:solidFill>
+                  <a:srgbClr val="F4F6FB"/>
+                </a:solidFill>
+                <a:latin typeface="Calibri" pitchFamily="34" charset="0"/>
+                <a:ea typeface="Calibri" pitchFamily="34" charset="-122"/>
+                <a:cs typeface="Calibri" pitchFamily="34" charset="-120"/>
+              </a:rPr>
+              <a:t>2–3 school / tutorial pilots · teacher progress view · broader WAEC coverage.</a:t>
+            </a:r>
+            <a:endParaRPr lang="en-US" sz="1500" dirty="0"/>
+          </a:p>
+        </p:txBody>
+      </p:sp>
+      <p:sp>
+        <p:nvSpPr>
+          <p:cNvPr id="11" name="Text 9"/>
+          <p:cNvSpPr/>
+          <p:nvPr/>
+        </p:nvSpPr>
+        <p:spPr>
+          <a:xfrm>
+            <a:off x="640080" y="4389120"/>
+            <a:ext cx="10972800" cy="640080"/>
+          </a:xfrm>
+          <a:prstGeom prst="rect">
+            <a:avLst/>
+          </a:prstGeom>
+          <a:noFill/>
+          <a:ln/>
+        </p:spPr>
+        <p:txBody>
+          <a:bodyPr wrap="square" rtlCol="0" anchor="ctr"/>
+          <a:lstStyle/>
+          <a:p>
+            <a:pPr indent="0" marL="0">
+              <a:buNone/>
+            </a:pPr>
+            <a:r>
+              <a:rPr lang="en-US" sz="1600" dirty="0">
+                <a:solidFill>
+                  <a:srgbClr val="F4F6FB"/>
+                </a:solidFill>
+                <a:latin typeface="Calibri" pitchFamily="34" charset="0"/>
+                <a:ea typeface="Calibri" pitchFamily="34" charset="-122"/>
+                <a:cs typeface="Calibri" pitchFamily="34" charset="-120"/>
+              </a:rPr>
+              <a:t>The ask: recognition and support to pilot Reca with real students for the next WAEC/JAMB cycle.</a:t>
+            </a:r>
+            <a:endParaRPr lang="en-US" sz="1600" dirty="0"/>
+          </a:p>
+        </p:txBody>
+      </p:sp>
+      <p:sp>
+        <p:nvSpPr>
+          <p:cNvPr id="12" name="Text 10"/>
+          <p:cNvSpPr/>
+          <p:nvPr/>
+        </p:nvSpPr>
+        <p:spPr>
+          <a:xfrm>
+            <a:off x="640080" y="6446520"/>
+            <a:ext cx="7315200" cy="274320"/>
+          </a:xfrm>
+          <a:prstGeom prst="rect">
+            <a:avLst/>
+          </a:prstGeom>
+          <a:noFill/>
+          <a:ln/>
+        </p:spPr>
+        <p:txBody>
+          <a:bodyPr wrap="square" rtlCol="0" anchor="ctr"/>
+          <a:lstStyle/>
+          <a:p>
+            <a:pPr indent="0" marL="0">
+              <a:buNone/>
+            </a:pPr>
+            <a:r>
+              <a:rPr lang="en-US" sz="1100" dirty="0">
+                <a:solidFill>
+                  <a:srgbClr val="9AA3B5"/>
+                </a:solidFill>
+                <a:latin typeface="Calibri" pitchFamily="34" charset="0"/>
+                <a:ea typeface="Calibri" pitchFamily="34" charset="-122"/>
+                <a:cs typeface="Calibri" pitchFamily="34" charset="-120"/>
+              </a:rPr>
+              <a:t>Case Study 2 · AI for Everyday Life</a:t>
+            </a:r>
+            <a:endParaRPr lang="en-US" sz="1100" dirty="0"/>
+          </a:p>
+        </p:txBody>
+      </p:sp>
+      <p:sp>
+        <p:nvSpPr>
+          <p:cNvPr id="13" name="Text 11"/>
+          <p:cNvSpPr/>
+          <p:nvPr/>
+        </p:nvSpPr>
+        <p:spPr>
+          <a:xfrm>
+            <a:off x="10241280" y="6446520"/>
+            <a:ext cx="1280160" cy="274320"/>
+          </a:xfrm>
+          <a:prstGeom prst="rect">
+            <a:avLst/>
+          </a:prstGeom>
+          <a:noFill/>
+          <a:ln/>
+        </p:spPr>
+        <p:txBody>
+          <a:bodyPr wrap="square" rtlCol="0" anchor="ctr"/>
+          <a:lstStyle/>
+          <a:p>
+            <a:pPr algn="r" indent="0" marL="0">
+              <a:buNone/>
+            </a:pPr>
+            <a:r>
+              <a:rPr lang="en-US" sz="1100" dirty="0">
+                <a:solidFill>
+                  <a:srgbClr val="9AA3B5"/>
+                </a:solidFill>
+                <a:latin typeface="Calibri" pitchFamily="34" charset="0"/>
+                <a:ea typeface="Calibri" pitchFamily="34" charset="-122"/>
+                <a:cs typeface="Calibri" pitchFamily="34" charset="-120"/>
+              </a:rPr>
+              <a:t>12 / 13</a:t>
+            </a:r>
+            <a:endParaRPr lang="en-US" sz="1100" dirty="0"/>
+          </a:p>
+        </p:txBody>
+      </p:sp>
+    </p:spTree>
+  </p:cSld>
+  <p:clrMapOvr>
+    <a:masterClrMapping/>
+  </p:clrMapOvr>
+</p:sld>
+</file>
+
+<file path=ppt/slides/slide13.xml><?xml version="1.0" encoding="utf-8"?>
+<p:sld xmlns:a="http://schemas.openxmlformats.org/drawingml/2006/main" xmlns:r="http://schemas.openxmlformats.org/officeDocument/2006/relationships" xmlns:p="http://schemas.openxmlformats.org/presentationml/2006/main">
+  <p:cSld name="Slide 13">
+    <p:spTree>
+      <p:nvGrpSpPr>
+        <p:cNvPr id="1" name=""/>
+        <p:cNvGrpSpPr/>
+        <p:nvPr/>
+      </p:nvGrpSpPr>
+      <p:grpSpPr>
+        <a:xfrm>
+          <a:off x="0" y="0"/>
+          <a:ext cx="0" cy="0"/>
+          <a:chOff x="0" y="0"/>
+          <a:chExt cx="0" cy="0"/>
+        </a:xfrm>
+      </p:grpSpPr>
+      <p:sp>
+        <p:nvSpPr>
+          <p:cNvPr id="2" name="Shape 0"/>
+          <p:cNvSpPr/>
+          <p:nvPr/>
+        </p:nvSpPr>
+        <p:spPr>
+          <a:xfrm>
+            <a:off x="0" y="0"/>
+            <a:ext cx="12191695" cy="6858000"/>
+          </a:xfrm>
+          <a:prstGeom prst="rect">
+            <a:avLst/>
+          </a:prstGeom>
+          <a:solidFill>
+            <a:srgbClr val="07090F"/>
+          </a:solidFill>
+          <a:ln/>
+        </p:spPr>
+      </p:sp>
+      <p:sp>
+        <p:nvSpPr>
           <p:cNvPr id="3" name="Shape 1"/>
           <p:cNvSpPr/>
           <p:nvPr/>
@@ -3566,7 +3973,7 @@
                 <a:ea typeface="Calibri" pitchFamily="34" charset="-122"/>
                 <a:cs typeface="Calibri" pitchFamily="34" charset="-120"/>
               </a:rPr>
-              <a:t>12 / 12</a:t>
+              <a:t>13 / 13</a:t>
             </a:r>
             <a:endParaRPr lang="en-US" sz="1100" dirty="0"/>
           </a:p>
@@ -4100,7 +4507,7 @@
                 <a:ea typeface="Calibri" pitchFamily="34" charset="-122"/>
                 <a:cs typeface="Calibri" pitchFamily="34" charset="-120"/>
               </a:rPr>
-              <a:t>2 / 12</a:t>
+              <a:t>2 / 13</a:t>
             </a:r>
             <a:endParaRPr lang="en-US" sz="1100" dirty="0"/>
           </a:p>
@@ -4621,7 +5028,7 @@
                 <a:ea typeface="Calibri" pitchFamily="34" charset="-122"/>
                 <a:cs typeface="Calibri" pitchFamily="34" charset="-120"/>
               </a:rPr>
-              <a:t>3 / 12</a:t>
+              <a:t>3 / 13</a:t>
             </a:r>
             <a:endParaRPr lang="en-US" sz="1100" dirty="0"/>
           </a:p>
@@ -4900,7 +5307,7 @@
                 <a:ea typeface="Calibri" pitchFamily="34" charset="-122"/>
                 <a:cs typeface="Calibri" pitchFamily="34" charset="-120"/>
               </a:rPr>
-              <a:t>4 / 12</a:t>
+              <a:t>4 / 13</a:t>
             </a:r>
             <a:endParaRPr lang="en-US" sz="1100" dirty="0"/>
           </a:p>
@@ -5699,7 +6106,7 @@
                 <a:ea typeface="Calibri" pitchFamily="34" charset="-122"/>
                 <a:cs typeface="Calibri" pitchFamily="34" charset="-120"/>
               </a:rPr>
-              <a:t>5 / 12</a:t>
+              <a:t>5 / 13</a:t>
             </a:r>
             <a:endParaRPr lang="en-US" sz="1100" dirty="0"/>
           </a:p>
@@ -6139,7 +6546,7 @@
                 <a:ea typeface="Calibri" pitchFamily="34" charset="-122"/>
                 <a:cs typeface="Calibri" pitchFamily="34" charset="-120"/>
               </a:rPr>
-              <a:t>6 / 12</a:t>
+              <a:t>6 / 13</a:t>
             </a:r>
             <a:endParaRPr lang="en-US" sz="1100" dirty="0"/>
           </a:p>
@@ -6223,7 +6630,7 @@
                 <a:ea typeface="Calibri" pitchFamily="34" charset="-122"/>
                 <a:cs typeface="Calibri" pitchFamily="34" charset="-120"/>
               </a:rPr>
-              <a:t>IMPACT &amp; USEFULNESS</a:t>
+              <a:t>TOOLS USED</a:t>
             </a:r>
             <a:endParaRPr lang="en-US" sz="1200" dirty="0"/>
           </a:p>
@@ -6237,8 +6644,8 @@
         </p:nvSpPr>
         <p:spPr>
           <a:xfrm>
-            <a:off x="640080" y="1005840"/>
-            <a:ext cx="10515600" cy="1005840"/>
+            <a:off x="640080" y="960120"/>
+            <a:ext cx="10972800" cy="640080"/>
           </a:xfrm>
           <a:prstGeom prst="rect">
             <a:avLst/>
@@ -6262,7 +6669,7 @@
                 <a:ea typeface="Georgia" pitchFamily="34" charset="-122"/>
                 <a:cs typeface="Georgia" pitchFamily="34" charset="-120"/>
               </a:rPr>
-              <a:t>Built for how Nigerian students already study.</a:t>
+              <a:t>What we built Reca with.</a:t>
             </a:r>
             <a:endParaRPr lang="en-US" sz="3200" dirty="0"/>
           </a:p>
@@ -6270,42 +6677,25 @@
       </p:sp>
       <p:sp>
         <p:nvSpPr>
-          <p:cNvPr id="5" name="Text 3"/>
-          <p:cNvSpPr/>
-          <p:nvPr/>
-        </p:nvSpPr>
-        <p:spPr>
-          <a:xfrm>
-            <a:off x="640080" y="2286000"/>
-            <a:ext cx="411480" cy="457200"/>
-          </a:xfrm>
-          <a:prstGeom prst="rect">
-            <a:avLst/>
-          </a:prstGeom>
-          <a:noFill/>
-          <a:ln/>
-        </p:spPr>
-        <p:txBody>
-          <a:bodyPr wrap="square" rtlCol="0" anchor="ctr"/>
-          <a:lstStyle/>
-          <a:p>
-            <a:pPr indent="0" marL="0">
-              <a:buNone/>
-            </a:pPr>
-            <a:r>
-              <a:rPr lang="en-US" sz="1800" dirty="0">
-                <a:solidFill>
-                  <a:srgbClr val="25D366"/>
-                </a:solidFill>
-                <a:latin typeface="Calibri" pitchFamily="34" charset="0"/>
-                <a:ea typeface="Calibri" pitchFamily="34" charset="-122"/>
-                <a:cs typeface="Calibri" pitchFamily="34" charset="-120"/>
-              </a:rPr>
-              <a:t>✓</a:t>
-            </a:r>
-            <a:endParaRPr lang="en-US" sz="1800" dirty="0"/>
-          </a:p>
-        </p:txBody>
+          <p:cNvPr id="5" name="Shape 3"/>
+          <p:cNvSpPr/>
+          <p:nvPr/>
+        </p:nvSpPr>
+        <p:spPr>
+          <a:xfrm>
+            <a:off x="640080" y="1828800"/>
+            <a:ext cx="5394960" cy="1874520"/>
+          </a:xfrm>
+          <a:prstGeom prst="roundRect">
+            <a:avLst>
+              <a:gd name="adj" fmla="val 5854"/>
+            </a:avLst>
+          </a:prstGeom>
+          <a:solidFill>
+            <a:srgbClr val="0E121B"/>
+          </a:solidFill>
+          <a:ln/>
+        </p:spPr>
       </p:sp>
       <p:sp>
         <p:nvSpPr>
@@ -6315,24 +6705,63 @@
         </p:nvSpPr>
         <p:spPr>
           <a:xfrm>
-            <a:off x="1143000" y="2286000"/>
-            <a:ext cx="10058400" cy="457200"/>
-          </a:xfrm>
-          <a:prstGeom prst="rect">
-            <a:avLst/>
-          </a:prstGeom>
-          <a:noFill/>
-          <a:ln/>
-        </p:spPr>
-        <p:txBody>
-          <a:bodyPr wrap="square" rtlCol="0" anchor="ctr"/>
-          <a:lstStyle/>
-          <a:p>
-            <a:pPr indent="0" marL="0">
-              <a:buNone/>
-            </a:pPr>
-            <a:r>
-              <a:rPr lang="en-US" sz="1700" dirty="0">
+            <a:off x="914400" y="2103120"/>
+            <a:ext cx="4846320" cy="320040"/>
+          </a:xfrm>
+          <a:prstGeom prst="rect">
+            <a:avLst/>
+          </a:prstGeom>
+          <a:noFill/>
+          <a:ln/>
+        </p:spPr>
+        <p:txBody>
+          <a:bodyPr wrap="square" rtlCol="0" anchor="ctr"/>
+          <a:lstStyle/>
+          <a:p>
+            <a:pPr indent="0" marL="0">
+              <a:buNone/>
+            </a:pPr>
+            <a:r>
+              <a:rPr lang="en-US" sz="1200" b="1" dirty="0">
+                <a:solidFill>
+                  <a:srgbClr val="9AA3B5"/>
+                </a:solidFill>
+                <a:latin typeface="Calibri" pitchFamily="34" charset="0"/>
+                <a:ea typeface="Calibri" pitchFamily="34" charset="-122"/>
+                <a:cs typeface="Calibri" pitchFamily="34" charset="-120"/>
+              </a:rPr>
+              <a:t>META BUSINESS SUITE</a:t>
+            </a:r>
+            <a:endParaRPr lang="en-US" sz="1200" dirty="0"/>
+          </a:p>
+        </p:txBody>
+      </p:sp>
+      <p:sp>
+        <p:nvSpPr>
+          <p:cNvPr id="7" name="Text 5"/>
+          <p:cNvSpPr/>
+          <p:nvPr/>
+        </p:nvSpPr>
+        <p:spPr>
+          <a:xfrm>
+            <a:off x="914400" y="2560320"/>
+            <a:ext cx="4846320" cy="868680"/>
+          </a:xfrm>
+          <a:prstGeom prst="rect">
+            <a:avLst/>
+          </a:prstGeom>
+          <a:noFill/>
+          <a:ln/>
+        </p:spPr>
+        <p:txBody>
+          <a:bodyPr wrap="square" rtlCol="0" anchor="ctr"/>
+          <a:lstStyle/>
+          <a:p>
+            <a:pPr indent="0" marL="0">
+              <a:buNone/>
+            </a:pPr>
+            <a:r>
+              <a:rPr lang="en-US" sz="1600" dirty="0">
                 <a:solidFill>
                   <a:srgbClr val="F4F6FB"/>
                 </a:solidFill>
@@ -6340,77 +6769,99 @@
                 <a:ea typeface="Calibri" pitchFamily="34" charset="-122"/>
                 <a:cs typeface="Calibri" pitchFamily="34" charset="-120"/>
               </a:rPr>
-              <a:t>After-school phone habit — not an in-school laptop fantasy</a:t>
-            </a:r>
-            <a:endParaRPr lang="en-US" sz="1700" dirty="0"/>
-          </a:p>
-        </p:txBody>
-      </p:sp>
-      <p:sp>
-        <p:nvSpPr>
-          <p:cNvPr id="7" name="Text 5"/>
-          <p:cNvSpPr/>
-          <p:nvPr/>
-        </p:nvSpPr>
-        <p:spPr>
-          <a:xfrm>
-            <a:off x="640080" y="2971800"/>
-            <a:ext cx="411480" cy="457200"/>
-          </a:xfrm>
-          <a:prstGeom prst="rect">
-            <a:avLst/>
-          </a:prstGeom>
-          <a:noFill/>
-          <a:ln/>
-        </p:spPr>
-        <p:txBody>
-          <a:bodyPr wrap="square" rtlCol="0" anchor="ctr"/>
-          <a:lstStyle/>
-          <a:p>
-            <a:pPr indent="0" marL="0">
-              <a:buNone/>
-            </a:pPr>
-            <a:r>
-              <a:rPr lang="en-US" sz="1800" dirty="0">
-                <a:solidFill>
-                  <a:srgbClr val="25D366"/>
-                </a:solidFill>
-                <a:latin typeface="Calibri" pitchFamily="34" charset="0"/>
-                <a:ea typeface="Calibri" pitchFamily="34" charset="-122"/>
-                <a:cs typeface="Calibri" pitchFamily="34" charset="-120"/>
-              </a:rPr>
-              <a:t>✓</a:t>
-            </a:r>
-            <a:endParaRPr lang="en-US" sz="1800" dirty="0"/>
-          </a:p>
-        </p:txBody>
-      </p:sp>
-      <p:sp>
-        <p:nvSpPr>
-          <p:cNvPr id="8" name="Text 6"/>
-          <p:cNvSpPr/>
-          <p:nvPr/>
-        </p:nvSpPr>
-        <p:spPr>
-          <a:xfrm>
-            <a:off x="1143000" y="2971800"/>
-            <a:ext cx="10058400" cy="457200"/>
-          </a:xfrm>
-          <a:prstGeom prst="rect">
-            <a:avLst/>
-          </a:prstGeom>
-          <a:noFill/>
-          <a:ln/>
-        </p:spPr>
-        <p:txBody>
-          <a:bodyPr wrap="square" rtlCol="0" anchor="ctr"/>
-          <a:lstStyle/>
-          <a:p>
-            <a:pPr indent="0" marL="0">
-              <a:buNone/>
-            </a:pPr>
-            <a:r>
-              <a:rPr lang="en-US" sz="1700" dirty="0">
+              <a:t>WhatsApp Cloud API setup, phone number, and messaging for OTP + unprompted resurface.</a:t>
+            </a:r>
+            <a:endParaRPr lang="en-US" sz="1600" dirty="0"/>
+          </a:p>
+        </p:txBody>
+      </p:sp>
+      <p:sp>
+        <p:nvSpPr>
+          <p:cNvPr id="8" name="Shape 6"/>
+          <p:cNvSpPr/>
+          <p:nvPr/>
+        </p:nvSpPr>
+        <p:spPr>
+          <a:xfrm>
+            <a:off x="6309360" y="1828800"/>
+            <a:ext cx="5394960" cy="1874520"/>
+          </a:xfrm>
+          <a:prstGeom prst="roundRect">
+            <a:avLst>
+              <a:gd name="adj" fmla="val 5854"/>
+            </a:avLst>
+          </a:prstGeom>
+          <a:solidFill>
+            <a:srgbClr val="0E121B"/>
+          </a:solidFill>
+          <a:ln/>
+        </p:spPr>
+      </p:sp>
+      <p:sp>
+        <p:nvSpPr>
+          <p:cNvPr id="9" name="Text 7"/>
+          <p:cNvSpPr/>
+          <p:nvPr/>
+        </p:nvSpPr>
+        <p:spPr>
+          <a:xfrm>
+            <a:off x="6583680" y="2103120"/>
+            <a:ext cx="4846320" cy="320040"/>
+          </a:xfrm>
+          <a:prstGeom prst="rect">
+            <a:avLst/>
+          </a:prstGeom>
+          <a:noFill/>
+          <a:ln/>
+        </p:spPr>
+        <p:txBody>
+          <a:bodyPr wrap="square" rtlCol="0" anchor="ctr"/>
+          <a:lstStyle/>
+          <a:p>
+            <a:pPr indent="0" marL="0">
+              <a:buNone/>
+            </a:pPr>
+            <a:r>
+              <a:rPr lang="en-US" sz="1200" b="1" dirty="0">
+                <a:solidFill>
+                  <a:srgbClr val="9AA3B5"/>
+                </a:solidFill>
+                <a:latin typeface="Calibri" pitchFamily="34" charset="0"/>
+                <a:ea typeface="Calibri" pitchFamily="34" charset="-122"/>
+                <a:cs typeface="Calibri" pitchFamily="34" charset="-120"/>
+              </a:rPr>
+              <a:t>GOOGLE GEMINI</a:t>
+            </a:r>
+            <a:endParaRPr lang="en-US" sz="1200" dirty="0"/>
+          </a:p>
+        </p:txBody>
+      </p:sp>
+      <p:sp>
+        <p:nvSpPr>
+          <p:cNvPr id="10" name="Text 8"/>
+          <p:cNvSpPr/>
+          <p:nvPr/>
+        </p:nvSpPr>
+        <p:spPr>
+          <a:xfrm>
+            <a:off x="6583680" y="2560320"/>
+            <a:ext cx="4846320" cy="868680"/>
+          </a:xfrm>
+          <a:prstGeom prst="rect">
+            <a:avLst/>
+          </a:prstGeom>
+          <a:noFill/>
+          <a:ln/>
+        </p:spPr>
+        <p:txBody>
+          <a:bodyPr wrap="square" rtlCol="0" anchor="ctr"/>
+          <a:lstStyle/>
+          <a:p>
+            <a:pPr indent="0" marL="0">
+              <a:buNone/>
+            </a:pPr>
+            <a:r>
+              <a:rPr lang="en-US" sz="1600" dirty="0">
                 <a:solidFill>
                   <a:srgbClr val="F4F6FB"/>
                 </a:solidFill>
@@ -6418,77 +6869,99 @@
                 <a:ea typeface="Calibri" pitchFamily="34" charset="-122"/>
                 <a:cs typeface="Calibri" pitchFamily="34" charset="-120"/>
               </a:rPr>
-              <a:t>Zero download friction on the channel they already use</a:t>
-            </a:r>
-            <a:endParaRPr lang="en-US" sz="1700" dirty="0"/>
-          </a:p>
-        </p:txBody>
-      </p:sp>
-      <p:sp>
-        <p:nvSpPr>
-          <p:cNvPr id="9" name="Text 7"/>
-          <p:cNvSpPr/>
-          <p:nvPr/>
-        </p:nvSpPr>
-        <p:spPr>
-          <a:xfrm>
-            <a:off x="640080" y="3657600"/>
-            <a:ext cx="411480" cy="457200"/>
-          </a:xfrm>
-          <a:prstGeom prst="rect">
-            <a:avLst/>
-          </a:prstGeom>
-          <a:noFill/>
-          <a:ln/>
-        </p:spPr>
-        <p:txBody>
-          <a:bodyPr wrap="square" rtlCol="0" anchor="ctr"/>
-          <a:lstStyle/>
-          <a:p>
-            <a:pPr indent="0" marL="0">
-              <a:buNone/>
-            </a:pPr>
-            <a:r>
-              <a:rPr lang="en-US" sz="1800" dirty="0">
-                <a:solidFill>
-                  <a:srgbClr val="25D366"/>
-                </a:solidFill>
-                <a:latin typeface="Calibri" pitchFamily="34" charset="0"/>
-                <a:ea typeface="Calibri" pitchFamily="34" charset="-122"/>
-                <a:cs typeface="Calibri" pitchFamily="34" charset="-120"/>
-              </a:rPr>
-              <a:t>✓</a:t>
-            </a:r>
-            <a:endParaRPr lang="en-US" sz="1800" dirty="0"/>
-          </a:p>
-        </p:txBody>
-      </p:sp>
-      <p:sp>
-        <p:nvSpPr>
-          <p:cNvPr id="10" name="Text 8"/>
-          <p:cNvSpPr/>
-          <p:nvPr/>
-        </p:nvSpPr>
-        <p:spPr>
-          <a:xfrm>
-            <a:off x="1143000" y="3657600"/>
-            <a:ext cx="10058400" cy="457200"/>
-          </a:xfrm>
-          <a:prstGeom prst="rect">
-            <a:avLst/>
-          </a:prstGeom>
-          <a:noFill/>
-          <a:ln/>
-        </p:spPr>
-        <p:txBody>
-          <a:bodyPr wrap="square" rtlCol="0" anchor="ctr"/>
-          <a:lstStyle/>
-          <a:p>
-            <a:pPr indent="0" marL="0">
-              <a:buNone/>
-            </a:pPr>
-            <a:r>
-              <a:rPr lang="en-US" sz="1700" dirty="0">
+              <a:t>Explain, quiz, grade, and photo past-questions — the teaching brain of Reca.</a:t>
+            </a:r>
+            <a:endParaRPr lang="en-US" sz="1600" dirty="0"/>
+          </a:p>
+        </p:txBody>
+      </p:sp>
+      <p:sp>
+        <p:nvSpPr>
+          <p:cNvPr id="11" name="Shape 9"/>
+          <p:cNvSpPr/>
+          <p:nvPr/>
+        </p:nvSpPr>
+        <p:spPr>
+          <a:xfrm>
+            <a:off x="640080" y="3886200"/>
+            <a:ext cx="5394960" cy="1874520"/>
+          </a:xfrm>
+          <a:prstGeom prst="roundRect">
+            <a:avLst>
+              <a:gd name="adj" fmla="val 5854"/>
+            </a:avLst>
+          </a:prstGeom>
+          <a:solidFill>
+            <a:srgbClr val="0E121B"/>
+          </a:solidFill>
+          <a:ln/>
+        </p:spPr>
+      </p:sp>
+      <p:sp>
+        <p:nvSpPr>
+          <p:cNvPr id="12" name="Text 10"/>
+          <p:cNvSpPr/>
+          <p:nvPr/>
+        </p:nvSpPr>
+        <p:spPr>
+          <a:xfrm>
+            <a:off x="914400" y="4160520"/>
+            <a:ext cx="4846320" cy="320040"/>
+          </a:xfrm>
+          <a:prstGeom prst="rect">
+            <a:avLst/>
+          </a:prstGeom>
+          <a:noFill/>
+          <a:ln/>
+        </p:spPr>
+        <p:txBody>
+          <a:bodyPr wrap="square" rtlCol="0" anchor="ctr"/>
+          <a:lstStyle/>
+          <a:p>
+            <a:pPr indent="0" marL="0">
+              <a:buNone/>
+            </a:pPr>
+            <a:r>
+              <a:rPr lang="en-US" sz="1200" b="1" dirty="0">
+                <a:solidFill>
+                  <a:srgbClr val="9AA3B5"/>
+                </a:solidFill>
+                <a:latin typeface="Calibri" pitchFamily="34" charset="0"/>
+                <a:ea typeface="Calibri" pitchFamily="34" charset="-122"/>
+                <a:cs typeface="Calibri" pitchFamily="34" charset="-120"/>
+              </a:rPr>
+              <a:t>ANTIGRAVITY</a:t>
+            </a:r>
+            <a:endParaRPr lang="en-US" sz="1200" dirty="0"/>
+          </a:p>
+        </p:txBody>
+      </p:sp>
+      <p:sp>
+        <p:nvSpPr>
+          <p:cNvPr id="13" name="Text 11"/>
+          <p:cNvSpPr/>
+          <p:nvPr/>
+        </p:nvSpPr>
+        <p:spPr>
+          <a:xfrm>
+            <a:off x="914400" y="4617720"/>
+            <a:ext cx="4846320" cy="868680"/>
+          </a:xfrm>
+          <a:prstGeom prst="rect">
+            <a:avLst/>
+          </a:prstGeom>
+          <a:noFill/>
+          <a:ln/>
+        </p:spPr>
+        <p:txBody>
+          <a:bodyPr wrap="square" rtlCol="0" anchor="ctr"/>
+          <a:lstStyle/>
+          <a:p>
+            <a:pPr indent="0" marL="0">
+              <a:buNone/>
+            </a:pPr>
+            <a:r>
+              <a:rPr lang="en-US" sz="1600" dirty="0">
                 <a:solidFill>
                   <a:srgbClr val="F4F6FB"/>
                 </a:solidFill>
@@ -6496,77 +6969,99 @@
                 <a:ea typeface="Calibri" pitchFamily="34" charset="-122"/>
                 <a:cs typeface="Calibri" pitchFamily="34" charset="-120"/>
               </a:rPr>
-              <a:t>Turns “I read it” into “I still know it”</a:t>
-            </a:r>
-            <a:endParaRPr lang="en-US" sz="1700" dirty="0"/>
-          </a:p>
-        </p:txBody>
-      </p:sp>
-      <p:sp>
-        <p:nvSpPr>
-          <p:cNvPr id="11" name="Text 9"/>
-          <p:cNvSpPr/>
-          <p:nvPr/>
-        </p:nvSpPr>
-        <p:spPr>
-          <a:xfrm>
-            <a:off x="640080" y="4343400"/>
-            <a:ext cx="411480" cy="457200"/>
-          </a:xfrm>
-          <a:prstGeom prst="rect">
-            <a:avLst/>
-          </a:prstGeom>
-          <a:noFill/>
-          <a:ln/>
-        </p:spPr>
-        <p:txBody>
-          <a:bodyPr wrap="square" rtlCol="0" anchor="ctr"/>
-          <a:lstStyle/>
-          <a:p>
-            <a:pPr indent="0" marL="0">
-              <a:buNone/>
-            </a:pPr>
-            <a:r>
-              <a:rPr lang="en-US" sz="1800" dirty="0">
-                <a:solidFill>
-                  <a:srgbClr val="25D366"/>
-                </a:solidFill>
-                <a:latin typeface="Calibri" pitchFamily="34" charset="0"/>
-                <a:ea typeface="Calibri" pitchFamily="34" charset="-122"/>
-                <a:cs typeface="Calibri" pitchFamily="34" charset="-120"/>
-              </a:rPr>
-              <a:t>✓</a:t>
-            </a:r>
-            <a:endParaRPr lang="en-US" sz="1800" dirty="0"/>
-          </a:p>
-        </p:txBody>
-      </p:sp>
-      <p:sp>
-        <p:nvSpPr>
-          <p:cNvPr id="12" name="Text 10"/>
-          <p:cNvSpPr/>
-          <p:nvPr/>
-        </p:nvSpPr>
-        <p:spPr>
-          <a:xfrm>
-            <a:off x="1143000" y="4343400"/>
-            <a:ext cx="10058400" cy="457200"/>
-          </a:xfrm>
-          <a:prstGeom prst="rect">
-            <a:avLst/>
-          </a:prstGeom>
-          <a:noFill/>
-          <a:ln/>
-        </p:spPr>
-        <p:txBody>
-          <a:bodyPr wrap="square" rtlCol="0" anchor="ctr"/>
-          <a:lstStyle/>
-          <a:p>
-            <a:pPr indent="0" marL="0">
-              <a:buNone/>
-            </a:pPr>
-            <a:r>
-              <a:rPr lang="en-US" sz="1700" dirty="0">
+              <a:t>AI coding agent for scaffolding and shipping the product loop faster.</a:t>
+            </a:r>
+            <a:endParaRPr lang="en-US" sz="1600" dirty="0"/>
+          </a:p>
+        </p:txBody>
+      </p:sp>
+      <p:sp>
+        <p:nvSpPr>
+          <p:cNvPr id="14" name="Shape 12"/>
+          <p:cNvSpPr/>
+          <p:nvPr/>
+        </p:nvSpPr>
+        <p:spPr>
+          <a:xfrm>
+            <a:off x="6309360" y="3886200"/>
+            <a:ext cx="5394960" cy="1874520"/>
+          </a:xfrm>
+          <a:prstGeom prst="roundRect">
+            <a:avLst>
+              <a:gd name="adj" fmla="val 5854"/>
+            </a:avLst>
+          </a:prstGeom>
+          <a:solidFill>
+            <a:srgbClr val="0E121B"/>
+          </a:solidFill>
+          <a:ln/>
+        </p:spPr>
+      </p:sp>
+      <p:sp>
+        <p:nvSpPr>
+          <p:cNvPr id="15" name="Text 13"/>
+          <p:cNvSpPr/>
+          <p:nvPr/>
+        </p:nvSpPr>
+        <p:spPr>
+          <a:xfrm>
+            <a:off x="6583680" y="4160520"/>
+            <a:ext cx="4846320" cy="320040"/>
+          </a:xfrm>
+          <a:prstGeom prst="rect">
+            <a:avLst/>
+          </a:prstGeom>
+          <a:noFill/>
+          <a:ln/>
+        </p:spPr>
+        <p:txBody>
+          <a:bodyPr wrap="square" rtlCol="0" anchor="ctr"/>
+          <a:lstStyle/>
+          <a:p>
+            <a:pPr indent="0" marL="0">
+              <a:buNone/>
+            </a:pPr>
+            <a:r>
+              <a:rPr lang="en-US" sz="1200" b="1" dirty="0">
+                <a:solidFill>
+                  <a:srgbClr val="9AA3B5"/>
+                </a:solidFill>
+                <a:latin typeface="Calibri" pitchFamily="34" charset="0"/>
+                <a:ea typeface="Calibri" pitchFamily="34" charset="-122"/>
+                <a:cs typeface="Calibri" pitchFamily="34" charset="-120"/>
+              </a:rPr>
+              <a:t>CURSOR</a:t>
+            </a:r>
+            <a:endParaRPr lang="en-US" sz="1200" dirty="0"/>
+          </a:p>
+        </p:txBody>
+      </p:sp>
+      <p:sp>
+        <p:nvSpPr>
+          <p:cNvPr id="16" name="Text 14"/>
+          <p:cNvSpPr/>
+          <p:nvPr/>
+        </p:nvSpPr>
+        <p:spPr>
+          <a:xfrm>
+            <a:off x="6583680" y="4617720"/>
+            <a:ext cx="4846320" cy="868680"/>
+          </a:xfrm>
+          <a:prstGeom prst="rect">
+            <a:avLst/>
+          </a:prstGeom>
+          <a:noFill/>
+          <a:ln/>
+        </p:spPr>
+        <p:txBody>
+          <a:bodyPr wrap="square" rtlCol="0" anchor="ctr"/>
+          <a:lstStyle/>
+          <a:p>
+            <a:pPr indent="0" marL="0">
+              <a:buNone/>
+            </a:pPr>
+            <a:r>
+              <a:rPr lang="en-US" sz="1600" dirty="0">
                 <a:solidFill>
                   <a:srgbClr val="F4F6FB"/>
                 </a:solidFill>
@@ -6574,15 +7069,15 @@
                 <a:ea typeface="Calibri" pitchFamily="34" charset="-122"/>
                 <a:cs typeface="Calibri" pitchFamily="34" charset="-120"/>
               </a:rPr>
-              <a:t>Free-tier stack so a pilot doesn’t require paid infra day one</a:t>
-            </a:r>
-            <a:endParaRPr lang="en-US" sz="1700" dirty="0"/>
-          </a:p>
-        </p:txBody>
-      </p:sp>
-      <p:sp>
-        <p:nvSpPr>
-          <p:cNvPr id="13" name="Text 11"/>
+              <a:t>IDE for product design, UX polish, security harden, and deck/handoff work.</a:t>
+            </a:r>
+            <a:endParaRPr lang="en-US" sz="1600" dirty="0"/>
+          </a:p>
+        </p:txBody>
+      </p:sp>
+      <p:sp>
+        <p:nvSpPr>
+          <p:cNvPr id="17" name="Text 15"/>
           <p:cNvSpPr/>
           <p:nvPr/>
         </p:nvSpPr>
@@ -6613,7 +7108,7 @@
                 <a:ea typeface="Calibri" pitchFamily="34" charset="-122"/>
                 <a:cs typeface="Calibri" pitchFamily="34" charset="-120"/>
               </a:rPr>
-              <a:t>Everyday life · exam calendar demand</a:t>
+              <a:t>Portal checklist: tools used</a:t>
             </a:r>
             <a:endParaRPr lang="en-US" sz="1100" dirty="0"/>
           </a:p>
@@ -6621,7 +7116,7 @@
       </p:sp>
       <p:sp>
         <p:nvSpPr>
-          <p:cNvPr id="14" name="Text 12"/>
+          <p:cNvPr id="18" name="Text 16"/>
           <p:cNvSpPr/>
           <p:nvPr/>
         </p:nvSpPr>
@@ -6652,7 +7147,7 @@
                 <a:ea typeface="Calibri" pitchFamily="34" charset="-122"/>
                 <a:cs typeface="Calibri" pitchFamily="34" charset="-120"/>
               </a:rPr>
-              <a:t>7 / 12</a:t>
+              <a:t>7 / 13</a:t>
             </a:r>
             <a:endParaRPr lang="en-US" sz="1100" dirty="0"/>
           </a:p>
@@ -6736,7 +7231,7 @@
                 <a:ea typeface="Calibri" pitchFamily="34" charset="-122"/>
                 <a:cs typeface="Calibri" pitchFamily="34" charset="-120"/>
               </a:rPr>
-              <a:t>BUSINESS MODEL</a:t>
+              <a:t>IMPACT &amp; USEFULNESS</a:t>
             </a:r>
             <a:endParaRPr lang="en-US" sz="1200" dirty="0"/>
           </a:p>
@@ -6751,23 +7246,23 @@
         <p:spPr>
           <a:xfrm>
             <a:off x="640080" y="1005840"/>
-            <a:ext cx="10972800" cy="1005840"/>
-          </a:xfrm>
-          <a:prstGeom prst="rect">
-            <a:avLst/>
-          </a:prstGeom>
-          <a:noFill/>
-          <a:ln/>
-        </p:spPr>
-        <p:txBody>
-          <a:bodyPr wrap="square" rtlCol="0" anchor="ctr"/>
-          <a:lstStyle/>
-          <a:p>
-            <a:pPr indent="0" marL="0">
-              <a:buNone/>
-            </a:pPr>
-            <a:r>
-              <a:rPr lang="en-US" sz="2800" dirty="0">
+            <a:ext cx="10515600" cy="1005840"/>
+          </a:xfrm>
+          <a:prstGeom prst="rect">
+            <a:avLst/>
+          </a:prstGeom>
+          <a:noFill/>
+          <a:ln/>
+        </p:spPr>
+        <p:txBody>
+          <a:bodyPr wrap="square" rtlCol="0" anchor="ctr"/>
+          <a:lstStyle/>
+          <a:p>
+            <a:pPr indent="0" marL="0">
+              <a:buNone/>
+            </a:pPr>
+            <a:r>
+              <a:rPr lang="en-US" sz="3200" dirty="0">
                 <a:solidFill>
                   <a:srgbClr val="F4F6FB"/>
                 </a:solidFill>
@@ -6775,33 +7270,50 @@
                 <a:ea typeface="Georgia" pitchFamily="34" charset="-122"/>
                 <a:cs typeface="Georgia" pitchFamily="34" charset="-120"/>
               </a:rPr>
-              <a:t>Free for students first. Paid where schools need visibility.</a:t>
-            </a:r>
-            <a:endParaRPr lang="en-US" sz="2800" dirty="0"/>
-          </a:p>
-        </p:txBody>
-      </p:sp>
-      <p:sp>
-        <p:nvSpPr>
-          <p:cNvPr id="5" name="Shape 3"/>
+              <a:t>Built for how Nigerian students already study.</a:t>
+            </a:r>
+            <a:endParaRPr lang="en-US" sz="3200" dirty="0"/>
+          </a:p>
+        </p:txBody>
+      </p:sp>
+      <p:sp>
+        <p:nvSpPr>
+          <p:cNvPr id="5" name="Text 3"/>
           <p:cNvSpPr/>
           <p:nvPr/>
         </p:nvSpPr>
         <p:spPr>
           <a:xfrm>
             <a:off x="640080" y="2286000"/>
-            <a:ext cx="3566160" cy="2377440"/>
-          </a:xfrm>
-          <a:prstGeom prst="roundRect">
-            <a:avLst>
-              <a:gd name="adj" fmla="val 4615"/>
-            </a:avLst>
-          </a:prstGeom>
-          <a:solidFill>
-            <a:srgbClr val="0E121B"/>
-          </a:solidFill>
-          <a:ln/>
-        </p:spPr>
+            <a:ext cx="411480" cy="457200"/>
+          </a:xfrm>
+          <a:prstGeom prst="rect">
+            <a:avLst/>
+          </a:prstGeom>
+          <a:noFill/>
+          <a:ln/>
+        </p:spPr>
+        <p:txBody>
+          <a:bodyPr wrap="square" rtlCol="0" anchor="ctr"/>
+          <a:lstStyle/>
+          <a:p>
+            <a:pPr indent="0" marL="0">
+              <a:buNone/>
+            </a:pPr>
+            <a:r>
+              <a:rPr lang="en-US" sz="1800" dirty="0">
+                <a:solidFill>
+                  <a:srgbClr val="25D366"/>
+                </a:solidFill>
+                <a:latin typeface="Calibri" pitchFamily="34" charset="0"/>
+                <a:ea typeface="Calibri" pitchFamily="34" charset="-122"/>
+                <a:cs typeface="Calibri" pitchFamily="34" charset="-120"/>
+              </a:rPr>
+              <a:t>✓</a:t>
+            </a:r>
+            <a:endParaRPr lang="en-US" sz="1800" dirty="0"/>
+          </a:p>
+        </p:txBody>
       </p:sp>
       <p:sp>
         <p:nvSpPr>
@@ -6811,34 +7323,34 @@
         </p:nvSpPr>
         <p:spPr>
           <a:xfrm>
-            <a:off x="868680" y="2514600"/>
-            <a:ext cx="3108960" cy="320040"/>
-          </a:xfrm>
-          <a:prstGeom prst="rect">
-            <a:avLst/>
-          </a:prstGeom>
-          <a:noFill/>
-          <a:ln/>
-        </p:spPr>
-        <p:txBody>
-          <a:bodyPr wrap="square" rtlCol="0" anchor="ctr"/>
-          <a:lstStyle/>
-          <a:p>
-            <a:pPr indent="0" marL="0">
-              <a:buNone/>
-            </a:pPr>
-            <a:r>
-              <a:rPr lang="en-US" sz="1200" b="1" dirty="0">
-                <a:solidFill>
-                  <a:srgbClr val="9AA3B5"/>
-                </a:solidFill>
-                <a:latin typeface="Calibri" pitchFamily="34" charset="0"/>
-                <a:ea typeface="Calibri" pitchFamily="34" charset="-122"/>
-                <a:cs typeface="Calibri" pitchFamily="34" charset="-120"/>
-              </a:rPr>
-              <a:t>FREEMIUM</a:t>
-            </a:r>
-            <a:endParaRPr lang="en-US" sz="1200" dirty="0"/>
+            <a:off x="1143000" y="2286000"/>
+            <a:ext cx="10058400" cy="457200"/>
+          </a:xfrm>
+          <a:prstGeom prst="rect">
+            <a:avLst/>
+          </a:prstGeom>
+          <a:noFill/>
+          <a:ln/>
+        </p:spPr>
+        <p:txBody>
+          <a:bodyPr wrap="square" rtlCol="0" anchor="ctr"/>
+          <a:lstStyle/>
+          <a:p>
+            <a:pPr indent="0" marL="0">
+              <a:buNone/>
+            </a:pPr>
+            <a:r>
+              <a:rPr lang="en-US" sz="1700" dirty="0">
+                <a:solidFill>
+                  <a:srgbClr val="F4F6FB"/>
+                </a:solidFill>
+                <a:latin typeface="Calibri" pitchFamily="34" charset="0"/>
+                <a:ea typeface="Calibri" pitchFamily="34" charset="-122"/>
+                <a:cs typeface="Calibri" pitchFamily="34" charset="-120"/>
+              </a:rPr>
+              <a:t>After-school phone habit — not an in-school laptop fantasy</a:t>
+            </a:r>
+            <a:endParaRPr lang="en-US" sz="1700" dirty="0"/>
           </a:p>
         </p:txBody>
       </p:sp>
@@ -6850,24 +7362,63 @@
         </p:nvSpPr>
         <p:spPr>
           <a:xfrm>
-            <a:off x="868680" y="3017520"/>
-            <a:ext cx="3108960" cy="1371600"/>
-          </a:xfrm>
-          <a:prstGeom prst="rect">
-            <a:avLst/>
-          </a:prstGeom>
-          <a:noFill/>
-          <a:ln/>
-        </p:spPr>
-        <p:txBody>
-          <a:bodyPr wrap="square" rtlCol="0" anchor="ctr"/>
-          <a:lstStyle/>
-          <a:p>
-            <a:pPr indent="0" marL="0">
-              <a:buNone/>
-            </a:pPr>
-            <a:r>
-              <a:rPr lang="en-US" sz="1400" dirty="0">
+            <a:off x="640080" y="2971800"/>
+            <a:ext cx="411480" cy="457200"/>
+          </a:xfrm>
+          <a:prstGeom prst="rect">
+            <a:avLst/>
+          </a:prstGeom>
+          <a:noFill/>
+          <a:ln/>
+        </p:spPr>
+        <p:txBody>
+          <a:bodyPr wrap="square" rtlCol="0" anchor="ctr"/>
+          <a:lstStyle/>
+          <a:p>
+            <a:pPr indent="0" marL="0">
+              <a:buNone/>
+            </a:pPr>
+            <a:r>
+              <a:rPr lang="en-US" sz="1800" dirty="0">
+                <a:solidFill>
+                  <a:srgbClr val="25D366"/>
+                </a:solidFill>
+                <a:latin typeface="Calibri" pitchFamily="34" charset="0"/>
+                <a:ea typeface="Calibri" pitchFamily="34" charset="-122"/>
+                <a:cs typeface="Calibri" pitchFamily="34" charset="-120"/>
+              </a:rPr>
+              <a:t>✓</a:t>
+            </a:r>
+            <a:endParaRPr lang="en-US" sz="1800" dirty="0"/>
+          </a:p>
+        </p:txBody>
+      </p:sp>
+      <p:sp>
+        <p:nvSpPr>
+          <p:cNvPr id="8" name="Text 6"/>
+          <p:cNvSpPr/>
+          <p:nvPr/>
+        </p:nvSpPr>
+        <p:spPr>
+          <a:xfrm>
+            <a:off x="1143000" y="2971800"/>
+            <a:ext cx="10058400" cy="457200"/>
+          </a:xfrm>
+          <a:prstGeom prst="rect">
+            <a:avLst/>
+          </a:prstGeom>
+          <a:noFill/>
+          <a:ln/>
+        </p:spPr>
+        <p:txBody>
+          <a:bodyPr wrap="square" rtlCol="0" anchor="ctr"/>
+          <a:lstStyle/>
+          <a:p>
+            <a:pPr indent="0" marL="0">
+              <a:buNone/>
+            </a:pPr>
+            <a:r>
+              <a:rPr lang="en-US" sz="1700" dirty="0">
                 <a:solidFill>
                   <a:srgbClr val="F4F6FB"/>
                 </a:solidFill>
@@ -6875,33 +7426,11 @@
                 <a:ea typeface="Calibri" pitchFamily="34" charset="-122"/>
                 <a:cs typeface="Calibri" pitchFamily="34" charset="-120"/>
               </a:rPr>
-              <a:t>Individual students stay free — low marginal AI cost per interaction.</a:t>
-            </a:r>
-            <a:endParaRPr lang="en-US" sz="1400" dirty="0"/>
-          </a:p>
-        </p:txBody>
-      </p:sp>
-      <p:sp>
-        <p:nvSpPr>
-          <p:cNvPr id="8" name="Shape 6"/>
-          <p:cNvSpPr/>
-          <p:nvPr/>
-        </p:nvSpPr>
-        <p:spPr>
-          <a:xfrm>
-            <a:off x="4389120" y="2286000"/>
-            <a:ext cx="3566160" cy="2377440"/>
-          </a:xfrm>
-          <a:prstGeom prst="roundRect">
-            <a:avLst>
-              <a:gd name="adj" fmla="val 4615"/>
-            </a:avLst>
-          </a:prstGeom>
-          <a:solidFill>
-            <a:srgbClr val="0E121B"/>
-          </a:solidFill>
-          <a:ln/>
-        </p:spPr>
+              <a:t>Zero download friction on the channel they already use</a:t>
+            </a:r>
+            <a:endParaRPr lang="en-US" sz="1700" dirty="0"/>
+          </a:p>
+        </p:txBody>
       </p:sp>
       <p:sp>
         <p:nvSpPr>
@@ -6911,34 +7440,34 @@
         </p:nvSpPr>
         <p:spPr>
           <a:xfrm>
-            <a:off x="4617720" y="2514600"/>
-            <a:ext cx="3108960" cy="320040"/>
-          </a:xfrm>
-          <a:prstGeom prst="rect">
-            <a:avLst/>
-          </a:prstGeom>
-          <a:noFill/>
-          <a:ln/>
-        </p:spPr>
-        <p:txBody>
-          <a:bodyPr wrap="square" rtlCol="0" anchor="ctr"/>
-          <a:lstStyle/>
-          <a:p>
-            <a:pPr indent="0" marL="0">
-              <a:buNone/>
-            </a:pPr>
-            <a:r>
-              <a:rPr lang="en-US" sz="1200" b="1" dirty="0">
-                <a:solidFill>
-                  <a:srgbClr val="9AA3B5"/>
-                </a:solidFill>
-                <a:latin typeface="Calibri" pitchFamily="34" charset="0"/>
-                <a:ea typeface="Calibri" pitchFamily="34" charset="-122"/>
-                <a:cs typeface="Calibri" pitchFamily="34" charset="-120"/>
-              </a:rPr>
-              <a:t>B2B2C</a:t>
-            </a:r>
-            <a:endParaRPr lang="en-US" sz="1200" dirty="0"/>
+            <a:off x="640080" y="3657600"/>
+            <a:ext cx="411480" cy="457200"/>
+          </a:xfrm>
+          <a:prstGeom prst="rect">
+            <a:avLst/>
+          </a:prstGeom>
+          <a:noFill/>
+          <a:ln/>
+        </p:spPr>
+        <p:txBody>
+          <a:bodyPr wrap="square" rtlCol="0" anchor="ctr"/>
+          <a:lstStyle/>
+          <a:p>
+            <a:pPr indent="0" marL="0">
+              <a:buNone/>
+            </a:pPr>
+            <a:r>
+              <a:rPr lang="en-US" sz="1800" dirty="0">
+                <a:solidFill>
+                  <a:srgbClr val="25D366"/>
+                </a:solidFill>
+                <a:latin typeface="Calibri" pitchFamily="34" charset="0"/>
+                <a:ea typeface="Calibri" pitchFamily="34" charset="-122"/>
+                <a:cs typeface="Calibri" pitchFamily="34" charset="-120"/>
+              </a:rPr>
+              <a:t>✓</a:t>
+            </a:r>
+            <a:endParaRPr lang="en-US" sz="1800" dirty="0"/>
           </a:p>
         </p:txBody>
       </p:sp>
@@ -6950,24 +7479,24 @@
         </p:nvSpPr>
         <p:spPr>
           <a:xfrm>
-            <a:off x="4617720" y="3017520"/>
-            <a:ext cx="3108960" cy="1371600"/>
-          </a:xfrm>
-          <a:prstGeom prst="rect">
-            <a:avLst/>
-          </a:prstGeom>
-          <a:noFill/>
-          <a:ln/>
-        </p:spPr>
-        <p:txBody>
-          <a:bodyPr wrap="square" rtlCol="0" anchor="ctr"/>
-          <a:lstStyle/>
-          <a:p>
-            <a:pPr indent="0" marL="0">
-              <a:buNone/>
-            </a:pPr>
-            <a:r>
-              <a:rPr lang="en-US" sz="1400" dirty="0">
+            <a:off x="1143000" y="3657600"/>
+            <a:ext cx="10058400" cy="457200"/>
+          </a:xfrm>
+          <a:prstGeom prst="rect">
+            <a:avLst/>
+          </a:prstGeom>
+          <a:noFill/>
+          <a:ln/>
+        </p:spPr>
+        <p:txBody>
+          <a:bodyPr wrap="square" rtlCol="0" anchor="ctr"/>
+          <a:lstStyle/>
+          <a:p>
+            <a:pPr indent="0" marL="0">
+              <a:buNone/>
+            </a:pPr>
+            <a:r>
+              <a:rPr lang="en-US" sz="1700" dirty="0">
                 <a:solidFill>
                   <a:srgbClr val="F4F6FB"/>
                 </a:solidFill>
@@ -6975,33 +7504,50 @@
                 <a:ea typeface="Calibri" pitchFamily="34" charset="-122"/>
                 <a:cs typeface="Calibri" pitchFamily="34" charset="-120"/>
               </a:rPr>
-              <a:t>Private schools &amp; tutorial centres — per-student / cohort plans + teacher progress view.</a:t>
-            </a:r>
-            <a:endParaRPr lang="en-US" sz="1400" dirty="0"/>
-          </a:p>
-        </p:txBody>
-      </p:sp>
-      <p:sp>
-        <p:nvSpPr>
-          <p:cNvPr id="11" name="Shape 9"/>
-          <p:cNvSpPr/>
-          <p:nvPr/>
-        </p:nvSpPr>
-        <p:spPr>
-          <a:xfrm>
-            <a:off x="8138160" y="2286000"/>
-            <a:ext cx="3566160" cy="2377440"/>
-          </a:xfrm>
-          <a:prstGeom prst="roundRect">
-            <a:avLst>
-              <a:gd name="adj" fmla="val 4615"/>
-            </a:avLst>
-          </a:prstGeom>
-          <a:solidFill>
-            <a:srgbClr val="0E121B"/>
-          </a:solidFill>
-          <a:ln/>
-        </p:spPr>
+              <a:t>Turns “I read it” into “I still know it”</a:t>
+            </a:r>
+            <a:endParaRPr lang="en-US" sz="1700" dirty="0"/>
+          </a:p>
+        </p:txBody>
+      </p:sp>
+      <p:sp>
+        <p:nvSpPr>
+          <p:cNvPr id="11" name="Text 9"/>
+          <p:cNvSpPr/>
+          <p:nvPr/>
+        </p:nvSpPr>
+        <p:spPr>
+          <a:xfrm>
+            <a:off x="640080" y="4343400"/>
+            <a:ext cx="411480" cy="457200"/>
+          </a:xfrm>
+          <a:prstGeom prst="rect">
+            <a:avLst/>
+          </a:prstGeom>
+          <a:noFill/>
+          <a:ln/>
+        </p:spPr>
+        <p:txBody>
+          <a:bodyPr wrap="square" rtlCol="0" anchor="ctr"/>
+          <a:lstStyle/>
+          <a:p>
+            <a:pPr indent="0" marL="0">
+              <a:buNone/>
+            </a:pPr>
+            <a:r>
+              <a:rPr lang="en-US" sz="1800" dirty="0">
+                <a:solidFill>
+                  <a:srgbClr val="25D366"/>
+                </a:solidFill>
+                <a:latin typeface="Calibri" pitchFamily="34" charset="0"/>
+                <a:ea typeface="Calibri" pitchFamily="34" charset="-122"/>
+                <a:cs typeface="Calibri" pitchFamily="34" charset="-120"/>
+              </a:rPr>
+              <a:t>✓</a:t>
+            </a:r>
+            <a:endParaRPr lang="en-US" sz="1800" dirty="0"/>
+          </a:p>
+        </p:txBody>
       </p:sp>
       <p:sp>
         <p:nvSpPr>
@@ -7011,118 +7557,40 @@
         </p:nvSpPr>
         <p:spPr>
           <a:xfrm>
-            <a:off x="8366760" y="2514600"/>
-            <a:ext cx="3108960" cy="320040"/>
-          </a:xfrm>
-          <a:prstGeom prst="rect">
-            <a:avLst/>
-          </a:prstGeom>
-          <a:noFill/>
-          <a:ln/>
-        </p:spPr>
-        <p:txBody>
-          <a:bodyPr wrap="square" rtlCol="0" anchor="ctr"/>
-          <a:lstStyle/>
-          <a:p>
-            <a:pPr indent="0" marL="0">
-              <a:buNone/>
-            </a:pPr>
-            <a:r>
-              <a:rPr lang="en-US" sz="1200" b="1" dirty="0">
-                <a:solidFill>
-                  <a:srgbClr val="9AA3B5"/>
-                </a:solidFill>
-                <a:latin typeface="Calibri" pitchFamily="34" charset="0"/>
-                <a:ea typeface="Calibri" pitchFamily="34" charset="-122"/>
-                <a:cs typeface="Calibri" pitchFamily="34" charset="-120"/>
-              </a:rPr>
-              <a:t>SPONSORED</a:t>
-            </a:r>
-            <a:endParaRPr lang="en-US" sz="1200" dirty="0"/>
+            <a:off x="1143000" y="4343400"/>
+            <a:ext cx="10058400" cy="457200"/>
+          </a:xfrm>
+          <a:prstGeom prst="rect">
+            <a:avLst/>
+          </a:prstGeom>
+          <a:noFill/>
+          <a:ln/>
+        </p:spPr>
+        <p:txBody>
+          <a:bodyPr wrap="square" rtlCol="0" anchor="ctr"/>
+          <a:lstStyle/>
+          <a:p>
+            <a:pPr indent="0" marL="0">
+              <a:buNone/>
+            </a:pPr>
+            <a:r>
+              <a:rPr lang="en-US" sz="1700" dirty="0">
+                <a:solidFill>
+                  <a:srgbClr val="F4F6FB"/>
+                </a:solidFill>
+                <a:latin typeface="Calibri" pitchFamily="34" charset="0"/>
+                <a:ea typeface="Calibri" pitchFamily="34" charset="-122"/>
+                <a:cs typeface="Calibri" pitchFamily="34" charset="-120"/>
+              </a:rPr>
+              <a:t>Free-tier stack so a pilot doesn’t require paid infra day one</a:t>
+            </a:r>
+            <a:endParaRPr lang="en-US" sz="1700" dirty="0"/>
           </a:p>
         </p:txBody>
       </p:sp>
       <p:sp>
         <p:nvSpPr>
           <p:cNvPr id="13" name="Text 11"/>
-          <p:cNvSpPr/>
-          <p:nvPr/>
-        </p:nvSpPr>
-        <p:spPr>
-          <a:xfrm>
-            <a:off x="8366760" y="3017520"/>
-            <a:ext cx="3108960" cy="1371600"/>
-          </a:xfrm>
-          <a:prstGeom prst="rect">
-            <a:avLst/>
-          </a:prstGeom>
-          <a:noFill/>
-          <a:ln/>
-        </p:spPr>
-        <p:txBody>
-          <a:bodyPr wrap="square" rtlCol="0" anchor="ctr"/>
-          <a:lstStyle/>
-          <a:p>
-            <a:pPr indent="0" marL="0">
-              <a:buNone/>
-            </a:pPr>
-            <a:r>
-              <a:rPr lang="en-US" sz="1400" dirty="0">
-                <a:solidFill>
-                  <a:srgbClr val="F4F6FB"/>
-                </a:solidFill>
-                <a:latin typeface="Calibri" pitchFamily="34" charset="0"/>
-                <a:ea typeface="Calibri" pitchFamily="34" charset="-122"/>
-                <a:cs typeface="Calibri" pitchFamily="34" charset="-120"/>
-              </a:rPr>
-              <a:t>Exam-prep sponsors, NGOs, or telcos subsidise public-school students.</a:t>
-            </a:r>
-            <a:endParaRPr lang="en-US" sz="1400" dirty="0"/>
-          </a:p>
-        </p:txBody>
-      </p:sp>
-      <p:sp>
-        <p:nvSpPr>
-          <p:cNvPr id="14" name="Text 12"/>
-          <p:cNvSpPr/>
-          <p:nvPr/>
-        </p:nvSpPr>
-        <p:spPr>
-          <a:xfrm>
-            <a:off x="640080" y="5029200"/>
-            <a:ext cx="10972800" cy="457200"/>
-          </a:xfrm>
-          <a:prstGeom prst="rect">
-            <a:avLst/>
-          </a:prstGeom>
-          <a:noFill/>
-          <a:ln/>
-        </p:spPr>
-        <p:txBody>
-          <a:bodyPr wrap="square" rtlCol="0" anchor="ctr"/>
-          <a:lstStyle/>
-          <a:p>
-            <a:pPr indent="0" marL="0">
-              <a:buNone/>
-            </a:pPr>
-            <a:r>
-              <a:rPr lang="en-US" sz="1400" dirty="0">
-                <a:solidFill>
-                  <a:srgbClr val="9AA3B5"/>
-                </a:solidFill>
-                <a:latin typeface="Calibri" pitchFamily="34" charset="0"/>
-                <a:ea typeface="Calibri" pitchFamily="34" charset="-122"/>
-                <a:cs typeface="Calibri" pitchFamily="34" charset="-120"/>
-              </a:rPr>
-              <a:t>Moat: attempt history + WhatsApp distribution + WAEC/JAMB curriculum.</a:t>
-            </a:r>
-            <a:endParaRPr lang="en-US" sz="1400" dirty="0"/>
-          </a:p>
-        </p:txBody>
-      </p:sp>
-      <p:sp>
-        <p:nvSpPr>
-          <p:cNvPr id="15" name="Text 13"/>
           <p:cNvSpPr/>
           <p:nvPr/>
         </p:nvSpPr>
@@ -7153,7 +7621,7 @@
                 <a:ea typeface="Calibri" pitchFamily="34" charset="-122"/>
                 <a:cs typeface="Calibri" pitchFamily="34" charset="-120"/>
               </a:rPr>
-              <a:t>Post-fest roadmap</a:t>
+              <a:t>Everyday life · exam calendar demand</a:t>
             </a:r>
             <a:endParaRPr lang="en-US" sz="1100" dirty="0"/>
           </a:p>
@@ -7161,7 +7629,7 @@
       </p:sp>
       <p:sp>
         <p:nvSpPr>
-          <p:cNvPr id="16" name="Text 14"/>
+          <p:cNvPr id="14" name="Text 12"/>
           <p:cNvSpPr/>
           <p:nvPr/>
         </p:nvSpPr>
@@ -7192,7 +7660,7 @@
                 <a:ea typeface="Calibri" pitchFamily="34" charset="-122"/>
                 <a:cs typeface="Calibri" pitchFamily="34" charset="-120"/>
               </a:rPr>
-              <a:t>8 / 12</a:t>
+              <a:t>8 / 13</a:t>
             </a:r>
             <a:endParaRPr lang="en-US" sz="1100" dirty="0"/>
           </a:p>
@@ -7276,7 +7744,7 @@
                 <a:ea typeface="Calibri" pitchFamily="34" charset="-122"/>
                 <a:cs typeface="Calibri" pitchFamily="34" charset="-120"/>
               </a:rPr>
-              <a:t>LIVE LINK &amp; DEMO</a:t>
+              <a:t>BUSINESS MODEL</a:t>
             </a:r>
             <a:endParaRPr lang="en-US" sz="1200" dirty="0"/>
           </a:p>
@@ -7291,23 +7759,23 @@
         <p:spPr>
           <a:xfrm>
             <a:off x="640080" y="1005840"/>
-            <a:ext cx="10515600" cy="822960"/>
-          </a:xfrm>
-          <a:prstGeom prst="rect">
-            <a:avLst/>
-          </a:prstGeom>
-          <a:noFill/>
-          <a:ln/>
-        </p:spPr>
-        <p:txBody>
-          <a:bodyPr wrap="square" rtlCol="0" anchor="ctr"/>
-          <a:lstStyle/>
-          <a:p>
-            <a:pPr indent="0" marL="0">
-              <a:buNone/>
-            </a:pPr>
-            <a:r>
-              <a:rPr lang="en-US" sz="3200" dirty="0">
+            <a:ext cx="10972800" cy="1005840"/>
+          </a:xfrm>
+          <a:prstGeom prst="rect">
+            <a:avLst/>
+          </a:prstGeom>
+          <a:noFill/>
+          <a:ln/>
+        </p:spPr>
+        <p:txBody>
+          <a:bodyPr wrap="square" rtlCol="0" anchor="ctr"/>
+          <a:lstStyle/>
+          <a:p>
+            <a:pPr indent="0" marL="0">
+              <a:buNone/>
+            </a:pPr>
+            <a:r>
+              <a:rPr lang="en-US" sz="2800" dirty="0">
                 <a:solidFill>
                   <a:srgbClr val="F4F6FB"/>
                 </a:solidFill>
@@ -7315,38 +7783,60 @@
                 <a:ea typeface="Georgia" pitchFamily="34" charset="-122"/>
                 <a:cs typeface="Georgia" pitchFamily="34" charset="-120"/>
               </a:rPr>
-              <a:t>Try the product. Watch the aha.</a:t>
-            </a:r>
-            <a:endParaRPr lang="en-US" sz="3200" dirty="0"/>
-          </a:p>
-        </p:txBody>
-      </p:sp>
-      <p:sp>
-        <p:nvSpPr>
-          <p:cNvPr id="5" name="Text 3"/>
-          <p:cNvSpPr/>
-          <p:nvPr/>
-        </p:nvSpPr>
-        <p:spPr>
-          <a:xfrm>
-            <a:off x="640080" y="2011680"/>
-            <a:ext cx="10515600" cy="1005840"/>
-          </a:xfrm>
-          <a:prstGeom prst="rect">
-            <a:avLst/>
-          </a:prstGeom>
-          <a:noFill/>
-          <a:ln/>
-        </p:spPr>
-        <p:txBody>
-          <a:bodyPr wrap="square" rtlCol="0" anchor="ctr"/>
-          <a:lstStyle/>
-          <a:p>
-            <a:pPr indent="0" marL="0">
-              <a:buNone/>
-            </a:pPr>
-            <a:r>
-              <a:rPr lang="en-US" sz="1600" dirty="0">
+              <a:t>Free for students first. Paid where schools need visibility.</a:t>
+            </a:r>
+            <a:endParaRPr lang="en-US" sz="2800" dirty="0"/>
+          </a:p>
+        </p:txBody>
+      </p:sp>
+      <p:sp>
+        <p:nvSpPr>
+          <p:cNvPr id="5" name="Shape 3"/>
+          <p:cNvSpPr/>
+          <p:nvPr/>
+        </p:nvSpPr>
+        <p:spPr>
+          <a:xfrm>
+            <a:off x="640080" y="2286000"/>
+            <a:ext cx="3566160" cy="2377440"/>
+          </a:xfrm>
+          <a:prstGeom prst="roundRect">
+            <a:avLst>
+              <a:gd name="adj" fmla="val 4615"/>
+            </a:avLst>
+          </a:prstGeom>
+          <a:solidFill>
+            <a:srgbClr val="0E121B"/>
+          </a:solidFill>
+          <a:ln/>
+        </p:spPr>
+      </p:sp>
+      <p:sp>
+        <p:nvSpPr>
+          <p:cNvPr id="6" name="Text 4"/>
+          <p:cNvSpPr/>
+          <p:nvPr/>
+        </p:nvSpPr>
+        <p:spPr>
+          <a:xfrm>
+            <a:off x="868680" y="2514600"/>
+            <a:ext cx="3108960" cy="320040"/>
+          </a:xfrm>
+          <a:prstGeom prst="rect">
+            <a:avLst/>
+          </a:prstGeom>
+          <a:noFill/>
+          <a:ln/>
+        </p:spPr>
+        <p:txBody>
+          <a:bodyPr wrap="square" rtlCol="0" anchor="ctr"/>
+          <a:lstStyle/>
+          <a:p>
+            <a:pPr indent="0" marL="0">
+              <a:buNone/>
+            </a:pPr>
+            <a:r>
+              <a:rPr lang="en-US" sz="1200" b="1" dirty="0">
                 <a:solidFill>
                   <a:srgbClr val="9AA3B5"/>
                 </a:solidFill>
@@ -7354,21 +7844,260 @@
                 <a:ea typeface="Calibri" pitchFamily="34" charset="-122"/>
                 <a:cs typeface="Calibri" pitchFamily="34" charset="-120"/>
               </a:rPr>
-              <a:t>Web companion (same memory loop): open Learn → ask a topic → miss one question → Reca comes back. WhatsApp is the stage hero — Reca messages first.</a:t>
-            </a:r>
-            <a:endParaRPr lang="en-US" sz="1600" dirty="0"/>
-          </a:p>
-        </p:txBody>
-      </p:sp>
-      <p:sp>
-        <p:nvSpPr>
-          <p:cNvPr id="6" name="Text 4"/>
-          <p:cNvSpPr/>
-          <p:nvPr/>
-        </p:nvSpPr>
-        <p:spPr>
-          <a:xfrm>
-            <a:off x="640080" y="3291840"/>
+              <a:t>FREEMIUM</a:t>
+            </a:r>
+            <a:endParaRPr lang="en-US" sz="1200" dirty="0"/>
+          </a:p>
+        </p:txBody>
+      </p:sp>
+      <p:sp>
+        <p:nvSpPr>
+          <p:cNvPr id="7" name="Text 5"/>
+          <p:cNvSpPr/>
+          <p:nvPr/>
+        </p:nvSpPr>
+        <p:spPr>
+          <a:xfrm>
+            <a:off x="868680" y="3017520"/>
+            <a:ext cx="3108960" cy="1371600"/>
+          </a:xfrm>
+          <a:prstGeom prst="rect">
+            <a:avLst/>
+          </a:prstGeom>
+          <a:noFill/>
+          <a:ln/>
+        </p:spPr>
+        <p:txBody>
+          <a:bodyPr wrap="square" rtlCol="0" anchor="ctr"/>
+          <a:lstStyle/>
+          <a:p>
+            <a:pPr indent="0" marL="0">
+              <a:buNone/>
+            </a:pPr>
+            <a:r>
+              <a:rPr lang="en-US" sz="1400" dirty="0">
+                <a:solidFill>
+                  <a:srgbClr val="F4F6FB"/>
+                </a:solidFill>
+                <a:latin typeface="Calibri" pitchFamily="34" charset="0"/>
+                <a:ea typeface="Calibri" pitchFamily="34" charset="-122"/>
+                <a:cs typeface="Calibri" pitchFamily="34" charset="-120"/>
+              </a:rPr>
+              <a:t>Individual students stay free — low marginal AI cost per interaction.</a:t>
+            </a:r>
+            <a:endParaRPr lang="en-US" sz="1400" dirty="0"/>
+          </a:p>
+        </p:txBody>
+      </p:sp>
+      <p:sp>
+        <p:nvSpPr>
+          <p:cNvPr id="8" name="Shape 6"/>
+          <p:cNvSpPr/>
+          <p:nvPr/>
+        </p:nvSpPr>
+        <p:spPr>
+          <a:xfrm>
+            <a:off x="4389120" y="2286000"/>
+            <a:ext cx="3566160" cy="2377440"/>
+          </a:xfrm>
+          <a:prstGeom prst="roundRect">
+            <a:avLst>
+              <a:gd name="adj" fmla="val 4615"/>
+            </a:avLst>
+          </a:prstGeom>
+          <a:solidFill>
+            <a:srgbClr val="0E121B"/>
+          </a:solidFill>
+          <a:ln/>
+        </p:spPr>
+      </p:sp>
+      <p:sp>
+        <p:nvSpPr>
+          <p:cNvPr id="9" name="Text 7"/>
+          <p:cNvSpPr/>
+          <p:nvPr/>
+        </p:nvSpPr>
+        <p:spPr>
+          <a:xfrm>
+            <a:off x="4617720" y="2514600"/>
+            <a:ext cx="3108960" cy="320040"/>
+          </a:xfrm>
+          <a:prstGeom prst="rect">
+            <a:avLst/>
+          </a:prstGeom>
+          <a:noFill/>
+          <a:ln/>
+        </p:spPr>
+        <p:txBody>
+          <a:bodyPr wrap="square" rtlCol="0" anchor="ctr"/>
+          <a:lstStyle/>
+          <a:p>
+            <a:pPr indent="0" marL="0">
+              <a:buNone/>
+            </a:pPr>
+            <a:r>
+              <a:rPr lang="en-US" sz="1200" b="1" dirty="0">
+                <a:solidFill>
+                  <a:srgbClr val="9AA3B5"/>
+                </a:solidFill>
+                <a:latin typeface="Calibri" pitchFamily="34" charset="0"/>
+                <a:ea typeface="Calibri" pitchFamily="34" charset="-122"/>
+                <a:cs typeface="Calibri" pitchFamily="34" charset="-120"/>
+              </a:rPr>
+              <a:t>B2B2C</a:t>
+            </a:r>
+            <a:endParaRPr lang="en-US" sz="1200" dirty="0"/>
+          </a:p>
+        </p:txBody>
+      </p:sp>
+      <p:sp>
+        <p:nvSpPr>
+          <p:cNvPr id="10" name="Text 8"/>
+          <p:cNvSpPr/>
+          <p:nvPr/>
+        </p:nvSpPr>
+        <p:spPr>
+          <a:xfrm>
+            <a:off x="4617720" y="3017520"/>
+            <a:ext cx="3108960" cy="1371600"/>
+          </a:xfrm>
+          <a:prstGeom prst="rect">
+            <a:avLst/>
+          </a:prstGeom>
+          <a:noFill/>
+          <a:ln/>
+        </p:spPr>
+        <p:txBody>
+          <a:bodyPr wrap="square" rtlCol="0" anchor="ctr"/>
+          <a:lstStyle/>
+          <a:p>
+            <a:pPr indent="0" marL="0">
+              <a:buNone/>
+            </a:pPr>
+            <a:r>
+              <a:rPr lang="en-US" sz="1400" dirty="0">
+                <a:solidFill>
+                  <a:srgbClr val="F4F6FB"/>
+                </a:solidFill>
+                <a:latin typeface="Calibri" pitchFamily="34" charset="0"/>
+                <a:ea typeface="Calibri" pitchFamily="34" charset="-122"/>
+                <a:cs typeface="Calibri" pitchFamily="34" charset="-120"/>
+              </a:rPr>
+              <a:t>Private schools &amp; tutorial centres — per-student / cohort plans + teacher progress view.</a:t>
+            </a:r>
+            <a:endParaRPr lang="en-US" sz="1400" dirty="0"/>
+          </a:p>
+        </p:txBody>
+      </p:sp>
+      <p:sp>
+        <p:nvSpPr>
+          <p:cNvPr id="11" name="Shape 9"/>
+          <p:cNvSpPr/>
+          <p:nvPr/>
+        </p:nvSpPr>
+        <p:spPr>
+          <a:xfrm>
+            <a:off x="8138160" y="2286000"/>
+            <a:ext cx="3566160" cy="2377440"/>
+          </a:xfrm>
+          <a:prstGeom prst="roundRect">
+            <a:avLst>
+              <a:gd name="adj" fmla="val 4615"/>
+            </a:avLst>
+          </a:prstGeom>
+          <a:solidFill>
+            <a:srgbClr val="0E121B"/>
+          </a:solidFill>
+          <a:ln/>
+        </p:spPr>
+      </p:sp>
+      <p:sp>
+        <p:nvSpPr>
+          <p:cNvPr id="12" name="Text 10"/>
+          <p:cNvSpPr/>
+          <p:nvPr/>
+        </p:nvSpPr>
+        <p:spPr>
+          <a:xfrm>
+            <a:off x="8366760" y="2514600"/>
+            <a:ext cx="3108960" cy="320040"/>
+          </a:xfrm>
+          <a:prstGeom prst="rect">
+            <a:avLst/>
+          </a:prstGeom>
+          <a:noFill/>
+          <a:ln/>
+        </p:spPr>
+        <p:txBody>
+          <a:bodyPr wrap="square" rtlCol="0" anchor="ctr"/>
+          <a:lstStyle/>
+          <a:p>
+            <a:pPr indent="0" marL="0">
+              <a:buNone/>
+            </a:pPr>
+            <a:r>
+              <a:rPr lang="en-US" sz="1200" b="1" dirty="0">
+                <a:solidFill>
+                  <a:srgbClr val="9AA3B5"/>
+                </a:solidFill>
+                <a:latin typeface="Calibri" pitchFamily="34" charset="0"/>
+                <a:ea typeface="Calibri" pitchFamily="34" charset="-122"/>
+                <a:cs typeface="Calibri" pitchFamily="34" charset="-120"/>
+              </a:rPr>
+              <a:t>SPONSORED</a:t>
+            </a:r>
+            <a:endParaRPr lang="en-US" sz="1200" dirty="0"/>
+          </a:p>
+        </p:txBody>
+      </p:sp>
+      <p:sp>
+        <p:nvSpPr>
+          <p:cNvPr id="13" name="Text 11"/>
+          <p:cNvSpPr/>
+          <p:nvPr/>
+        </p:nvSpPr>
+        <p:spPr>
+          <a:xfrm>
+            <a:off x="8366760" y="3017520"/>
+            <a:ext cx="3108960" cy="1371600"/>
+          </a:xfrm>
+          <a:prstGeom prst="rect">
+            <a:avLst/>
+          </a:prstGeom>
+          <a:noFill/>
+          <a:ln/>
+        </p:spPr>
+        <p:txBody>
+          <a:bodyPr wrap="square" rtlCol="0" anchor="ctr"/>
+          <a:lstStyle/>
+          <a:p>
+            <a:pPr indent="0" marL="0">
+              <a:buNone/>
+            </a:pPr>
+            <a:r>
+              <a:rPr lang="en-US" sz="1400" dirty="0">
+                <a:solidFill>
+                  <a:srgbClr val="F4F6FB"/>
+                </a:solidFill>
+                <a:latin typeface="Calibri" pitchFamily="34" charset="0"/>
+                <a:ea typeface="Calibri" pitchFamily="34" charset="-122"/>
+                <a:cs typeface="Calibri" pitchFamily="34" charset="-120"/>
+              </a:rPr>
+              <a:t>Exam-prep sponsors, NGOs, or telcos subsidise public-school students.</a:t>
+            </a:r>
+            <a:endParaRPr lang="en-US" sz="1400" dirty="0"/>
+          </a:p>
+        </p:txBody>
+      </p:sp>
+      <p:sp>
+        <p:nvSpPr>
+          <p:cNvPr id="14" name="Text 12"/>
+          <p:cNvSpPr/>
+          <p:nvPr/>
+        </p:nvSpPr>
+        <p:spPr>
+          <a:xfrm>
+            <a:off x="640080" y="5029200"/>
             <a:ext cx="10972800" cy="457200"/>
           </a:xfrm>
           <a:prstGeom prst="rect">
@@ -7385,45 +8114,6 @@
               <a:buNone/>
             </a:pPr>
             <a:r>
-              <a:rPr lang="en-US" sz="1800" b="1" dirty="0">
-                <a:solidFill>
-                  <a:srgbClr val="225AEB"/>
-                </a:solidFill>
-                <a:latin typeface="Calibri" pitchFamily="34" charset="0"/>
-                <a:ea typeface="Calibri" pitchFamily="34" charset="-122"/>
-                <a:cs typeface="Calibri" pitchFamily="34" charset="-120"/>
-              </a:rPr>
-              <a:t>https://reca-study-companion.vercel.app/signup.html</a:t>
-            </a:r>
-            <a:endParaRPr lang="en-US" sz="1800" dirty="0"/>
-          </a:p>
-        </p:txBody>
-      </p:sp>
-      <p:sp>
-        <p:nvSpPr>
-          <p:cNvPr id="7" name="Text 5"/>
-          <p:cNvSpPr/>
-          <p:nvPr/>
-        </p:nvSpPr>
-        <p:spPr>
-          <a:xfrm>
-            <a:off x="640080" y="4114800"/>
-            <a:ext cx="10972800" cy="640080"/>
-          </a:xfrm>
-          <a:prstGeom prst="rect">
-            <a:avLst/>
-          </a:prstGeom>
-          <a:noFill/>
-          <a:ln/>
-        </p:spPr>
-        <p:txBody>
-          <a:bodyPr wrap="square" rtlCol="0" anchor="ctr"/>
-          <a:lstStyle/>
-          <a:p>
-            <a:pPr indent="0" marL="0">
-              <a:buNone/>
-            </a:pPr>
-            <a:r>
               <a:rPr lang="en-US" sz="1400" dirty="0">
                 <a:solidFill>
                   <a:srgbClr val="9AA3B5"/>
@@ -7432,7 +8122,7 @@
                 <a:ea typeface="Calibri" pitchFamily="34" charset="-122"/>
                 <a:cs typeface="Calibri" pitchFamily="34" charset="-120"/>
               </a:rPr>
-              <a:t>Demo script: explain photosynthesis → wrong Q1 (mitochondria) → unprompted resurface → chloroplast</a:t>
+              <a:t>Moat: attempt history + WhatsApp distribution + WAEC/JAMB curriculum.</a:t>
             </a:r>
             <a:endParaRPr lang="en-US" sz="1400" dirty="0"/>
           </a:p>
@@ -7440,7 +8130,7 @@
       </p:sp>
       <p:sp>
         <p:nvSpPr>
-          <p:cNvPr id="8" name="Text 6"/>
+          <p:cNvPr id="15" name="Text 13"/>
           <p:cNvSpPr/>
           <p:nvPr/>
         </p:nvSpPr>
@@ -7471,7 +8161,7 @@
                 <a:ea typeface="Calibri" pitchFamily="34" charset="-122"/>
                 <a:cs typeface="Calibri" pitchFamily="34" charset="-120"/>
               </a:rPr>
-              <a:t>Guest mode available</a:t>
+              <a:t>Post-fest roadmap</a:t>
             </a:r>
             <a:endParaRPr lang="en-US" sz="1100" dirty="0"/>
           </a:p>
@@ -7479,7 +8169,7 @@
       </p:sp>
       <p:sp>
         <p:nvSpPr>
-          <p:cNvPr id="9" name="Text 7"/>
+          <p:cNvPr id="16" name="Text 14"/>
           <p:cNvSpPr/>
           <p:nvPr/>
         </p:nvSpPr>
@@ -7510,7 +8200,7 @@
                 <a:ea typeface="Calibri" pitchFamily="34" charset="-122"/>
                 <a:cs typeface="Calibri" pitchFamily="34" charset="-120"/>
               </a:rPr>
-              <a:t>9 / 12</a:t>
+              <a:t>9 / 13</a:t>
             </a:r>
             <a:endParaRPr lang="en-US" sz="1100" dirty="0"/>
           </a:p>

</xml_diff>